<commit_message>
fix(docs): mejoras visuales en la PPT de Evaluacion 2
Slide 1 (Portada):
  - Seccion INTEGRANTES con header espaciado
  - Nombre real Claudio Vicente Aro Kath sin corchetes
  - Linea de docente agregada
  - Layout mas balanceado

Slide 2 (El Problema):
  - Texto descriptivo en una sola linea limpia
  - Cita Fuente: FAO . ODEPA separada

Slide 3 (La Solucion):
  - Flechas entre cards ahora son triangulos > limpios
  - (antes eran rectangulo + arrow superpuestos)

Slide 5 (Arquitectura 4+1):
  - Descripciones de cada vista mas substantivas
  - Fisica: Despliegue cloud / Android . API . BD
  - (antes: Android->Render ->Supabase con salto feo)

Slide 6 (Resultados):
  - Linea de info de entrenamiento con mejor contraste
  - (color C.border en vez de C.textMute)

Slide 7 (Estado Avance):
  - Fix: 9 / 9 tests -> 9/9 tests
  - Persistencia + historial paginado (mas claro)
</commit_message>
<xml_diff>
--- a/Documentación/Evaluacion_2/MaduraApp_Presentacion_Evaluacion2.pptx
+++ b/Documentación/Evaluacion_2/MaduraApp_Presentacion_Evaluacion2.pptx
@@ -1857,8 +1857,8 @@
         </p:nvSpPr>
         <p:spPr>
           <a:xfrm>
-            <a:off x="1371600" y="3200400"/>
-            <a:ext cx="6400800" cy="822960"/>
+            <a:off x="1371600" y="3154680"/>
+            <a:ext cx="6400800" cy="777240"/>
           </a:xfrm>
           <a:prstGeom prst="rect">
             <a:avLst/>
@@ -1882,8 +1882,8 @@
         </p:nvSpPr>
         <p:spPr>
           <a:xfrm>
-            <a:off x="1371600" y="3200400"/>
-            <a:ext cx="6400800" cy="822960"/>
+            <a:off x="1371600" y="3154680"/>
+            <a:ext cx="6400800" cy="777240"/>
           </a:xfrm>
           <a:prstGeom prst="rect">
             <a:avLst/>
@@ -1907,7 +1907,7 @@
                 <a:ea typeface="Calibri" pitchFamily="34" charset="-122"/>
                 <a:cs typeface="Calibri" pitchFamily="34" charset="-120"/>
               </a:rPr>
-              <a:t>Taller Aplicado de Programación (TPY1101)  |  DuocUC</a:t>
+              <a:t>Taller Aplicado de Programación (TPY1101)  ·  DuocUC</a:t>
             </a:r>
             <a:endParaRPr lang="en-US" sz="1300" dirty="0"/>
           </a:p>
@@ -1924,7 +1924,7 @@
                 <a:ea typeface="Calibri" pitchFamily="34" charset="-122"/>
                 <a:cs typeface="Calibri" pitchFamily="34" charset="-120"/>
               </a:rPr>
-              <a:t>Evaluación Parcial N° 2 — Estado de Avance  |  Mayo 2026</a:t>
+              <a:t>Evaluación Parcial N° 2  ·  Mayo 2026</a:t>
             </a:r>
             <a:endParaRPr lang="en-US" sz="1300" dirty="0"/>
           </a:p>
@@ -1938,8 +1938,8 @@
         </p:nvSpPr>
         <p:spPr>
           <a:xfrm>
-            <a:off x="457200" y="4206240"/>
-            <a:ext cx="8229600" cy="365760"/>
+            <a:off x="457200" y="4114800"/>
+            <a:ext cx="8229600" cy="274320"/>
           </a:xfrm>
           <a:prstGeom prst="rect">
             <a:avLst/>
@@ -1955,7 +1955,85 @@
               <a:buNone/>
             </a:pPr>
             <a:r>
-              <a:rPr lang="en-US" sz="1300" dirty="0">
+              <a:rPr lang="en-US" sz="1000" b="1" spc="400" kern="0" dirty="0">
+                <a:solidFill>
+                  <a:srgbClr val="4CAF50"/>
+                </a:solidFill>
+                <a:latin typeface="Calibri" pitchFamily="34" charset="0"/>
+                <a:ea typeface="Calibri" pitchFamily="34" charset="-122"/>
+                <a:cs typeface="Calibri" pitchFamily="34" charset="-120"/>
+              </a:rPr>
+              <a:t>INTEGRANTES</a:t>
+            </a:r>
+            <a:endParaRPr lang="en-US" sz="1000" dirty="0"/>
+          </a:p>
+        </p:txBody>
+      </p:sp>
+      <p:sp>
+        <p:nvSpPr>
+          <p:cNvPr id="13" name="Text 11"/>
+          <p:cNvSpPr/>
+          <p:nvPr/>
+        </p:nvSpPr>
+        <p:spPr>
+          <a:xfrm>
+            <a:off x="457200" y="4370832"/>
+            <a:ext cx="8229600" cy="320040"/>
+          </a:xfrm>
+          <a:prstGeom prst="rect">
+            <a:avLst/>
+          </a:prstGeom>
+          <a:noFill/>
+          <a:ln/>
+        </p:spPr>
+        <p:txBody>
+          <a:bodyPr wrap="square" lIns="0" tIns="0" rIns="0" bIns="0" rtlCol="0" anchor="ctr"/>
+          <a:lstStyle/>
+          <a:p>
+            <a:pPr algn="ctr" indent="0" marL="0">
+              <a:buNone/>
+            </a:pPr>
+            <a:r>
+              <a:rPr lang="en-US" sz="1400" dirty="0">
+                <a:solidFill>
+                  <a:srgbClr val="FFFFFF"/>
+                </a:solidFill>
+                <a:latin typeface="Calibri" pitchFamily="34" charset="0"/>
+                <a:ea typeface="Calibri" pitchFamily="34" charset="-122"/>
+                <a:cs typeface="Calibri" pitchFamily="34" charset="-120"/>
+              </a:rPr>
+              <a:t>Claudio Vicente Aro Kath   ·   [Integrante 2]   ·   [Integrante 3]</a:t>
+            </a:r>
+            <a:endParaRPr lang="en-US" sz="1400" dirty="0"/>
+          </a:p>
+        </p:txBody>
+      </p:sp>
+      <p:sp>
+        <p:nvSpPr>
+          <p:cNvPr id="14" name="Text 12"/>
+          <p:cNvSpPr/>
+          <p:nvPr/>
+        </p:nvSpPr>
+        <p:spPr>
+          <a:xfrm>
+            <a:off x="457200" y="4736592"/>
+            <a:ext cx="8229600" cy="274320"/>
+          </a:xfrm>
+          <a:prstGeom prst="rect">
+            <a:avLst/>
+          </a:prstGeom>
+          <a:noFill/>
+          <a:ln/>
+        </p:spPr>
+        <p:txBody>
+          <a:bodyPr wrap="square" lIns="0" tIns="0" rIns="0" bIns="0" rtlCol="0" anchor="ctr"/>
+          <a:lstStyle/>
+          <a:p>
+            <a:pPr algn="ctr" indent="0" marL="0">
+              <a:buNone/>
+            </a:pPr>
+            <a:r>
+              <a:rPr lang="en-US" sz="1100" i="1" dirty="0">
                 <a:solidFill>
                   <a:srgbClr val="718096"/>
                 </a:solidFill>
@@ -1963,15 +2041,15 @@
                 <a:ea typeface="Calibri" pitchFamily="34" charset="-122"/>
                 <a:cs typeface="Calibri" pitchFamily="34" charset="-120"/>
               </a:rPr>
-              <a:t>[Nombre Integrante 1]  ·  [Nombre Integrante 2]  ·  [Nombre Integrante 3]</a:t>
-            </a:r>
-            <a:endParaRPr lang="en-US" sz="1300" dirty="0"/>
-          </a:p>
-        </p:txBody>
-      </p:sp>
-      <p:sp>
-        <p:nvSpPr>
-          <p:cNvPr id="13" name="Shape 11"/>
+              <a:t>Docente: [Nombre del Docente]</a:t>
+            </a:r>
+            <a:endParaRPr lang="en-US" sz="1100" dirty="0"/>
+          </a:p>
+        </p:txBody>
+      </p:sp>
+      <p:sp>
+        <p:nvSpPr>
+          <p:cNvPr id="15" name="Shape 13"/>
           <p:cNvSpPr/>
           <p:nvPr/>
         </p:nvSpPr>
@@ -2159,24 +2237,24 @@
         </p:nvSpPr>
         <p:spPr>
           <a:xfrm>
-            <a:off x="457200" y="2286000"/>
-            <a:ext cx="2743200" cy="1005840"/>
-          </a:xfrm>
-          <a:prstGeom prst="rect">
-            <a:avLst/>
-          </a:prstGeom>
-          <a:noFill/>
-          <a:ln/>
-        </p:spPr>
-        <p:txBody>
-          <a:bodyPr wrap="square" lIns="101600" tIns="101600" rIns="101600" bIns="101600" rtlCol="0" anchor="ctr"/>
+            <a:off x="502920" y="2331720"/>
+            <a:ext cx="2651760" cy="640080"/>
+          </a:xfrm>
+          <a:prstGeom prst="rect">
+            <a:avLst/>
+          </a:prstGeom>
+          <a:noFill/>
+          <a:ln/>
+        </p:spPr>
+        <p:txBody>
+          <a:bodyPr wrap="square" lIns="50800" tIns="50800" rIns="50800" bIns="50800" rtlCol="0" anchor="ctr"/>
           <a:lstStyle/>
           <a:p>
             <a:pPr algn="ctr" indent="0" marL="0">
               <a:buNone/>
             </a:pPr>
             <a:r>
-              <a:rPr lang="en-US" sz="1300" dirty="0">
+              <a:rPr lang="en-US" sz="1200" dirty="0">
                 <a:solidFill>
                   <a:srgbClr val="4A5568"/>
                 </a:solidFill>
@@ -2184,47 +2262,54 @@
                 <a:ea typeface="Calibri" pitchFamily="34" charset="-122"/>
                 <a:cs typeface="Calibri" pitchFamily="34" charset="-120"/>
               </a:rPr>
-              <a:t>de la producción de frutas
-</a:t>
-            </a:r>
+              <a:t>de la producción de frutas se pierde post-cosecha en Chile</a:t>
+            </a:r>
+            <a:endParaRPr lang="en-US" sz="1200" dirty="0"/>
+          </a:p>
+        </p:txBody>
+      </p:sp>
+      <p:sp>
+        <p:nvSpPr>
+          <p:cNvPr id="7" name="Text 5"/>
+          <p:cNvSpPr/>
+          <p:nvPr/>
+        </p:nvSpPr>
+        <p:spPr>
+          <a:xfrm>
+            <a:off x="502920" y="2971800"/>
+            <a:ext cx="2651760" cy="274320"/>
+          </a:xfrm>
+          <a:prstGeom prst="rect">
+            <a:avLst/>
+          </a:prstGeom>
+          <a:noFill/>
+          <a:ln/>
+        </p:spPr>
+        <p:txBody>
+          <a:bodyPr wrap="square" lIns="0" tIns="0" rIns="0" bIns="0" rtlCol="0" anchor="ctr"/>
+          <a:lstStyle/>
+          <a:p>
             <a:pPr algn="ctr" indent="0" marL="0">
               <a:buNone/>
             </a:pPr>
             <a:r>
-              <a:rPr lang="en-US" sz="1300" dirty="0">
-                <a:solidFill>
-                  <a:srgbClr val="4A5568"/>
-                </a:solidFill>
-                <a:latin typeface="Calibri" pitchFamily="34" charset="0"/>
-                <a:ea typeface="Calibri" pitchFamily="34" charset="-122"/>
-                <a:cs typeface="Calibri" pitchFamily="34" charset="-120"/>
-              </a:rPr>
-              <a:t>se pierde post-cosecha</a:t>
-            </a:r>
-            <a:endParaRPr lang="en-US" sz="1300" dirty="0"/>
-          </a:p>
-          <a:p>
-            <a:pPr algn="ctr" indent="0" marL="0">
-              <a:buNone/>
-            </a:pPr>
-            <a:r>
-              <a:rPr lang="en-US" sz="1300" dirty="0">
-                <a:solidFill>
-                  <a:srgbClr val="4A5568"/>
-                </a:solidFill>
-                <a:latin typeface="Calibri" pitchFamily="34" charset="0"/>
-                <a:ea typeface="Calibri" pitchFamily="34" charset="-122"/>
-                <a:cs typeface="Calibri" pitchFamily="34" charset="-120"/>
-              </a:rPr>
-              <a:t>en Chile (FAO / ODEPA)</a:t>
-            </a:r>
-            <a:endParaRPr lang="en-US" sz="1300" dirty="0"/>
-          </a:p>
-        </p:txBody>
-      </p:sp>
-      <p:sp>
-        <p:nvSpPr>
-          <p:cNvPr id="7" name="Shape 5"/>
+              <a:rPr lang="en-US" sz="1000" i="1" dirty="0">
+                <a:solidFill>
+                  <a:srgbClr val="718096"/>
+                </a:solidFill>
+                <a:latin typeface="Calibri" pitchFamily="34" charset="0"/>
+                <a:ea typeface="Calibri" pitchFamily="34" charset="-122"/>
+                <a:cs typeface="Calibri" pitchFamily="34" charset="-120"/>
+              </a:rPr>
+              <a:t>Fuente: FAO  ·  ODEPA</a:t>
+            </a:r>
+            <a:endParaRPr lang="en-US" sz="1000" dirty="0"/>
+          </a:p>
+        </p:txBody>
+      </p:sp>
+      <p:sp>
+        <p:nvSpPr>
+          <p:cNvPr id="8" name="Shape 6"/>
           <p:cNvSpPr/>
           <p:nvPr/>
         </p:nvSpPr>
@@ -2256,7 +2341,7 @@
       </p:sp>
       <p:sp>
         <p:nvSpPr>
-          <p:cNvPr id="8" name="Text 6"/>
+          <p:cNvPr id="9" name="Text 7"/>
           <p:cNvSpPr/>
           <p:nvPr/>
         </p:nvSpPr>
@@ -2292,7 +2377,7 @@
       </p:sp>
       <p:sp>
         <p:nvSpPr>
-          <p:cNvPr id="9" name="Text 7"/>
+          <p:cNvPr id="10" name="Text 8"/>
           <p:cNvSpPr/>
           <p:nvPr/>
         </p:nvSpPr>
@@ -2331,7 +2416,7 @@
       </p:sp>
       <p:sp>
         <p:nvSpPr>
-          <p:cNvPr id="10" name="Text 8"/>
+          <p:cNvPr id="11" name="Text 9"/>
           <p:cNvSpPr/>
           <p:nvPr/>
         </p:nvSpPr>
@@ -2370,7 +2455,7 @@
       </p:sp>
       <p:sp>
         <p:nvSpPr>
-          <p:cNvPr id="11" name="Shape 9"/>
+          <p:cNvPr id="12" name="Shape 10"/>
           <p:cNvSpPr/>
           <p:nvPr/>
         </p:nvSpPr>
@@ -2402,7 +2487,7 @@
       </p:sp>
       <p:sp>
         <p:nvSpPr>
-          <p:cNvPr id="12" name="Text 10"/>
+          <p:cNvPr id="13" name="Text 11"/>
           <p:cNvSpPr/>
           <p:nvPr/>
         </p:nvSpPr>
@@ -2438,7 +2523,7 @@
       </p:sp>
       <p:sp>
         <p:nvSpPr>
-          <p:cNvPr id="13" name="Text 11"/>
+          <p:cNvPr id="14" name="Text 12"/>
           <p:cNvSpPr/>
           <p:nvPr/>
         </p:nvSpPr>
@@ -2477,7 +2562,7 @@
       </p:sp>
       <p:sp>
         <p:nvSpPr>
-          <p:cNvPr id="14" name="Text 12"/>
+          <p:cNvPr id="15" name="Text 13"/>
           <p:cNvSpPr/>
           <p:nvPr/>
         </p:nvSpPr>
@@ -2516,7 +2601,7 @@
       </p:sp>
       <p:sp>
         <p:nvSpPr>
-          <p:cNvPr id="15" name="Shape 13"/>
+          <p:cNvPr id="16" name="Shape 14"/>
           <p:cNvSpPr/>
           <p:nvPr/>
         </p:nvSpPr>
@@ -2548,7 +2633,7 @@
       </p:sp>
       <p:sp>
         <p:nvSpPr>
-          <p:cNvPr id="16" name="Text 14"/>
+          <p:cNvPr id="17" name="Text 15"/>
           <p:cNvSpPr/>
           <p:nvPr/>
         </p:nvSpPr>
@@ -2584,7 +2669,7 @@
       </p:sp>
       <p:sp>
         <p:nvSpPr>
-          <p:cNvPr id="17" name="Text 15"/>
+          <p:cNvPr id="18" name="Text 16"/>
           <p:cNvSpPr/>
           <p:nvPr/>
         </p:nvSpPr>
@@ -2623,7 +2708,7 @@
       </p:sp>
       <p:sp>
         <p:nvSpPr>
-          <p:cNvPr id="18" name="Text 16"/>
+          <p:cNvPr id="19" name="Text 17"/>
           <p:cNvSpPr/>
           <p:nvPr/>
         </p:nvSpPr>
@@ -2662,7 +2747,7 @@
       </p:sp>
       <p:sp>
         <p:nvSpPr>
-          <p:cNvPr id="19" name="Text 17"/>
+          <p:cNvPr id="20" name="Text 18"/>
           <p:cNvSpPr/>
           <p:nvPr/>
         </p:nvSpPr>
@@ -2955,34 +3040,14 @@
       </p:sp>
       <p:sp>
         <p:nvSpPr>
-          <p:cNvPr id="8" name="Shape 6"/>
-          <p:cNvSpPr/>
-          <p:nvPr/>
-        </p:nvSpPr>
-        <p:spPr>
-          <a:xfrm>
-            <a:off x="2971800" y="2057400"/>
-            <a:ext cx="320040" cy="109728"/>
-          </a:xfrm>
-          <a:prstGeom prst="rect">
-            <a:avLst/>
-          </a:prstGeom>
-          <a:solidFill>
-            <a:srgbClr val="4CAF50"/>
-          </a:solidFill>
-          <a:ln/>
-        </p:spPr>
-      </p:sp>
-      <p:sp>
-        <p:nvSpPr>
-          <p:cNvPr id="9" name="Text 7"/>
-          <p:cNvSpPr/>
-          <p:nvPr/>
-        </p:nvSpPr>
-        <p:spPr>
-          <a:xfrm>
-            <a:off x="2944368" y="1920240"/>
-            <a:ext cx="365760" cy="347472"/>
+          <p:cNvPr id="8" name="Text 6"/>
+          <p:cNvSpPr/>
+          <p:nvPr/>
+        </p:nvSpPr>
+        <p:spPr>
+          <a:xfrm>
+            <a:off x="2944368" y="1993392"/>
+            <a:ext cx="365760" cy="365760"/>
           </a:xfrm>
           <a:prstGeom prst="rect">
             <a:avLst/>
@@ -2998,20 +3063,23 @@
               <a:buNone/>
             </a:pPr>
             <a:r>
-              <a:rPr lang="en-US" sz="1800" dirty="0">
+              <a:rPr lang="en-US" sz="2400" dirty="0">
                 <a:solidFill>
                   <a:srgbClr val="4CAF50"/>
                 </a:solidFill>
-              </a:rPr>
-              <a:t>→</a:t>
-            </a:r>
-            <a:endParaRPr lang="en-US" sz="1800" dirty="0"/>
-          </a:p>
-        </p:txBody>
-      </p:sp>
-      <p:sp>
-        <p:nvSpPr>
-          <p:cNvPr id="10" name="Shape 8"/>
+                <a:latin typeface="Calibri" pitchFamily="34" charset="0"/>
+                <a:ea typeface="Calibri" pitchFamily="34" charset="-122"/>
+                <a:cs typeface="Calibri" pitchFamily="34" charset="-120"/>
+              </a:rPr>
+              <a:t>▶</a:t>
+            </a:r>
+            <a:endParaRPr lang="en-US" sz="2400" dirty="0"/>
+          </a:p>
+        </p:txBody>
+      </p:sp>
+      <p:sp>
+        <p:nvSpPr>
+          <p:cNvPr id="9" name="Shape 7"/>
           <p:cNvSpPr/>
           <p:nvPr/>
         </p:nvSpPr>
@@ -3043,7 +3111,7 @@
       </p:sp>
       <p:sp>
         <p:nvSpPr>
-          <p:cNvPr id="11" name="Text 9"/>
+          <p:cNvPr id="10" name="Text 8"/>
           <p:cNvSpPr/>
           <p:nvPr/>
         </p:nvSpPr>
@@ -3079,7 +3147,7 @@
       </p:sp>
       <p:sp>
         <p:nvSpPr>
-          <p:cNvPr id="12" name="Text 10"/>
+          <p:cNvPr id="11" name="Text 9"/>
           <p:cNvSpPr/>
           <p:nvPr/>
         </p:nvSpPr>
@@ -3118,7 +3186,7 @@
       </p:sp>
       <p:sp>
         <p:nvSpPr>
-          <p:cNvPr id="13" name="Text 11"/>
+          <p:cNvPr id="12" name="Text 10"/>
           <p:cNvSpPr/>
           <p:nvPr/>
         </p:nvSpPr>
@@ -3174,63 +3242,46 @@
       </p:sp>
       <p:sp>
         <p:nvSpPr>
+          <p:cNvPr id="13" name="Text 11"/>
+          <p:cNvSpPr/>
+          <p:nvPr/>
+        </p:nvSpPr>
+        <p:spPr>
+          <a:xfrm>
+            <a:off x="5779008" y="1993392"/>
+            <a:ext cx="365760" cy="365760"/>
+          </a:xfrm>
+          <a:prstGeom prst="rect">
+            <a:avLst/>
+          </a:prstGeom>
+          <a:noFill/>
+          <a:ln/>
+        </p:spPr>
+        <p:txBody>
+          <a:bodyPr wrap="square" lIns="0" tIns="0" rIns="0" bIns="0" rtlCol="0" anchor="ctr"/>
+          <a:lstStyle/>
+          <a:p>
+            <a:pPr algn="ctr" indent="0" marL="0">
+              <a:buNone/>
+            </a:pPr>
+            <a:r>
+              <a:rPr lang="en-US" sz="2400" dirty="0">
+                <a:solidFill>
+                  <a:srgbClr val="4CAF50"/>
+                </a:solidFill>
+                <a:latin typeface="Calibri" pitchFamily="34" charset="0"/>
+                <a:ea typeface="Calibri" pitchFamily="34" charset="-122"/>
+                <a:cs typeface="Calibri" pitchFamily="34" charset="-120"/>
+              </a:rPr>
+              <a:t>▶</a:t>
+            </a:r>
+            <a:endParaRPr lang="en-US" sz="2400" dirty="0"/>
+          </a:p>
+        </p:txBody>
+      </p:sp>
+      <p:sp>
+        <p:nvSpPr>
           <p:cNvPr id="14" name="Shape 12"/>
-          <p:cNvSpPr/>
-          <p:nvPr/>
-        </p:nvSpPr>
-        <p:spPr>
-          <a:xfrm>
-            <a:off x="5806440" y="2057400"/>
-            <a:ext cx="320040" cy="109728"/>
-          </a:xfrm>
-          <a:prstGeom prst="rect">
-            <a:avLst/>
-          </a:prstGeom>
-          <a:solidFill>
-            <a:srgbClr val="4CAF50"/>
-          </a:solidFill>
-          <a:ln/>
-        </p:spPr>
-      </p:sp>
-      <p:sp>
-        <p:nvSpPr>
-          <p:cNvPr id="15" name="Text 13"/>
-          <p:cNvSpPr/>
-          <p:nvPr/>
-        </p:nvSpPr>
-        <p:spPr>
-          <a:xfrm>
-            <a:off x="5779008" y="1920240"/>
-            <a:ext cx="365760" cy="347472"/>
-          </a:xfrm>
-          <a:prstGeom prst="rect">
-            <a:avLst/>
-          </a:prstGeom>
-          <a:noFill/>
-          <a:ln/>
-        </p:spPr>
-        <p:txBody>
-          <a:bodyPr wrap="square" lIns="0" tIns="0" rIns="0" bIns="0" rtlCol="0" anchor="ctr"/>
-          <a:lstStyle/>
-          <a:p>
-            <a:pPr algn="ctr" indent="0" marL="0">
-              <a:buNone/>
-            </a:pPr>
-            <a:r>
-              <a:rPr lang="en-US" sz="1800" dirty="0">
-                <a:solidFill>
-                  <a:srgbClr val="4CAF50"/>
-                </a:solidFill>
-              </a:rPr>
-              <a:t>→</a:t>
-            </a:r>
-            <a:endParaRPr lang="en-US" sz="1800" dirty="0"/>
-          </a:p>
-        </p:txBody>
-      </p:sp>
-      <p:sp>
-        <p:nvSpPr>
-          <p:cNvPr id="16" name="Shape 14"/>
           <p:cNvSpPr/>
           <p:nvPr/>
         </p:nvSpPr>
@@ -3262,7 +3313,7 @@
       </p:sp>
       <p:sp>
         <p:nvSpPr>
-          <p:cNvPr id="17" name="Text 15"/>
+          <p:cNvPr id="15" name="Text 13"/>
           <p:cNvSpPr/>
           <p:nvPr/>
         </p:nvSpPr>
@@ -3298,7 +3349,7 @@
       </p:sp>
       <p:sp>
         <p:nvSpPr>
-          <p:cNvPr id="18" name="Text 16"/>
+          <p:cNvPr id="16" name="Text 14"/>
           <p:cNvSpPr/>
           <p:nvPr/>
         </p:nvSpPr>
@@ -3337,7 +3388,7 @@
       </p:sp>
       <p:sp>
         <p:nvSpPr>
-          <p:cNvPr id="19" name="Text 17"/>
+          <p:cNvPr id="17" name="Text 15"/>
           <p:cNvSpPr/>
           <p:nvPr/>
         </p:nvSpPr>
@@ -3393,7 +3444,7 @@
       </p:sp>
       <p:sp>
         <p:nvSpPr>
-          <p:cNvPr id="20" name="Text 18"/>
+          <p:cNvPr id="18" name="Text 16"/>
           <p:cNvSpPr/>
           <p:nvPr/>
         </p:nvSpPr>
@@ -3432,7 +3483,7 @@
       </p:sp>
       <p:sp>
         <p:nvSpPr>
-          <p:cNvPr id="21" name="Shape 19"/>
+          <p:cNvPr id="19" name="Shape 17"/>
           <p:cNvSpPr/>
           <p:nvPr/>
         </p:nvSpPr>
@@ -3464,7 +3515,7 @@
       </p:sp>
       <p:sp>
         <p:nvSpPr>
-          <p:cNvPr id="22" name="Text 20"/>
+          <p:cNvPr id="20" name="Text 18"/>
           <p:cNvSpPr/>
           <p:nvPr/>
         </p:nvSpPr>
@@ -3500,7 +3551,7 @@
       </p:sp>
       <p:sp>
         <p:nvSpPr>
-          <p:cNvPr id="23" name="Text 21"/>
+          <p:cNvPr id="21" name="Text 19"/>
           <p:cNvSpPr/>
           <p:nvPr/>
         </p:nvSpPr>
@@ -3539,7 +3590,7 @@
       </p:sp>
       <p:sp>
         <p:nvSpPr>
-          <p:cNvPr id="24" name="Shape 22"/>
+          <p:cNvPr id="22" name="Shape 20"/>
           <p:cNvSpPr/>
           <p:nvPr/>
         </p:nvSpPr>
@@ -3571,7 +3622,7 @@
       </p:sp>
       <p:sp>
         <p:nvSpPr>
-          <p:cNvPr id="25" name="Text 23"/>
+          <p:cNvPr id="23" name="Text 21"/>
           <p:cNvSpPr/>
           <p:nvPr/>
         </p:nvSpPr>
@@ -3607,7 +3658,7 @@
       </p:sp>
       <p:sp>
         <p:nvSpPr>
-          <p:cNvPr id="26" name="Text 24"/>
+          <p:cNvPr id="24" name="Text 22"/>
           <p:cNvSpPr/>
           <p:nvPr/>
         </p:nvSpPr>
@@ -3646,7 +3697,7 @@
       </p:sp>
       <p:sp>
         <p:nvSpPr>
-          <p:cNvPr id="27" name="Shape 25"/>
+          <p:cNvPr id="25" name="Shape 23"/>
           <p:cNvSpPr/>
           <p:nvPr/>
         </p:nvSpPr>
@@ -3678,7 +3729,7 @@
       </p:sp>
       <p:sp>
         <p:nvSpPr>
-          <p:cNvPr id="28" name="Text 26"/>
+          <p:cNvPr id="26" name="Text 24"/>
           <p:cNvSpPr/>
           <p:nvPr/>
         </p:nvSpPr>
@@ -3714,7 +3765,7 @@
       </p:sp>
       <p:sp>
         <p:nvSpPr>
-          <p:cNvPr id="29" name="Text 27"/>
+          <p:cNvPr id="27" name="Text 25"/>
           <p:cNvSpPr/>
           <p:nvPr/>
         </p:nvSpPr>
@@ -3753,7 +3804,7 @@
       </p:sp>
       <p:sp>
         <p:nvSpPr>
-          <p:cNvPr id="30" name="Shape 28"/>
+          <p:cNvPr id="28" name="Shape 26"/>
           <p:cNvSpPr/>
           <p:nvPr/>
         </p:nvSpPr>
@@ -3785,7 +3836,7 @@
       </p:sp>
       <p:sp>
         <p:nvSpPr>
-          <p:cNvPr id="31" name="Text 29"/>
+          <p:cNvPr id="29" name="Text 27"/>
           <p:cNvSpPr/>
           <p:nvPr/>
         </p:nvSpPr>
@@ -3821,7 +3872,7 @@
       </p:sp>
       <p:sp>
         <p:nvSpPr>
-          <p:cNvPr id="32" name="Text 30"/>
+          <p:cNvPr id="30" name="Text 28"/>
           <p:cNvSpPr/>
           <p:nvPr/>
         </p:nvSpPr>
@@ -5076,7 +5127,7 @@
                 <a:ea typeface="Calibri" pitchFamily="34" charset="-122"/>
                 <a:cs typeface="Calibri" pitchFamily="34" charset="-120"/>
               </a:rPr>
-              <a:t>Clases, DTOs,</a:t>
+              <a:t>Clases, DTOs y</a:t>
             </a:r>
             <a:endParaRPr lang="en-US" sz="1200" dirty="0"/>
           </a:p>
@@ -5093,7 +5144,7 @@
                 <a:ea typeface="Calibri" pitchFamily="34" charset="-122"/>
                 <a:cs typeface="Calibri" pitchFamily="34" charset="-120"/>
               </a:rPr>
-              <a:t>componentes</a:t>
+              <a:t>componentes del dominio</a:t>
             </a:r>
             <a:endParaRPr lang="en-US" sz="1200" dirty="0"/>
           </a:p>
@@ -5279,7 +5330,7 @@
                 <a:ea typeface="Calibri" pitchFamily="34" charset="-122"/>
                 <a:cs typeface="Calibri" pitchFamily="34" charset="-120"/>
               </a:rPr>
-              <a:t>concurrencia</a:t>
+              <a:t>concurrencia FastAPI</a:t>
             </a:r>
             <a:endParaRPr lang="en-US" sz="1200" dirty="0"/>
           </a:p>
@@ -5465,7 +5516,7 @@
                 <a:ea typeface="Calibri" pitchFamily="34" charset="-122"/>
                 <a:cs typeface="Calibri" pitchFamily="34" charset="-120"/>
               </a:rPr>
-              <a:t>Clean Backend</a:t>
+              <a:t>Clean Architecture</a:t>
             </a:r>
             <a:endParaRPr lang="en-US" sz="1200" dirty="0"/>
           </a:p>
@@ -5634,7 +5685,7 @@
                 <a:ea typeface="Calibri" pitchFamily="34" charset="-122"/>
                 <a:cs typeface="Calibri" pitchFamily="34" charset="-120"/>
               </a:rPr>
-              <a:t>Android→Render</a:t>
+              <a:t>Despliegue cloud</a:t>
             </a:r>
             <a:endParaRPr lang="en-US" sz="1200" dirty="0"/>
           </a:p>
@@ -5651,7 +5702,7 @@
                 <a:ea typeface="Calibri" pitchFamily="34" charset="-122"/>
                 <a:cs typeface="Calibri" pitchFamily="34" charset="-120"/>
               </a:rPr>
-              <a:t>→Supabase</a:t>
+              <a:t>Android · API · BD</a:t>
             </a:r>
             <a:endParaRPr lang="en-US" sz="1200" dirty="0"/>
           </a:p>
@@ -6467,59 +6518,17 @@
               <a:buNone/>
             </a:pPr>
             <a:r>
-              <a:rPr lang="en-US" sz="1200" dirty="0">
-                <a:solidFill>
-                  <a:srgbClr val="718096"/>
-                </a:solidFill>
-                <a:latin typeface="Calibri" pitchFamily="34" charset="0"/>
-                <a:ea typeface="Calibri" pitchFamily="34" charset="-122"/>
-                <a:cs typeface="Calibri" pitchFamily="34" charset="-120"/>
-              </a:rPr>
-              <a:t>80 épocas  ·  </a:t>
-            </a:r>
-            <a:pPr algn="ctr" indent="0" marL="0">
-              <a:buNone/>
-            </a:pPr>
-            <a:r>
-              <a:rPr lang="en-US" sz="1200" dirty="0">
-                <a:solidFill>
-                  <a:srgbClr val="718096"/>
-                </a:solidFill>
-                <a:latin typeface="Calibri" pitchFamily="34" charset="0"/>
-                <a:ea typeface="Calibri" pitchFamily="34" charset="-122"/>
-                <a:cs typeface="Calibri" pitchFamily="34" charset="-120"/>
-              </a:rPr>
-              <a:t>31.940 imágenes  ·  </a:t>
-            </a:r>
-            <a:pPr algn="ctr" indent="0" marL="0">
-              <a:buNone/>
-            </a:pPr>
-            <a:r>
-              <a:rPr lang="en-US" sz="1200" dirty="0">
-                <a:solidFill>
-                  <a:srgbClr val="718096"/>
-                </a:solidFill>
-                <a:latin typeface="Calibri" pitchFamily="34" charset="0"/>
-                <a:ea typeface="Calibri" pitchFamily="34" charset="-122"/>
-                <a:cs typeface="Calibri" pitchFamily="34" charset="-120"/>
-              </a:rPr>
-              <a:t>Kaggle Tesla T4 ×2  ·  </a:t>
-            </a:r>
-            <a:pPr algn="ctr" indent="0" marL="0">
-              <a:buNone/>
-            </a:pPr>
-            <a:r>
-              <a:rPr lang="en-US" sz="1200" dirty="0">
-                <a:solidFill>
-                  <a:srgbClr val="718096"/>
-                </a:solidFill>
-                <a:latin typeface="Calibri" pitchFamily="34" charset="0"/>
-                <a:ea typeface="Calibri" pitchFamily="34" charset="-122"/>
-                <a:cs typeface="Calibri" pitchFamily="34" charset="-120"/>
-              </a:rPr>
-              <a:t>YOLO26n (Ultralytics)</a:t>
-            </a:r>
-            <a:endParaRPr lang="en-US" sz="1200" dirty="0"/>
+              <a:rPr lang="en-US" sz="1300" dirty="0">
+                <a:solidFill>
+                  <a:srgbClr val="C8E6C9"/>
+                </a:solidFill>
+                <a:latin typeface="Calibri" pitchFamily="34" charset="0"/>
+                <a:ea typeface="Calibri" pitchFamily="34" charset="-122"/>
+                <a:cs typeface="Calibri" pitchFamily="34" charset="-120"/>
+              </a:rPr>
+              <a:t>80 épocas  ·  31.940 imágenes  ·  Kaggle Tesla T4 ×2  ·  YOLO26n (Ultralytics)</a:t>
+            </a:r>
+            <a:endParaRPr lang="en-US" sz="1300" dirty="0"/>
           </a:p>
         </p:txBody>
       </p:sp>
@@ -7075,7 +7084,7 @@
                 <a:ea typeface="Calibri" pitchFamily="34" charset="-122"/>
                 <a:cs typeface="Calibri" pitchFamily="34" charset="-120"/>
               </a:rPr>
-              <a:t>Room + historial paginado</a:t>
+              <a:t>Persistencia + historial paginado</a:t>
             </a:r>
             <a:endParaRPr lang="en-US" sz="1300" dirty="0"/>
           </a:p>
@@ -7115,7 +7124,7 @@
                 <a:ea typeface="Calibri" pitchFamily="34" charset="-122"/>
                 <a:cs typeface="Calibri" pitchFamily="34" charset="-120"/>
               </a:rPr>
-              <a:t>9 / 9 tests pytest pasando</a:t>
+              <a:t>9/9 tests pytest pasando</a:t>
             </a:r>
             <a:endParaRPr lang="en-US" sz="1300" dirty="0"/>
           </a:p>

</xml_diff>

<commit_message>
docs: actualizar informe Word y PPT con cambios manuales
Cambios aplicados manualmente por el autor:
- Informe_Evaluacion_2_MaduraApp.docx: contenido actualizado (portada, datos del grupo)
- MaduraApp_Presentacion_Evaluacion2.pptx: ajustes finales de presentacion
</commit_message>
<xml_diff>
--- a/Documentación/Evaluacion_2/MaduraApp_Presentacion_Evaluacion2.pptx
+++ b/Documentación/Evaluacion_2/MaduraApp_Presentacion_Evaluacion2.pptx
@@ -4,6 +4,9 @@
   <p:sldMasterIdLst>
     <p:sldMasterId id="2147483648" r:id="rId1"/>
   </p:sldMasterIdLst>
+  <p:notesMasterIdLst>
+    <p:notesMasterId r:id="rId11"/>
+  </p:notesMasterIdLst>
   <p:sldIdLst>
     <p:sldId id="256" r:id="rId2"/>
     <p:sldId id="257" r:id="rId3"/>
@@ -15,10 +18,7 @@
     <p:sldId id="263" r:id="rId9"/>
     <p:sldId id="264" r:id="rId10"/>
   </p:sldIdLst>
-  <p:notesMasterIdLst>
-    <p:notesMasterId r:id="rId11"/>
-  </p:notesMasterIdLst>
-  <p:sldSz cx="9144000" cy="5143500"/>
+  <p:sldSz cx="9144000" cy="5143500" type="screen16x9"/>
   <p:notesSz cx="5143500" cy="9144000"/>
   <p:defaultTextStyle>
     <a:lvl1pPr marL="0" algn="l" defTabSz="914400" rtl="0" eaLnBrk="1" latinLnBrk="0" hangingPunct="1">
@@ -112,6 +112,11 @@
       </a:defRPr>
     </a:lvl9pPr>
   </p:defaultTextStyle>
+  <p:extLst>
+    <p:ext uri="{EFAFB233-063F-42B5-8137-9DF3F51BA10A}">
+      <p15:sldGuideLst xmlns:p15="http://schemas.microsoft.com/office/powerpoint/2012/main"/>
+    </p:ext>
+  </p:extLst>
 </p:presentation>
 </file>
 
@@ -137,234 +142,10 @@
           <a:chExt cx="0" cy="0"/>
         </a:xfrm>
       </p:grpSpPr>
-      <p:sp>
-        <p:nvSpPr>
-          <p:cNvPr id="2" name="Header Placeholder 1"/>
-          <p:cNvSpPr>
-            <a:spLocks noGrp="1"/>
-          </p:cNvSpPr>
-          <p:nvPr>
-            <p:ph type="hdr" sz="quarter"/>
-          </p:nvPr>
-        </p:nvSpPr>
-        <p:spPr>
-          <a:xfrm>
-            <a:off x="0" y="0"/>
-            <a:ext cx="2971800" cy="458788"/>
-          </a:xfrm>
-          <a:prstGeom prst="rect">
-            <a:avLst/>
-          </a:prstGeom>
-        </p:spPr>
-        <p:txBody>
-          <a:bodyPr vert="horz" lIns="91440" tIns="45720" rIns="91440" bIns="45720" rtlCol="0"/>
-          <a:lstStyle>
-            <a:lvl1pPr algn="l">
-              <a:defRPr sz="1200"/>
-            </a:lvl1pPr>
-          </a:lstStyle>
-          <a:p>
-            <a:endParaRPr lang="en-US"/>
-          </a:p>
-        </p:txBody>
-      </p:sp>
-      <p:sp>
-        <p:nvSpPr>
-          <p:cNvPr id="3" name="Date Placeholder 2"/>
-          <p:cNvSpPr>
-            <a:spLocks noGrp="1"/>
-          </p:cNvSpPr>
-          <p:nvPr>
-            <p:ph type="dt" idx="1"/>
-          </p:nvPr>
-        </p:nvSpPr>
-        <p:spPr>
-          <a:xfrm>
-            <a:off x="3884613" y="0"/>
-            <a:ext cx="2971800" cy="458788"/>
-          </a:xfrm>
-          <a:prstGeom prst="rect">
-            <a:avLst/>
-          </a:prstGeom>
-        </p:spPr>
-        <p:txBody>
-          <a:bodyPr vert="horz" lIns="91440" tIns="45720" rIns="91440" bIns="45720" rtlCol="0"/>
-          <a:lstStyle>
-            <a:lvl1pPr algn="r">
-              <a:defRPr sz="1200"/>
-            </a:lvl1pPr>
-          </a:lstStyle>
-          <a:p>
-            <a:fld id="{5282F153-3F37-0F45-9E97-73ACFA13230C}" type="datetimeFigureOut">
-              <a:rPr lang="en-US"/>
-              <a:t>7/23/19</a:t>
-            </a:fld>
-            <a:endParaRPr lang="en-US"/>
-          </a:p>
-        </p:txBody>
-      </p:sp>
-      <p:sp>
-        <p:nvSpPr>
-          <p:cNvPr id="4" name="Slide Image Placeholder 3"/>
-          <p:cNvSpPr>
-            <a:spLocks noGrp="1" noRot="1" noChangeAspect="1"/>
-          </p:cNvSpPr>
-          <p:nvPr>
-            <p:ph type="sldImg" idx="2"/>
-          </p:nvPr>
-        </p:nvSpPr>
-        <p:spPr>
-          <a:xfrm>
-            <a:off x="685800" y="1143000"/>
-            <a:ext cx="5486400" cy="3086100"/>
-          </a:xfrm>
-          <a:prstGeom prst="rect">
-            <a:avLst/>
-          </a:prstGeom>
-          <a:noFill/>
-          <a:ln w="12700">
-            <a:solidFill>
-              <a:prstClr val="black"/>
-            </a:solidFill>
-          </a:ln>
-        </p:spPr>
-        <p:txBody>
-          <a:bodyPr vert="horz" lIns="91440" tIns="45720" rIns="91440" bIns="45720" rtlCol="0" anchor="ctr"/>
-          <a:lstStyle/>
-          <a:p>
-            <a:endParaRPr lang="en-US"/>
-          </a:p>
-        </p:txBody>
-      </p:sp>
-      <p:sp>
-        <p:nvSpPr>
-          <p:cNvPr id="5" name="Notes Placeholder 4"/>
-          <p:cNvSpPr>
-            <a:spLocks noGrp="1"/>
-          </p:cNvSpPr>
-          <p:nvPr>
-            <p:ph type="body" sz="quarter" idx="3"/>
-          </p:nvPr>
-        </p:nvSpPr>
-        <p:spPr>
-          <a:xfrm>
-            <a:off x="685800" y="4400550"/>
-            <a:ext cx="5486400" cy="3600450"/>
-          </a:xfrm>
-          <a:prstGeom prst="rect">
-            <a:avLst/>
-          </a:prstGeom>
-        </p:spPr>
-        <p:txBody>
-          <a:bodyPr vert="horz" lIns="91440" tIns="45720" rIns="91440" bIns="45720" rtlCol="0"/>
-          <a:lstStyle/>
-          <a:p>
-            <a:pPr lvl="0"/>
-            <a:r>
-              <a:rPr lang="en-US"/>
-              <a:t>Click to edit Master text styles</a:t>
-            </a:r>
-          </a:p>
-          <a:p>
-            <a:pPr lvl="1"/>
-            <a:r>
-              <a:rPr lang="en-US"/>
-              <a:t>Second level</a:t>
-            </a:r>
-          </a:p>
-          <a:p>
-            <a:pPr lvl="2"/>
-            <a:r>
-              <a:rPr lang="en-US"/>
-              <a:t>Third level</a:t>
-            </a:r>
-          </a:p>
-          <a:p>
-            <a:pPr lvl="3"/>
-            <a:r>
-              <a:rPr lang="en-US"/>
-              <a:t>Fourth level</a:t>
-            </a:r>
-          </a:p>
-          <a:p>
-            <a:pPr lvl="4"/>
-            <a:r>
-              <a:rPr lang="en-US"/>
-              <a:t>Fifth level</a:t>
-            </a:r>
-          </a:p>
-        </p:txBody>
-      </p:sp>
-      <p:sp>
-        <p:nvSpPr>
-          <p:cNvPr id="6" name="Footer Placeholder 5"/>
-          <p:cNvSpPr>
-            <a:spLocks noGrp="1"/>
-          </p:cNvSpPr>
-          <p:nvPr>
-            <p:ph type="ftr" sz="quarter" idx="4"/>
-          </p:nvPr>
-        </p:nvSpPr>
-        <p:spPr>
-          <a:xfrm>
-            <a:off x="0" y="8685213"/>
-            <a:ext cx="2971800" cy="458787"/>
-          </a:xfrm>
-          <a:prstGeom prst="rect">
-            <a:avLst/>
-          </a:prstGeom>
-        </p:spPr>
-        <p:txBody>
-          <a:bodyPr vert="horz" lIns="91440" tIns="45720" rIns="91440" bIns="45720" rtlCol="0" anchor="b"/>
-          <a:lstStyle>
-            <a:lvl1pPr algn="l">
-              <a:defRPr sz="1200"/>
-            </a:lvl1pPr>
-          </a:lstStyle>
-          <a:p>
-            <a:endParaRPr lang="en-US"/>
-          </a:p>
-        </p:txBody>
-      </p:sp>
-      <p:sp>
-        <p:nvSpPr>
-          <p:cNvPr id="7" name="Slide Number Placeholder 6"/>
-          <p:cNvSpPr>
-            <a:spLocks noGrp="1"/>
-          </p:cNvSpPr>
-          <p:nvPr>
-            <p:ph type="sldNum" sz="quarter" idx="5"/>
-          </p:nvPr>
-        </p:nvSpPr>
-        <p:spPr>
-          <a:xfrm>
-            <a:off x="3884613" y="8685213"/>
-            <a:ext cx="2971800" cy="458787"/>
-          </a:xfrm>
-          <a:prstGeom prst="rect">
-            <a:avLst/>
-          </a:prstGeom>
-        </p:spPr>
-        <p:txBody>
-          <a:bodyPr vert="horz" lIns="91440" tIns="45720" rIns="91440" bIns="45720" rtlCol="0" anchor="b"/>
-          <a:lstStyle>
-            <a:lvl1pPr algn="r">
-              <a:defRPr sz="1200"/>
-            </a:lvl1pPr>
-          </a:lstStyle>
-          <a:p>
-            <a:fld id="{CE5E9CC1-C706-0F49-92D6-E571CC5EEA8F}" type="slidenum">
-              <a:rPr lang="en-US"/>
-              <a:t>‹#›</a:t>
-            </a:fld>
-            <a:endParaRPr lang="en-US"/>
-          </a:p>
-        </p:txBody>
-      </p:sp>
     </p:spTree>
     <p:extLst>
       <p:ext uri="{BB962C8B-B14F-4D97-AF65-F5344CB8AC3E}">
-        <p14:creationId xmlns:p14="http://schemas.microsoft.com/office/powerpoint/2010/main" val="1024086991"/>
+        <p14:creationId xmlns:p14="http://schemas.microsoft.com/office/powerpoint/2010/main" val="2441036924"/>
       </p:ext>
     </p:extLst>
   </p:cSld>
@@ -508,10 +289,6 @@
           <a:bodyPr/>
           <a:lstStyle/>
           <a:p>
-            <a:r>
-              <a:rPr lang="en-US" dirty="0"/>
-              <a:t/>
-            </a:r>
             <a:endParaRPr lang="en-US" dirty="0"/>
           </a:p>
         </p:txBody>
@@ -596,10 +373,6 @@
           <a:bodyPr/>
           <a:lstStyle/>
           <a:p>
-            <a:r>
-              <a:rPr lang="en-US" dirty="0"/>
-              <a:t/>
-            </a:r>
             <a:endParaRPr lang="en-US" dirty="0"/>
           </a:p>
         </p:txBody>
@@ -684,10 +457,6 @@
           <a:bodyPr/>
           <a:lstStyle/>
           <a:p>
-            <a:r>
-              <a:rPr lang="en-US" dirty="0"/>
-              <a:t/>
-            </a:r>
             <a:endParaRPr lang="en-US" dirty="0"/>
           </a:p>
         </p:txBody>
@@ -772,10 +541,6 @@
           <a:bodyPr/>
           <a:lstStyle/>
           <a:p>
-            <a:r>
-              <a:rPr lang="en-US" dirty="0"/>
-              <a:t/>
-            </a:r>
             <a:endParaRPr lang="en-US" dirty="0"/>
           </a:p>
         </p:txBody>
@@ -860,10 +625,6 @@
           <a:bodyPr/>
           <a:lstStyle/>
           <a:p>
-            <a:r>
-              <a:rPr lang="en-US" dirty="0"/>
-              <a:t/>
-            </a:r>
             <a:endParaRPr lang="en-US" dirty="0"/>
           </a:p>
         </p:txBody>
@@ -948,10 +709,6 @@
           <a:bodyPr/>
           <a:lstStyle/>
           <a:p>
-            <a:r>
-              <a:rPr lang="en-US" dirty="0"/>
-              <a:t/>
-            </a:r>
             <a:endParaRPr lang="en-US" dirty="0"/>
           </a:p>
         </p:txBody>
@@ -1036,10 +793,6 @@
           <a:bodyPr/>
           <a:lstStyle/>
           <a:p>
-            <a:r>
-              <a:rPr lang="en-US" dirty="0"/>
-              <a:t/>
-            </a:r>
             <a:endParaRPr lang="en-US" dirty="0"/>
           </a:p>
         </p:txBody>
@@ -1124,10 +877,6 @@
           <a:bodyPr/>
           <a:lstStyle/>
           <a:p>
-            <a:r>
-              <a:rPr lang="en-US" dirty="0"/>
-              <a:t/>
-            </a:r>
             <a:endParaRPr lang="en-US" dirty="0"/>
           </a:p>
         </p:txBody>
@@ -1212,10 +961,6 @@
           <a:bodyPr/>
           <a:lstStyle/>
           <a:p>
-            <a:r>
-              <a:rPr lang="en-US" dirty="0"/>
-              <a:t/>
-            </a:r>
             <a:endParaRPr lang="en-US" dirty="0"/>
           </a:p>
         </p:txBody>
@@ -1289,6 +1034,11 @@
 <file path=ppt/slideMasters/slideMaster1.xml><?xml version="1.0" encoding="utf-8"?>
 <p:sldMaster xmlns:a="http://schemas.openxmlformats.org/drawingml/2006/main" xmlns:r="http://schemas.openxmlformats.org/officeDocument/2006/relationships" xmlns:p="http://schemas.openxmlformats.org/presentationml/2006/main">
   <p:cSld>
+    <p:bg>
+      <p:bgRef idx="1001">
+        <a:schemeClr val="bg1"/>
+      </p:bgRef>
+    </p:bg>
     <p:spTree>
       <p:nvGrpSpPr>
         <p:cNvPr id="1" name=""/>
@@ -1571,6 +1321,7 @@
         <a:solidFill>
           <a:srgbClr val="0F2318"/>
         </a:solidFill>
+        <a:effectLst/>
       </p:bgPr>
     </p:bg>
     <p:spTree>
@@ -1606,6 +1357,13 @@
           </a:solidFill>
           <a:ln/>
         </p:spPr>
+        <p:txBody>
+          <a:bodyPr/>
+          <a:lstStyle/>
+          <a:p>
+            <a:endParaRPr lang="es-CL"/>
+          </a:p>
+        </p:txBody>
       </p:sp>
       <p:sp>
         <p:nvSpPr>
@@ -1628,7 +1386,7 @@
           <a:bodyPr wrap="square" rtlCol="0" anchor="ctr"/>
           <a:lstStyle/>
           <a:p>
-            <a:pPr algn="ctr" indent="0" marL="0">
+            <a:pPr marL="0" indent="0" algn="ctr">
               <a:buNone/>
             </a:pPr>
             <a:r>
@@ -1664,7 +1422,7 @@
           <a:bodyPr wrap="square" rtlCol="0" anchor="ctr"/>
           <a:lstStyle/>
           <a:p>
-            <a:pPr algn="ctr" indent="0" marL="0">
+            <a:pPr marL="0" indent="0" algn="ctr">
               <a:buNone/>
             </a:pPr>
             <a:r>
@@ -1700,7 +1458,7 @@
           <a:bodyPr wrap="square" rtlCol="0" anchor="ctr"/>
           <a:lstStyle/>
           <a:p>
-            <a:pPr algn="ctr" indent="0" marL="0">
+            <a:pPr marL="0" indent="0" algn="ctr">
               <a:buNone/>
             </a:pPr>
             <a:r>
@@ -1736,7 +1494,7 @@
           <a:bodyPr wrap="square" rtlCol="0" anchor="ctr"/>
           <a:lstStyle/>
           <a:p>
-            <a:pPr algn="ctr" indent="0" marL="0">
+            <a:pPr marL="0" indent="0" algn="ctr">
               <a:buNone/>
             </a:pPr>
             <a:r>
@@ -1772,11 +1530,11 @@
           <a:bodyPr wrap="square" lIns="0" tIns="0" rIns="0" bIns="0" rtlCol="0" anchor="ctr"/>
           <a:lstStyle/>
           <a:p>
-            <a:pPr algn="ctr" indent="0" marL="0">
-              <a:buNone/>
-            </a:pPr>
-            <a:r>
-              <a:rPr lang="en-US" sz="5800" b="1" spc="300" kern="0" dirty="0">
+            <a:pPr marL="0" indent="0" algn="ctr">
+              <a:buNone/>
+            </a:pPr>
+            <a:r>
+              <a:rPr lang="en-US" sz="5800" b="1" kern="0" spc="300" dirty="0">
                 <a:solidFill>
                   <a:srgbClr val="FFFFFF"/>
                 </a:solidFill>
@@ -1811,7 +1569,7 @@
           <a:bodyPr wrap="square" lIns="0" tIns="0" rIns="0" bIns="0" rtlCol="0" anchor="ctr"/>
           <a:lstStyle/>
           <a:p>
-            <a:pPr algn="ctr" indent="0" marL="0">
+            <a:pPr marL="0" indent="0" algn="ctr">
               <a:buNone/>
             </a:pPr>
             <a:r>
@@ -1848,6 +1606,13 @@
           </a:solidFill>
           <a:ln/>
         </p:spPr>
+        <p:txBody>
+          <a:bodyPr/>
+          <a:lstStyle/>
+          <a:p>
+            <a:endParaRPr lang="es-CL"/>
+          </a:p>
+        </p:txBody>
       </p:sp>
       <p:sp>
         <p:nvSpPr>
@@ -1873,6 +1638,13 @@
             <a:prstDash val="solid"/>
           </a:ln>
         </p:spPr>
+        <p:txBody>
+          <a:bodyPr/>
+          <a:lstStyle/>
+          <a:p>
+            <a:endParaRPr lang="es-CL"/>
+          </a:p>
+        </p:txBody>
       </p:sp>
       <p:sp>
         <p:nvSpPr>
@@ -1895,7 +1667,7 @@
           <a:bodyPr wrap="square" lIns="152400" tIns="152400" rIns="152400" bIns="152400" rtlCol="0" anchor="ctr"/>
           <a:lstStyle/>
           <a:p>
-            <a:pPr algn="ctr" indent="0" marL="0">
+            <a:pPr marL="0" indent="0" algn="ctr">
               <a:buNone/>
             </a:pPr>
             <a:r>
@@ -1912,7 +1684,7 @@
             <a:endParaRPr lang="en-US" sz="1300" dirty="0"/>
           </a:p>
           <a:p>
-            <a:pPr algn="ctr" indent="0" marL="0">
+            <a:pPr marL="0" indent="0" algn="ctr">
               <a:buNone/>
             </a:pPr>
             <a:r>
@@ -1951,11 +1723,11 @@
           <a:bodyPr wrap="square" lIns="0" tIns="0" rIns="0" bIns="0" rtlCol="0" anchor="ctr"/>
           <a:lstStyle/>
           <a:p>
-            <a:pPr algn="ctr" indent="0" marL="0">
-              <a:buNone/>
-            </a:pPr>
-            <a:r>
-              <a:rPr lang="en-US" sz="1000" b="1" spc="400" kern="0" dirty="0">
+            <a:pPr marL="0" indent="0" algn="ctr">
+              <a:buNone/>
+            </a:pPr>
+            <a:r>
+              <a:rPr lang="en-US" sz="1000" b="1" kern="0" spc="400" dirty="0">
                 <a:solidFill>
                   <a:srgbClr val="4CAF50"/>
                 </a:solidFill>
@@ -1990,7 +1762,7 @@
           <a:bodyPr wrap="square" lIns="0" tIns="0" rIns="0" bIns="0" rtlCol="0" anchor="ctr"/>
           <a:lstStyle/>
           <a:p>
-            <a:pPr algn="ctr" indent="0" marL="0">
+            <a:pPr marL="0" indent="0" algn="ctr">
               <a:buNone/>
             </a:pPr>
             <a:r>
@@ -2002,7 +1774,7 @@
                 <a:ea typeface="Calibri" pitchFamily="34" charset="-122"/>
                 <a:cs typeface="Calibri" pitchFamily="34" charset="-120"/>
               </a:rPr>
-              <a:t>Claudio Vicente Aro Kath   ·   [Integrante 2]   ·   [Integrante 3]</a:t>
+              <a:t>Claudio Vicente Aro Kath</a:t>
             </a:r>
             <a:endParaRPr lang="en-US" sz="1400" dirty="0"/>
           </a:p>
@@ -2029,7 +1801,7 @@
           <a:bodyPr wrap="square" lIns="0" tIns="0" rIns="0" bIns="0" rtlCol="0" anchor="ctr"/>
           <a:lstStyle/>
           <a:p>
-            <a:pPr algn="ctr" indent="0" marL="0">
+            <a:pPr marL="0" indent="0" algn="ctr">
               <a:buNone/>
             </a:pPr>
             <a:r>
@@ -2041,7 +1813,18 @@
                 <a:ea typeface="Calibri" pitchFamily="34" charset="-122"/>
                 <a:cs typeface="Calibri" pitchFamily="34" charset="-120"/>
               </a:rPr>
-              <a:t>Docente: [Nombre del Docente]</a:t>
+              <a:t>Docente: José Ignacio Campos </a:t>
+            </a:r>
+            <a:r>
+              <a:rPr lang="en-US" sz="1100" i="1" dirty="0" err="1">
+                <a:solidFill>
+                  <a:srgbClr val="718096"/>
+                </a:solidFill>
+                <a:latin typeface="Calibri" pitchFamily="34" charset="0"/>
+                <a:ea typeface="Calibri" pitchFamily="34" charset="-122"/>
+                <a:cs typeface="Calibri" pitchFamily="34" charset="-120"/>
+              </a:rPr>
+              <a:t>Árevalo</a:t>
             </a:r>
             <a:endParaRPr lang="en-US" sz="1100" dirty="0"/>
           </a:p>
@@ -2066,6 +1849,13 @@
           </a:solidFill>
           <a:ln/>
         </p:spPr>
+        <p:txBody>
+          <a:bodyPr/>
+          <a:lstStyle/>
+          <a:p>
+            <a:endParaRPr lang="es-CL"/>
+          </a:p>
+        </p:txBody>
       </p:sp>
     </p:spTree>
   </p:cSld>
@@ -2083,6 +1873,7 @@
         <a:solidFill>
           <a:srgbClr val="F8FBF8"/>
         </a:solidFill>
+        <a:effectLst/>
       </p:bgPr>
     </p:bg>
     <p:spTree>
@@ -2120,7 +1911,7 @@
           <a:bodyPr wrap="square" lIns="0" tIns="0" rIns="0" bIns="0" rtlCol="0" anchor="ctr"/>
           <a:lstStyle/>
           <a:p>
-            <a:pPr algn="l" indent="0" marL="0">
+            <a:pPr marL="0" indent="0" algn="l">
               <a:buNone/>
             </a:pPr>
             <a:r>
@@ -2157,6 +1948,13 @@
           </a:solidFill>
           <a:ln/>
         </p:spPr>
+        <p:txBody>
+          <a:bodyPr/>
+          <a:lstStyle/>
+          <a:p>
+            <a:endParaRPr lang="es-CL"/>
+          </a:p>
+        </p:txBody>
       </p:sp>
       <p:sp>
         <p:nvSpPr>
@@ -2182,13 +1980,20 @@
             <a:prstDash val="solid"/>
           </a:ln>
           <a:effectLst>
-            <a:outerShdw sx="100000" sy="100000" kx="0" ky="0" algn="bl" rotWithShape="0" blurRad="101600" dist="38100" dir="8100000">
+            <a:outerShdw blurRad="101600" dist="38100" dir="8100000" algn="bl" rotWithShape="0">
               <a:srgbClr val="000000">
                 <a:alpha val="12000"/>
               </a:srgbClr>
             </a:outerShdw>
           </a:effectLst>
         </p:spPr>
+        <p:txBody>
+          <a:bodyPr/>
+          <a:lstStyle/>
+          <a:p>
+            <a:endParaRPr lang="es-CL"/>
+          </a:p>
+        </p:txBody>
       </p:sp>
       <p:sp>
         <p:nvSpPr>
@@ -2211,7 +2016,7 @@
           <a:bodyPr wrap="square" lIns="0" tIns="0" rIns="0" bIns="0" rtlCol="0" anchor="ctr"/>
           <a:lstStyle/>
           <a:p>
-            <a:pPr algn="ctr" indent="0" marL="0">
+            <a:pPr marL="0" indent="0" algn="ctr">
               <a:buNone/>
             </a:pPr>
             <a:r>
@@ -2250,7 +2055,7 @@
           <a:bodyPr wrap="square" lIns="50800" tIns="50800" rIns="50800" bIns="50800" rtlCol="0" anchor="ctr"/>
           <a:lstStyle/>
           <a:p>
-            <a:pPr algn="ctr" indent="0" marL="0">
+            <a:pPr marL="0" indent="0" algn="ctr">
               <a:buNone/>
             </a:pPr>
             <a:r>
@@ -2289,7 +2094,7 @@
           <a:bodyPr wrap="square" lIns="0" tIns="0" rIns="0" bIns="0" rtlCol="0" anchor="ctr"/>
           <a:lstStyle/>
           <a:p>
-            <a:pPr algn="ctr" indent="0" marL="0">
+            <a:pPr marL="0" indent="0" algn="ctr">
               <a:buNone/>
             </a:pPr>
             <a:r>
@@ -2331,13 +2136,20 @@
             <a:prstDash val="solid"/>
           </a:ln>
           <a:effectLst>
-            <a:outerShdw sx="100000" sy="100000" kx="0" ky="0" algn="bl" rotWithShape="0" blurRad="101600" dist="38100" dir="8100000">
+            <a:outerShdw blurRad="101600" dist="38100" dir="8100000" algn="bl" rotWithShape="0">
               <a:srgbClr val="000000">
                 <a:alpha val="12000"/>
               </a:srgbClr>
             </a:outerShdw>
           </a:effectLst>
         </p:spPr>
+        <p:txBody>
+          <a:bodyPr/>
+          <a:lstStyle/>
+          <a:p>
+            <a:endParaRPr lang="es-CL"/>
+          </a:p>
+        </p:txBody>
       </p:sp>
       <p:sp>
         <p:nvSpPr>
@@ -2360,7 +2172,7 @@
           <a:bodyPr wrap="square" lIns="0" tIns="0" rIns="0" bIns="0" rtlCol="0" anchor="ctr"/>
           <a:lstStyle/>
           <a:p>
-            <a:pPr algn="ctr" indent="0" marL="0">
+            <a:pPr marL="0" indent="0" algn="ctr">
               <a:buNone/>
             </a:pPr>
             <a:r>
@@ -2396,7 +2208,7 @@
           <a:bodyPr wrap="square" lIns="0" tIns="0" rIns="0" bIns="0" rtlCol="0" anchor="ctr"/>
           <a:lstStyle/>
           <a:p>
-            <a:pPr indent="0" marL="0">
+            <a:pPr marL="0" indent="0">
               <a:buNone/>
             </a:pPr>
             <a:r>
@@ -2435,7 +2247,7 @@
           <a:bodyPr wrap="square" lIns="0" tIns="0" rIns="0" bIns="0" rtlCol="0" anchor="ctr"/>
           <a:lstStyle/>
           <a:p>
-            <a:pPr indent="0" marL="0">
+            <a:pPr marL="0" indent="0">
               <a:buNone/>
             </a:pPr>
             <a:r>
@@ -2477,13 +2289,20 @@
             <a:prstDash val="solid"/>
           </a:ln>
           <a:effectLst>
-            <a:outerShdw sx="100000" sy="100000" kx="0" ky="0" algn="bl" rotWithShape="0" blurRad="101600" dist="38100" dir="8100000">
+            <a:outerShdw blurRad="101600" dist="38100" dir="8100000" algn="bl" rotWithShape="0">
               <a:srgbClr val="000000">
                 <a:alpha val="12000"/>
               </a:srgbClr>
             </a:outerShdw>
           </a:effectLst>
         </p:spPr>
+        <p:txBody>
+          <a:bodyPr/>
+          <a:lstStyle/>
+          <a:p>
+            <a:endParaRPr lang="es-CL"/>
+          </a:p>
+        </p:txBody>
       </p:sp>
       <p:sp>
         <p:nvSpPr>
@@ -2506,7 +2325,7 @@
           <a:bodyPr wrap="square" lIns="0" tIns="0" rIns="0" bIns="0" rtlCol="0" anchor="ctr"/>
           <a:lstStyle/>
           <a:p>
-            <a:pPr algn="ctr" indent="0" marL="0">
+            <a:pPr marL="0" indent="0" algn="ctr">
               <a:buNone/>
             </a:pPr>
             <a:r>
@@ -2542,7 +2361,7 @@
           <a:bodyPr wrap="square" lIns="0" tIns="0" rIns="0" bIns="0" rtlCol="0" anchor="ctr"/>
           <a:lstStyle/>
           <a:p>
-            <a:pPr indent="0" marL="0">
+            <a:pPr marL="0" indent="0">
               <a:buNone/>
             </a:pPr>
             <a:r>
@@ -2581,7 +2400,7 @@
           <a:bodyPr wrap="square" lIns="0" tIns="0" rIns="0" bIns="0" rtlCol="0" anchor="ctr"/>
           <a:lstStyle/>
           <a:p>
-            <a:pPr indent="0" marL="0">
+            <a:pPr marL="0" indent="0">
               <a:buNone/>
             </a:pPr>
             <a:r>
@@ -2623,13 +2442,20 @@
             <a:prstDash val="solid"/>
           </a:ln>
           <a:effectLst>
-            <a:outerShdw sx="100000" sy="100000" kx="0" ky="0" algn="bl" rotWithShape="0" blurRad="101600" dist="38100" dir="8100000">
+            <a:outerShdw blurRad="101600" dist="38100" dir="8100000" algn="bl" rotWithShape="0">
               <a:srgbClr val="000000">
                 <a:alpha val="12000"/>
               </a:srgbClr>
             </a:outerShdw>
           </a:effectLst>
         </p:spPr>
+        <p:txBody>
+          <a:bodyPr/>
+          <a:lstStyle/>
+          <a:p>
+            <a:endParaRPr lang="es-CL"/>
+          </a:p>
+        </p:txBody>
       </p:sp>
       <p:sp>
         <p:nvSpPr>
@@ -2652,7 +2478,7 @@
           <a:bodyPr wrap="square" lIns="0" tIns="0" rIns="0" bIns="0" rtlCol="0" anchor="ctr"/>
           <a:lstStyle/>
           <a:p>
-            <a:pPr algn="ctr" indent="0" marL="0">
+            <a:pPr marL="0" indent="0" algn="ctr">
               <a:buNone/>
             </a:pPr>
             <a:r>
@@ -2688,7 +2514,7 @@
           <a:bodyPr wrap="square" lIns="0" tIns="0" rIns="0" bIns="0" rtlCol="0" anchor="ctr"/>
           <a:lstStyle/>
           <a:p>
-            <a:pPr indent="0" marL="0">
+            <a:pPr marL="0" indent="0">
               <a:buNone/>
             </a:pPr>
             <a:r>
@@ -2727,7 +2553,7 @@
           <a:bodyPr wrap="square" lIns="0" tIns="0" rIns="0" bIns="0" rtlCol="0" anchor="ctr"/>
           <a:lstStyle/>
           <a:p>
-            <a:pPr indent="0" marL="0">
+            <a:pPr marL="0" indent="0">
               <a:buNone/>
             </a:pPr>
             <a:r>
@@ -2766,7 +2592,7 @@
           <a:bodyPr wrap="square" lIns="0" tIns="0" rIns="0" bIns="0" rtlCol="0" anchor="ctr"/>
           <a:lstStyle/>
           <a:p>
-            <a:pPr algn="ctr" indent="0" marL="0">
+            <a:pPr marL="0" indent="0" algn="ctr">
               <a:buNone/>
             </a:pPr>
             <a:r>
@@ -2800,6 +2626,7 @@
         <a:solidFill>
           <a:srgbClr val="F8FBF8"/>
         </a:solidFill>
+        <a:effectLst/>
       </p:bgPr>
     </p:bg>
     <p:spTree>
@@ -2837,7 +2664,7 @@
           <a:bodyPr wrap="square" lIns="0" tIns="0" rIns="0" bIns="0" rtlCol="0" anchor="ctr"/>
           <a:lstStyle/>
           <a:p>
-            <a:pPr algn="l" indent="0" marL="0">
+            <a:pPr marL="0" indent="0" algn="l">
               <a:buNone/>
             </a:pPr>
             <a:r>
@@ -2874,6 +2701,13 @@
           </a:solidFill>
           <a:ln/>
         </p:spPr>
+        <p:txBody>
+          <a:bodyPr/>
+          <a:lstStyle/>
+          <a:p>
+            <a:endParaRPr lang="es-CL"/>
+          </a:p>
+        </p:txBody>
       </p:sp>
       <p:sp>
         <p:nvSpPr>
@@ -2899,13 +2733,20 @@
             <a:prstDash val="solid"/>
           </a:ln>
           <a:effectLst>
-            <a:outerShdw sx="100000" sy="100000" kx="0" ky="0" algn="bl" rotWithShape="0" blurRad="101600" dist="38100" dir="8100000">
+            <a:outerShdw blurRad="101600" dist="38100" dir="8100000" algn="bl" rotWithShape="0">
               <a:srgbClr val="000000">
                 <a:alpha val="12000"/>
               </a:srgbClr>
             </a:outerShdw>
           </a:effectLst>
         </p:spPr>
+        <p:txBody>
+          <a:bodyPr/>
+          <a:lstStyle/>
+          <a:p>
+            <a:endParaRPr lang="es-CL"/>
+          </a:p>
+        </p:txBody>
       </p:sp>
       <p:sp>
         <p:nvSpPr>
@@ -2928,7 +2769,7 @@
           <a:bodyPr wrap="square" lIns="0" tIns="0" rIns="0" bIns="0" rtlCol="0" anchor="ctr"/>
           <a:lstStyle/>
           <a:p>
-            <a:pPr algn="ctr" indent="0" marL="0">
+            <a:pPr marL="0" indent="0" algn="ctr">
               <a:buNone/>
             </a:pPr>
             <a:r>
@@ -2964,7 +2805,7 @@
           <a:bodyPr wrap="square" lIns="0" tIns="0" rIns="0" bIns="0" rtlCol="0" anchor="ctr"/>
           <a:lstStyle/>
           <a:p>
-            <a:pPr algn="ctr" indent="0" marL="0">
+            <a:pPr marL="0" indent="0" algn="ctr">
               <a:buNone/>
             </a:pPr>
             <a:r>
@@ -3003,7 +2844,7 @@
           <a:bodyPr wrap="square" lIns="50800" tIns="50800" rIns="50800" bIns="50800" rtlCol="0" anchor="ctr"/>
           <a:lstStyle/>
           <a:p>
-            <a:pPr algn="ctr" indent="0" marL="0">
+            <a:pPr marL="0" indent="0" algn="ctr">
               <a:buNone/>
             </a:pPr>
             <a:r>
@@ -3020,7 +2861,7 @@
             <a:endParaRPr lang="en-US" sz="1200" dirty="0"/>
           </a:p>
           <a:p>
-            <a:pPr algn="ctr" indent="0" marL="0">
+            <a:pPr marL="0" indent="0" algn="ctr">
               <a:buNone/>
             </a:pPr>
             <a:r>
@@ -3059,7 +2900,7 @@
           <a:bodyPr wrap="square" lIns="0" tIns="0" rIns="0" bIns="0" rtlCol="0" anchor="ctr"/>
           <a:lstStyle/>
           <a:p>
-            <a:pPr algn="ctr" indent="0" marL="0">
+            <a:pPr marL="0" indent="0" algn="ctr">
               <a:buNone/>
             </a:pPr>
             <a:r>
@@ -3101,13 +2942,20 @@
             <a:prstDash val="solid"/>
           </a:ln>
           <a:effectLst>
-            <a:outerShdw sx="100000" sy="100000" kx="0" ky="0" algn="bl" rotWithShape="0" blurRad="101600" dist="38100" dir="8100000">
+            <a:outerShdw blurRad="101600" dist="38100" dir="8100000" algn="bl" rotWithShape="0">
               <a:srgbClr val="000000">
                 <a:alpha val="12000"/>
               </a:srgbClr>
             </a:outerShdw>
           </a:effectLst>
         </p:spPr>
+        <p:txBody>
+          <a:bodyPr/>
+          <a:lstStyle/>
+          <a:p>
+            <a:endParaRPr lang="es-CL"/>
+          </a:p>
+        </p:txBody>
       </p:sp>
       <p:sp>
         <p:nvSpPr>
@@ -3130,7 +2978,7 @@
           <a:bodyPr wrap="square" lIns="0" tIns="0" rIns="0" bIns="0" rtlCol="0" anchor="ctr"/>
           <a:lstStyle/>
           <a:p>
-            <a:pPr algn="ctr" indent="0" marL="0">
+            <a:pPr marL="0" indent="0" algn="ctr">
               <a:buNone/>
             </a:pPr>
             <a:r>
@@ -3166,7 +3014,7 @@
           <a:bodyPr wrap="square" lIns="0" tIns="0" rIns="0" bIns="0" rtlCol="0" anchor="ctr"/>
           <a:lstStyle/>
           <a:p>
-            <a:pPr algn="ctr" indent="0" marL="0">
+            <a:pPr marL="0" indent="0" algn="ctr">
               <a:buNone/>
             </a:pPr>
             <a:r>
@@ -3205,7 +3053,7 @@
           <a:bodyPr wrap="square" lIns="50800" tIns="50800" rIns="50800" bIns="50800" rtlCol="0" anchor="ctr"/>
           <a:lstStyle/>
           <a:p>
-            <a:pPr algn="ctr" indent="0" marL="0">
+            <a:pPr marL="0" indent="0" algn="ctr">
               <a:buNone/>
             </a:pPr>
             <a:r>
@@ -3222,7 +3070,7 @@
             <a:endParaRPr lang="en-US" sz="1200" dirty="0"/>
           </a:p>
           <a:p>
-            <a:pPr algn="ctr" indent="0" marL="0">
+            <a:pPr marL="0" indent="0" algn="ctr">
               <a:buNone/>
             </a:pPr>
             <a:r>
@@ -3261,7 +3109,7 @@
           <a:bodyPr wrap="square" lIns="0" tIns="0" rIns="0" bIns="0" rtlCol="0" anchor="ctr"/>
           <a:lstStyle/>
           <a:p>
-            <a:pPr algn="ctr" indent="0" marL="0">
+            <a:pPr marL="0" indent="0" algn="ctr">
               <a:buNone/>
             </a:pPr>
             <a:r>
@@ -3303,13 +3151,20 @@
             <a:prstDash val="solid"/>
           </a:ln>
           <a:effectLst>
-            <a:outerShdw sx="100000" sy="100000" kx="0" ky="0" algn="bl" rotWithShape="0" blurRad="101600" dist="38100" dir="8100000">
+            <a:outerShdw blurRad="101600" dist="38100" dir="8100000" algn="bl" rotWithShape="0">
               <a:srgbClr val="000000">
                 <a:alpha val="12000"/>
               </a:srgbClr>
             </a:outerShdw>
           </a:effectLst>
         </p:spPr>
+        <p:txBody>
+          <a:bodyPr/>
+          <a:lstStyle/>
+          <a:p>
+            <a:endParaRPr lang="es-CL"/>
+          </a:p>
+        </p:txBody>
       </p:sp>
       <p:sp>
         <p:nvSpPr>
@@ -3332,7 +3187,7 @@
           <a:bodyPr wrap="square" lIns="0" tIns="0" rIns="0" bIns="0" rtlCol="0" anchor="ctr"/>
           <a:lstStyle/>
           <a:p>
-            <a:pPr algn="ctr" indent="0" marL="0">
+            <a:pPr marL="0" indent="0" algn="ctr">
               <a:buNone/>
             </a:pPr>
             <a:r>
@@ -3368,7 +3223,7 @@
           <a:bodyPr wrap="square" lIns="0" tIns="0" rIns="0" bIns="0" rtlCol="0" anchor="ctr"/>
           <a:lstStyle/>
           <a:p>
-            <a:pPr algn="ctr" indent="0" marL="0">
+            <a:pPr marL="0" indent="0" algn="ctr">
               <a:buNone/>
             </a:pPr>
             <a:r>
@@ -3407,7 +3262,7 @@
           <a:bodyPr wrap="square" lIns="50800" tIns="50800" rIns="50800" bIns="50800" rtlCol="0" anchor="ctr"/>
           <a:lstStyle/>
           <a:p>
-            <a:pPr algn="ctr" indent="0" marL="0">
+            <a:pPr marL="0" indent="0" algn="ctr">
               <a:buNone/>
             </a:pPr>
             <a:r>
@@ -3424,7 +3279,7 @@
             <a:endParaRPr lang="en-US" sz="1200" dirty="0"/>
           </a:p>
           <a:p>
-            <a:pPr algn="ctr" indent="0" marL="0">
+            <a:pPr marL="0" indent="0" algn="ctr">
               <a:buNone/>
             </a:pPr>
             <a:r>
@@ -3463,7 +3318,7 @@
           <a:bodyPr wrap="square" lIns="0" tIns="0" rIns="0" bIns="0" rtlCol="0" anchor="ctr"/>
           <a:lstStyle/>
           <a:p>
-            <a:pPr indent="0" marL="0">
+            <a:pPr marL="0" indent="0">
               <a:buNone/>
             </a:pPr>
             <a:r>
@@ -3505,13 +3360,20 @@
             <a:prstDash val="solid"/>
           </a:ln>
           <a:effectLst>
-            <a:outerShdw sx="100000" sy="100000" kx="0" ky="0" algn="bl" rotWithShape="0" blurRad="101600" dist="38100" dir="8100000">
+            <a:outerShdw blurRad="101600" dist="38100" dir="8100000" algn="bl" rotWithShape="0">
               <a:srgbClr val="000000">
                 <a:alpha val="12000"/>
               </a:srgbClr>
             </a:outerShdw>
           </a:effectLst>
         </p:spPr>
+        <p:txBody>
+          <a:bodyPr/>
+          <a:lstStyle/>
+          <a:p>
+            <a:endParaRPr lang="es-CL"/>
+          </a:p>
+        </p:txBody>
       </p:sp>
       <p:sp>
         <p:nvSpPr>
@@ -3534,7 +3396,7 @@
           <a:bodyPr wrap="square" lIns="0" tIns="0" rIns="0" bIns="0" rtlCol="0" anchor="ctr"/>
           <a:lstStyle/>
           <a:p>
-            <a:pPr algn="ctr" indent="0" marL="0">
+            <a:pPr marL="0" indent="0" algn="ctr">
               <a:buNone/>
             </a:pPr>
             <a:r>
@@ -3570,7 +3432,7 @@
           <a:bodyPr wrap="square" lIns="0" tIns="0" rIns="0" bIns="0" rtlCol="0" anchor="ctr"/>
           <a:lstStyle/>
           <a:p>
-            <a:pPr algn="ctr" indent="0" marL="0">
+            <a:pPr marL="0" indent="0" algn="ctr">
               <a:buNone/>
             </a:pPr>
             <a:r>
@@ -3612,13 +3474,20 @@
             <a:prstDash val="solid"/>
           </a:ln>
           <a:effectLst>
-            <a:outerShdw sx="100000" sy="100000" kx="0" ky="0" algn="bl" rotWithShape="0" blurRad="101600" dist="38100" dir="8100000">
+            <a:outerShdw blurRad="101600" dist="38100" dir="8100000" algn="bl" rotWithShape="0">
               <a:srgbClr val="000000">
                 <a:alpha val="12000"/>
               </a:srgbClr>
             </a:outerShdw>
           </a:effectLst>
         </p:spPr>
+        <p:txBody>
+          <a:bodyPr/>
+          <a:lstStyle/>
+          <a:p>
+            <a:endParaRPr lang="es-CL"/>
+          </a:p>
+        </p:txBody>
       </p:sp>
       <p:sp>
         <p:nvSpPr>
@@ -3641,7 +3510,7 @@
           <a:bodyPr wrap="square" lIns="0" tIns="0" rIns="0" bIns="0" rtlCol="0" anchor="ctr"/>
           <a:lstStyle/>
           <a:p>
-            <a:pPr algn="ctr" indent="0" marL="0">
+            <a:pPr marL="0" indent="0" algn="ctr">
               <a:buNone/>
             </a:pPr>
             <a:r>
@@ -3677,7 +3546,7 @@
           <a:bodyPr wrap="square" lIns="0" tIns="0" rIns="0" bIns="0" rtlCol="0" anchor="ctr"/>
           <a:lstStyle/>
           <a:p>
-            <a:pPr algn="ctr" indent="0" marL="0">
+            <a:pPr marL="0" indent="0" algn="ctr">
               <a:buNone/>
             </a:pPr>
             <a:r>
@@ -3719,13 +3588,20 @@
             <a:prstDash val="solid"/>
           </a:ln>
           <a:effectLst>
-            <a:outerShdw sx="100000" sy="100000" kx="0" ky="0" algn="bl" rotWithShape="0" blurRad="101600" dist="38100" dir="8100000">
+            <a:outerShdw blurRad="101600" dist="38100" dir="8100000" algn="bl" rotWithShape="0">
               <a:srgbClr val="000000">
                 <a:alpha val="12000"/>
               </a:srgbClr>
             </a:outerShdw>
           </a:effectLst>
         </p:spPr>
+        <p:txBody>
+          <a:bodyPr/>
+          <a:lstStyle/>
+          <a:p>
+            <a:endParaRPr lang="es-CL"/>
+          </a:p>
+        </p:txBody>
       </p:sp>
       <p:sp>
         <p:nvSpPr>
@@ -3748,7 +3624,7 @@
           <a:bodyPr wrap="square" lIns="0" tIns="0" rIns="0" bIns="0" rtlCol="0" anchor="ctr"/>
           <a:lstStyle/>
           <a:p>
-            <a:pPr algn="ctr" indent="0" marL="0">
+            <a:pPr marL="0" indent="0" algn="ctr">
               <a:buNone/>
             </a:pPr>
             <a:r>
@@ -3784,7 +3660,7 @@
           <a:bodyPr wrap="square" lIns="0" tIns="0" rIns="0" bIns="0" rtlCol="0" anchor="ctr"/>
           <a:lstStyle/>
           <a:p>
-            <a:pPr algn="ctr" indent="0" marL="0">
+            <a:pPr marL="0" indent="0" algn="ctr">
               <a:buNone/>
             </a:pPr>
             <a:r>
@@ -3826,13 +3702,20 @@
             <a:prstDash val="solid"/>
           </a:ln>
           <a:effectLst>
-            <a:outerShdw sx="100000" sy="100000" kx="0" ky="0" algn="bl" rotWithShape="0" blurRad="101600" dist="38100" dir="8100000">
+            <a:outerShdw blurRad="101600" dist="38100" dir="8100000" algn="bl" rotWithShape="0">
               <a:srgbClr val="000000">
                 <a:alpha val="12000"/>
               </a:srgbClr>
             </a:outerShdw>
           </a:effectLst>
         </p:spPr>
+        <p:txBody>
+          <a:bodyPr/>
+          <a:lstStyle/>
+          <a:p>
+            <a:endParaRPr lang="es-CL"/>
+          </a:p>
+        </p:txBody>
       </p:sp>
       <p:sp>
         <p:nvSpPr>
@@ -3855,7 +3738,7 @@
           <a:bodyPr wrap="square" lIns="0" tIns="0" rIns="0" bIns="0" rtlCol="0" anchor="ctr"/>
           <a:lstStyle/>
           <a:p>
-            <a:pPr algn="ctr" indent="0" marL="0">
+            <a:pPr marL="0" indent="0" algn="ctr">
               <a:buNone/>
             </a:pPr>
             <a:r>
@@ -3891,7 +3774,7 @@
           <a:bodyPr wrap="square" lIns="0" tIns="0" rIns="0" bIns="0" rtlCol="0" anchor="ctr"/>
           <a:lstStyle/>
           <a:p>
-            <a:pPr algn="ctr" indent="0" marL="0">
+            <a:pPr marL="0" indent="0" algn="ctr">
               <a:buNone/>
             </a:pPr>
             <a:r>
@@ -3925,6 +3808,7 @@
         <a:solidFill>
           <a:srgbClr val="F8FBF8"/>
         </a:solidFill>
+        <a:effectLst/>
       </p:bgPr>
     </p:bg>
     <p:spTree>
@@ -3962,7 +3846,7 @@
           <a:bodyPr wrap="square" lIns="0" tIns="0" rIns="0" bIns="0" rtlCol="0" anchor="ctr"/>
           <a:lstStyle/>
           <a:p>
-            <a:pPr algn="l" indent="0" marL="0">
+            <a:pPr marL="0" indent="0" algn="l">
               <a:buNone/>
             </a:pPr>
             <a:r>
@@ -3999,6 +3883,13 @@
           </a:solidFill>
           <a:ln/>
         </p:spPr>
+        <p:txBody>
+          <a:bodyPr/>
+          <a:lstStyle/>
+          <a:p>
+            <a:endParaRPr lang="es-CL"/>
+          </a:p>
+        </p:txBody>
       </p:sp>
       <p:sp>
         <p:nvSpPr>
@@ -4024,13 +3915,20 @@
             <a:prstDash val="solid"/>
           </a:ln>
           <a:effectLst>
-            <a:outerShdw sx="100000" sy="100000" kx="0" ky="0" algn="bl" rotWithShape="0" blurRad="101600" dist="38100" dir="8100000">
+            <a:outerShdw blurRad="101600" dist="38100" dir="8100000" algn="bl" rotWithShape="0">
               <a:srgbClr val="000000">
                 <a:alpha val="12000"/>
               </a:srgbClr>
             </a:outerShdw>
           </a:effectLst>
         </p:spPr>
+        <p:txBody>
+          <a:bodyPr/>
+          <a:lstStyle/>
+          <a:p>
+            <a:endParaRPr lang="es-CL"/>
+          </a:p>
+        </p:txBody>
       </p:sp>
       <p:sp>
         <p:nvSpPr>
@@ -4051,6 +3949,13 @@
           </a:solidFill>
           <a:ln/>
         </p:spPr>
+        <p:txBody>
+          <a:bodyPr/>
+          <a:lstStyle/>
+          <a:p>
+            <a:endParaRPr lang="es-CL"/>
+          </a:p>
+        </p:txBody>
       </p:sp>
       <p:sp>
         <p:nvSpPr>
@@ -4073,7 +3978,7 @@
           <a:bodyPr wrap="square" lIns="76200" tIns="76200" rIns="76200" bIns="76200" rtlCol="0" anchor="ctr"/>
           <a:lstStyle/>
           <a:p>
-            <a:pPr algn="ctr" indent="0" marL="0">
+            <a:pPr marL="0" indent="0" algn="ctr">
               <a:buNone/>
             </a:pPr>
             <a:r>
@@ -4315,13 +4220,20 @@
             <a:prstDash val="solid"/>
           </a:ln>
           <a:effectLst>
-            <a:outerShdw sx="100000" sy="100000" kx="0" ky="0" algn="bl" rotWithShape="0" blurRad="101600" dist="38100" dir="8100000">
+            <a:outerShdw blurRad="101600" dist="38100" dir="8100000" algn="bl" rotWithShape="0">
               <a:srgbClr val="000000">
                 <a:alpha val="12000"/>
               </a:srgbClr>
             </a:outerShdw>
           </a:effectLst>
         </p:spPr>
+        <p:txBody>
+          <a:bodyPr/>
+          <a:lstStyle/>
+          <a:p>
+            <a:endParaRPr lang="es-CL"/>
+          </a:p>
+        </p:txBody>
       </p:sp>
       <p:sp>
         <p:nvSpPr>
@@ -4342,6 +4254,13 @@
           </a:solidFill>
           <a:ln/>
         </p:spPr>
+        <p:txBody>
+          <a:bodyPr/>
+          <a:lstStyle/>
+          <a:p>
+            <a:endParaRPr lang="es-CL"/>
+          </a:p>
+        </p:txBody>
       </p:sp>
       <p:sp>
         <p:nvSpPr>
@@ -4364,7 +4283,7 @@
           <a:bodyPr wrap="square" lIns="76200" tIns="76200" rIns="76200" bIns="76200" rtlCol="0" anchor="ctr"/>
           <a:lstStyle/>
           <a:p>
-            <a:pPr algn="ctr" indent="0" marL="0">
+            <a:pPr marL="0" indent="0" algn="ctr">
               <a:buNone/>
             </a:pPr>
             <a:r>
@@ -4606,13 +4525,20 @@
             <a:prstDash val="solid"/>
           </a:ln>
           <a:effectLst>
-            <a:outerShdw sx="100000" sy="100000" kx="0" ky="0" algn="bl" rotWithShape="0" blurRad="101600" dist="38100" dir="8100000">
+            <a:outerShdw blurRad="101600" dist="38100" dir="8100000" algn="bl" rotWithShape="0">
               <a:srgbClr val="000000">
                 <a:alpha val="12000"/>
               </a:srgbClr>
             </a:outerShdw>
           </a:effectLst>
         </p:spPr>
+        <p:txBody>
+          <a:bodyPr/>
+          <a:lstStyle/>
+          <a:p>
+            <a:endParaRPr lang="es-CL"/>
+          </a:p>
+        </p:txBody>
       </p:sp>
       <p:sp>
         <p:nvSpPr>
@@ -4633,6 +4559,13 @@
           </a:solidFill>
           <a:ln/>
         </p:spPr>
+        <p:txBody>
+          <a:bodyPr/>
+          <a:lstStyle/>
+          <a:p>
+            <a:endParaRPr lang="es-CL"/>
+          </a:p>
+        </p:txBody>
       </p:sp>
       <p:sp>
         <p:nvSpPr>
@@ -4655,7 +4588,7 @@
           <a:bodyPr wrap="square" lIns="76200" tIns="76200" rIns="76200" bIns="76200" rtlCol="0" anchor="ctr"/>
           <a:lstStyle/>
           <a:p>
-            <a:pPr algn="ctr" indent="0" marL="0">
+            <a:pPr marL="0" indent="0" algn="ctr">
               <a:buNone/>
             </a:pPr>
             <a:r>
@@ -4889,6 +4822,7 @@
         <a:solidFill>
           <a:srgbClr val="F8FBF8"/>
         </a:solidFill>
+        <a:effectLst/>
       </p:bgPr>
     </p:bg>
     <p:spTree>
@@ -4926,7 +4860,7 @@
           <a:bodyPr wrap="square" lIns="0" tIns="0" rIns="0" bIns="0" rtlCol="0" anchor="ctr"/>
           <a:lstStyle/>
           <a:p>
-            <a:pPr algn="l" indent="0" marL="0">
+            <a:pPr marL="0" indent="0" algn="l">
               <a:buNone/>
             </a:pPr>
             <a:r>
@@ -4963,6 +4897,13 @@
           </a:solidFill>
           <a:ln/>
         </p:spPr>
+        <p:txBody>
+          <a:bodyPr/>
+          <a:lstStyle/>
+          <a:p>
+            <a:endParaRPr lang="es-CL"/>
+          </a:p>
+        </p:txBody>
       </p:sp>
       <p:sp>
         <p:nvSpPr>
@@ -4988,13 +4929,20 @@
             <a:prstDash val="solid"/>
           </a:ln>
           <a:effectLst>
-            <a:outerShdw sx="100000" sy="100000" kx="0" ky="0" algn="bl" rotWithShape="0" blurRad="101600" dist="38100" dir="8100000">
+            <a:outerShdw blurRad="101600" dist="38100" dir="8100000" algn="bl" rotWithShape="0">
               <a:srgbClr val="000000">
                 <a:alpha val="12000"/>
               </a:srgbClr>
             </a:outerShdw>
           </a:effectLst>
         </p:spPr>
+        <p:txBody>
+          <a:bodyPr/>
+          <a:lstStyle/>
+          <a:p>
+            <a:endParaRPr lang="es-CL"/>
+          </a:p>
+        </p:txBody>
       </p:sp>
       <p:sp>
         <p:nvSpPr>
@@ -5015,6 +4963,13 @@
           </a:solidFill>
           <a:ln/>
         </p:spPr>
+        <p:txBody>
+          <a:bodyPr/>
+          <a:lstStyle/>
+          <a:p>
+            <a:endParaRPr lang="es-CL"/>
+          </a:p>
+        </p:txBody>
       </p:sp>
       <p:sp>
         <p:nvSpPr>
@@ -5037,7 +4992,7 @@
           <a:bodyPr wrap="square" lIns="0" tIns="0" rIns="0" bIns="0" rtlCol="0" anchor="ctr"/>
           <a:lstStyle/>
           <a:p>
-            <a:pPr algn="ctr" indent="0" marL="0">
+            <a:pPr marL="0" indent="0" algn="ctr">
               <a:buNone/>
             </a:pPr>
             <a:r>
@@ -5076,7 +5031,7 @@
           <a:bodyPr wrap="square" lIns="0" tIns="0" rIns="0" bIns="0" rtlCol="0" anchor="ctr"/>
           <a:lstStyle/>
           <a:p>
-            <a:pPr indent="0" marL="0">
+            <a:pPr marL="0" indent="0">
               <a:buNone/>
             </a:pPr>
             <a:r>
@@ -5115,7 +5070,7 @@
           <a:bodyPr wrap="square" lIns="0" tIns="0" rIns="0" bIns="0" rtlCol="0" anchor="ctr"/>
           <a:lstStyle/>
           <a:p>
-            <a:pPr indent="0" marL="0">
+            <a:pPr marL="0" indent="0">
               <a:buNone/>
             </a:pPr>
             <a:r>
@@ -5132,7 +5087,7 @@
             <a:endParaRPr lang="en-US" sz="1200" dirty="0"/>
           </a:p>
           <a:p>
-            <a:pPr indent="0" marL="0">
+            <a:pPr marL="0" indent="0">
               <a:buNone/>
             </a:pPr>
             <a:r>
@@ -5174,13 +5129,20 @@
             <a:prstDash val="solid"/>
           </a:ln>
           <a:effectLst>
-            <a:outerShdw sx="100000" sy="100000" kx="0" ky="0" algn="bl" rotWithShape="0" blurRad="101600" dist="38100" dir="8100000">
+            <a:outerShdw blurRad="101600" dist="38100" dir="8100000" algn="bl" rotWithShape="0">
               <a:srgbClr val="000000">
                 <a:alpha val="12000"/>
               </a:srgbClr>
             </a:outerShdw>
           </a:effectLst>
         </p:spPr>
+        <p:txBody>
+          <a:bodyPr/>
+          <a:lstStyle/>
+          <a:p>
+            <a:endParaRPr lang="es-CL"/>
+          </a:p>
+        </p:txBody>
       </p:sp>
       <p:sp>
         <p:nvSpPr>
@@ -5201,6 +5163,13 @@
           </a:solidFill>
           <a:ln/>
         </p:spPr>
+        <p:txBody>
+          <a:bodyPr/>
+          <a:lstStyle/>
+          <a:p>
+            <a:endParaRPr lang="es-CL"/>
+          </a:p>
+        </p:txBody>
       </p:sp>
       <p:sp>
         <p:nvSpPr>
@@ -5223,7 +5192,7 @@
           <a:bodyPr wrap="square" lIns="0" tIns="0" rIns="0" bIns="0" rtlCol="0" anchor="ctr"/>
           <a:lstStyle/>
           <a:p>
-            <a:pPr algn="ctr" indent="0" marL="0">
+            <a:pPr marL="0" indent="0" algn="ctr">
               <a:buNone/>
             </a:pPr>
             <a:r>
@@ -5262,7 +5231,7 @@
           <a:bodyPr wrap="square" lIns="0" tIns="0" rIns="0" bIns="0" rtlCol="0" anchor="ctr"/>
           <a:lstStyle/>
           <a:p>
-            <a:pPr indent="0" marL="0">
+            <a:pPr marL="0" indent="0">
               <a:buNone/>
             </a:pPr>
             <a:r>
@@ -5301,7 +5270,7 @@
           <a:bodyPr wrap="square" lIns="0" tIns="0" rIns="0" bIns="0" rtlCol="0" anchor="ctr"/>
           <a:lstStyle/>
           <a:p>
-            <a:pPr indent="0" marL="0">
+            <a:pPr marL="0" indent="0">
               <a:buNone/>
             </a:pPr>
             <a:r>
@@ -5318,7 +5287,7 @@
             <a:endParaRPr lang="en-US" sz="1200" dirty="0"/>
           </a:p>
           <a:p>
-            <a:pPr indent="0" marL="0">
+            <a:pPr marL="0" indent="0">
               <a:buNone/>
             </a:pPr>
             <a:r>
@@ -5360,13 +5329,20 @@
             <a:prstDash val="solid"/>
           </a:ln>
           <a:effectLst>
-            <a:outerShdw sx="100000" sy="100000" kx="0" ky="0" algn="bl" rotWithShape="0" blurRad="101600" dist="38100" dir="8100000">
+            <a:outerShdw blurRad="101600" dist="38100" dir="8100000" algn="bl" rotWithShape="0">
               <a:srgbClr val="000000">
                 <a:alpha val="12000"/>
               </a:srgbClr>
             </a:outerShdw>
           </a:effectLst>
         </p:spPr>
+        <p:txBody>
+          <a:bodyPr/>
+          <a:lstStyle/>
+          <a:p>
+            <a:endParaRPr lang="es-CL"/>
+          </a:p>
+        </p:txBody>
       </p:sp>
       <p:sp>
         <p:nvSpPr>
@@ -5387,6 +5363,13 @@
           </a:solidFill>
           <a:ln/>
         </p:spPr>
+        <p:txBody>
+          <a:bodyPr/>
+          <a:lstStyle/>
+          <a:p>
+            <a:endParaRPr lang="es-CL"/>
+          </a:p>
+        </p:txBody>
       </p:sp>
       <p:sp>
         <p:nvSpPr>
@@ -5409,7 +5392,7 @@
           <a:bodyPr wrap="square" lIns="0" tIns="0" rIns="0" bIns="0" rtlCol="0" anchor="ctr"/>
           <a:lstStyle/>
           <a:p>
-            <a:pPr algn="ctr" indent="0" marL="0">
+            <a:pPr marL="0" indent="0" algn="ctr">
               <a:buNone/>
             </a:pPr>
             <a:r>
@@ -5448,7 +5431,7 @@
           <a:bodyPr wrap="square" lIns="0" tIns="0" rIns="0" bIns="0" rtlCol="0" anchor="ctr"/>
           <a:lstStyle/>
           <a:p>
-            <a:pPr indent="0" marL="0">
+            <a:pPr marL="0" indent="0">
               <a:buNone/>
             </a:pPr>
             <a:r>
@@ -5487,7 +5470,7 @@
           <a:bodyPr wrap="square" lIns="0" tIns="0" rIns="0" bIns="0" rtlCol="0" anchor="ctr"/>
           <a:lstStyle/>
           <a:p>
-            <a:pPr indent="0" marL="0">
+            <a:pPr marL="0" indent="0">
               <a:buNone/>
             </a:pPr>
             <a:r>
@@ -5504,7 +5487,7 @@
             <a:endParaRPr lang="en-US" sz="1200" dirty="0"/>
           </a:p>
           <a:p>
-            <a:pPr indent="0" marL="0">
+            <a:pPr marL="0" indent="0">
               <a:buNone/>
             </a:pPr>
             <a:r>
@@ -5546,13 +5529,20 @@
             <a:prstDash val="solid"/>
           </a:ln>
           <a:effectLst>
-            <a:outerShdw sx="100000" sy="100000" kx="0" ky="0" algn="bl" rotWithShape="0" blurRad="101600" dist="38100" dir="8100000">
+            <a:outerShdw blurRad="101600" dist="38100" dir="8100000" algn="bl" rotWithShape="0">
               <a:srgbClr val="000000">
                 <a:alpha val="12000"/>
               </a:srgbClr>
             </a:outerShdw>
           </a:effectLst>
         </p:spPr>
+        <p:txBody>
+          <a:bodyPr/>
+          <a:lstStyle/>
+          <a:p>
+            <a:endParaRPr lang="es-CL"/>
+          </a:p>
+        </p:txBody>
       </p:sp>
       <p:sp>
         <p:nvSpPr>
@@ -5573,6 +5563,13 @@
           </a:solidFill>
           <a:ln/>
         </p:spPr>
+        <p:txBody>
+          <a:bodyPr/>
+          <a:lstStyle/>
+          <a:p>
+            <a:endParaRPr lang="es-CL"/>
+          </a:p>
+        </p:txBody>
       </p:sp>
       <p:sp>
         <p:nvSpPr>
@@ -5595,7 +5592,7 @@
           <a:bodyPr wrap="square" lIns="0" tIns="0" rIns="0" bIns="0" rtlCol="0" anchor="ctr"/>
           <a:lstStyle/>
           <a:p>
-            <a:pPr algn="ctr" indent="0" marL="0">
+            <a:pPr marL="0" indent="0" algn="ctr">
               <a:buNone/>
             </a:pPr>
             <a:r>
@@ -5634,7 +5631,7 @@
           <a:bodyPr wrap="square" lIns="0" tIns="0" rIns="0" bIns="0" rtlCol="0" anchor="ctr"/>
           <a:lstStyle/>
           <a:p>
-            <a:pPr indent="0" marL="0">
+            <a:pPr marL="0" indent="0">
               <a:buNone/>
             </a:pPr>
             <a:r>
@@ -5673,7 +5670,7 @@
           <a:bodyPr wrap="square" lIns="0" tIns="0" rIns="0" bIns="0" rtlCol="0" anchor="ctr"/>
           <a:lstStyle/>
           <a:p>
-            <a:pPr indent="0" marL="0">
+            <a:pPr marL="0" indent="0">
               <a:buNone/>
             </a:pPr>
             <a:r>
@@ -5690,7 +5687,7 @@
             <a:endParaRPr lang="en-US" sz="1200" dirty="0"/>
           </a:p>
           <a:p>
-            <a:pPr indent="0" marL="0">
+            <a:pPr marL="0" indent="0">
               <a:buNone/>
             </a:pPr>
             <a:r>
@@ -5732,13 +5729,20 @@
             <a:prstDash val="solid"/>
           </a:ln>
           <a:effectLst>
-            <a:outerShdw sx="100000" sy="100000" kx="0" ky="0" algn="bl" rotWithShape="0" blurRad="101600" dist="38100" dir="8100000">
+            <a:outerShdw blurRad="101600" dist="38100" dir="8100000" algn="bl" rotWithShape="0">
               <a:srgbClr val="000000">
                 <a:alpha val="12000"/>
               </a:srgbClr>
             </a:outerShdw>
           </a:effectLst>
         </p:spPr>
+        <p:txBody>
+          <a:bodyPr/>
+          <a:lstStyle/>
+          <a:p>
+            <a:endParaRPr lang="es-CL"/>
+          </a:p>
+        </p:txBody>
       </p:sp>
       <p:sp>
         <p:nvSpPr>
@@ -5759,6 +5763,13 @@
           </a:solidFill>
           <a:ln/>
         </p:spPr>
+        <p:txBody>
+          <a:bodyPr/>
+          <a:lstStyle/>
+          <a:p>
+            <a:endParaRPr lang="es-CL"/>
+          </a:p>
+        </p:txBody>
       </p:sp>
       <p:sp>
         <p:nvSpPr>
@@ -5781,7 +5792,7 @@
           <a:bodyPr wrap="square" lIns="0" tIns="0" rIns="0" bIns="0" rtlCol="0" anchor="ctr"/>
           <a:lstStyle/>
           <a:p>
-            <a:pPr algn="ctr" indent="0" marL="0">
+            <a:pPr marL="0" indent="0" algn="ctr">
               <a:buNone/>
             </a:pPr>
             <a:r>
@@ -5820,7 +5831,7 @@
           <a:bodyPr wrap="square" lIns="0" tIns="0" rIns="0" bIns="0" rtlCol="0" anchor="ctr"/>
           <a:lstStyle/>
           <a:p>
-            <a:pPr indent="0" marL="0">
+            <a:pPr marL="0" indent="0">
               <a:buNone/>
             </a:pPr>
             <a:r>
@@ -5854,6 +5865,7 @@
         <a:solidFill>
           <a:srgbClr val="0F2318"/>
         </a:solidFill>
+        <a:effectLst/>
       </p:bgPr>
     </p:bg>
     <p:spTree>
@@ -5891,7 +5903,7 @@
           <a:bodyPr wrap="square" lIns="0" tIns="0" rIns="0" bIns="0" rtlCol="0" anchor="ctr"/>
           <a:lstStyle/>
           <a:p>
-            <a:pPr algn="l" indent="0" marL="0">
+            <a:pPr marL="0" indent="0" algn="l">
               <a:buNone/>
             </a:pPr>
             <a:r>
@@ -5928,6 +5940,13 @@
           </a:solidFill>
           <a:ln/>
         </p:spPr>
+        <p:txBody>
+          <a:bodyPr/>
+          <a:lstStyle/>
+          <a:p>
+            <a:endParaRPr lang="es-CL"/>
+          </a:p>
+        </p:txBody>
       </p:sp>
       <p:sp>
         <p:nvSpPr>
@@ -5948,13 +5967,20 @@
           </a:solidFill>
           <a:ln/>
           <a:effectLst>
-            <a:outerShdw sx="100000" sy="100000" kx="0" ky="0" algn="bl" rotWithShape="0" blurRad="101600" dist="38100" dir="8100000">
+            <a:outerShdw blurRad="101600" dist="38100" dir="8100000" algn="bl" rotWithShape="0">
               <a:srgbClr val="000000">
                 <a:alpha val="12000"/>
               </a:srgbClr>
             </a:outerShdw>
           </a:effectLst>
         </p:spPr>
+        <p:txBody>
+          <a:bodyPr/>
+          <a:lstStyle/>
+          <a:p>
+            <a:endParaRPr lang="es-CL"/>
+          </a:p>
+        </p:txBody>
       </p:sp>
       <p:sp>
         <p:nvSpPr>
@@ -5977,7 +6003,7 @@
           <a:bodyPr wrap="square" lIns="0" tIns="0" rIns="0" bIns="0" rtlCol="0" anchor="ctr"/>
           <a:lstStyle/>
           <a:p>
-            <a:pPr algn="ctr" indent="0" marL="0">
+            <a:pPr marL="0" indent="0" algn="ctr">
               <a:buNone/>
             </a:pPr>
             <a:r>
@@ -6016,7 +6042,7 @@
           <a:bodyPr wrap="square" lIns="0" tIns="0" rIns="0" bIns="0" rtlCol="0" anchor="ctr"/>
           <a:lstStyle/>
           <a:p>
-            <a:pPr algn="ctr" indent="0" marL="0">
+            <a:pPr marL="0" indent="0" algn="ctr">
               <a:buNone/>
             </a:pPr>
             <a:r>
@@ -6055,7 +6081,7 @@
           <a:bodyPr wrap="square" lIns="0" tIns="0" rIns="0" bIns="0" rtlCol="0" anchor="ctr"/>
           <a:lstStyle/>
           <a:p>
-            <a:pPr algn="ctr" indent="0" marL="0">
+            <a:pPr marL="0" indent="0" algn="ctr">
               <a:buNone/>
             </a:pPr>
             <a:r>
@@ -6092,13 +6118,20 @@
           </a:solidFill>
           <a:ln/>
           <a:effectLst>
-            <a:outerShdw sx="100000" sy="100000" kx="0" ky="0" algn="bl" rotWithShape="0" blurRad="101600" dist="38100" dir="8100000">
+            <a:outerShdw blurRad="101600" dist="38100" dir="8100000" algn="bl" rotWithShape="0">
               <a:srgbClr val="000000">
                 <a:alpha val="12000"/>
               </a:srgbClr>
             </a:outerShdw>
           </a:effectLst>
         </p:spPr>
+        <p:txBody>
+          <a:bodyPr/>
+          <a:lstStyle/>
+          <a:p>
+            <a:endParaRPr lang="es-CL"/>
+          </a:p>
+        </p:txBody>
       </p:sp>
       <p:sp>
         <p:nvSpPr>
@@ -6121,7 +6154,7 @@
           <a:bodyPr wrap="square" lIns="0" tIns="0" rIns="0" bIns="0" rtlCol="0" anchor="ctr"/>
           <a:lstStyle/>
           <a:p>
-            <a:pPr algn="ctr" indent="0" marL="0">
+            <a:pPr marL="0" indent="0" algn="ctr">
               <a:buNone/>
             </a:pPr>
             <a:r>
@@ -6160,7 +6193,7 @@
           <a:bodyPr wrap="square" lIns="0" tIns="0" rIns="0" bIns="0" rtlCol="0" anchor="ctr"/>
           <a:lstStyle/>
           <a:p>
-            <a:pPr algn="ctr" indent="0" marL="0">
+            <a:pPr marL="0" indent="0" algn="ctr">
               <a:buNone/>
             </a:pPr>
             <a:r>
@@ -6197,13 +6230,20 @@
           </a:solidFill>
           <a:ln/>
           <a:effectLst>
-            <a:outerShdw sx="100000" sy="100000" kx="0" ky="0" algn="bl" rotWithShape="0" blurRad="101600" dist="38100" dir="8100000">
+            <a:outerShdw blurRad="101600" dist="38100" dir="8100000" algn="bl" rotWithShape="0">
               <a:srgbClr val="000000">
                 <a:alpha val="12000"/>
               </a:srgbClr>
             </a:outerShdw>
           </a:effectLst>
         </p:spPr>
+        <p:txBody>
+          <a:bodyPr/>
+          <a:lstStyle/>
+          <a:p>
+            <a:endParaRPr lang="es-CL"/>
+          </a:p>
+        </p:txBody>
       </p:sp>
       <p:sp>
         <p:nvSpPr>
@@ -6226,7 +6266,7 @@
           <a:bodyPr wrap="square" lIns="0" tIns="0" rIns="0" bIns="0" rtlCol="0" anchor="ctr"/>
           <a:lstStyle/>
           <a:p>
-            <a:pPr algn="ctr" indent="0" marL="0">
+            <a:pPr marL="0" indent="0" algn="ctr">
               <a:buNone/>
             </a:pPr>
             <a:r>
@@ -6265,7 +6305,7 @@
           <a:bodyPr wrap="square" lIns="0" tIns="0" rIns="0" bIns="0" rtlCol="0" anchor="ctr"/>
           <a:lstStyle/>
           <a:p>
-            <a:pPr algn="ctr" indent="0" marL="0">
+            <a:pPr marL="0" indent="0" algn="ctr">
               <a:buNone/>
             </a:pPr>
             <a:r>
@@ -6302,13 +6342,20 @@
           </a:solidFill>
           <a:ln/>
           <a:effectLst>
-            <a:outerShdw sx="100000" sy="100000" kx="0" ky="0" algn="bl" rotWithShape="0" blurRad="101600" dist="38100" dir="8100000">
+            <a:outerShdw blurRad="101600" dist="38100" dir="8100000" algn="bl" rotWithShape="0">
               <a:srgbClr val="000000">
                 <a:alpha val="12000"/>
               </a:srgbClr>
             </a:outerShdw>
           </a:effectLst>
         </p:spPr>
+        <p:txBody>
+          <a:bodyPr/>
+          <a:lstStyle/>
+          <a:p>
+            <a:endParaRPr lang="es-CL"/>
+          </a:p>
+        </p:txBody>
       </p:sp>
       <p:sp>
         <p:nvSpPr>
@@ -6331,7 +6378,7 @@
           <a:bodyPr wrap="square" lIns="0" tIns="0" rIns="0" bIns="0" rtlCol="0" anchor="ctr"/>
           <a:lstStyle/>
           <a:p>
-            <a:pPr algn="ctr" indent="0" marL="0">
+            <a:pPr marL="0" indent="0" algn="ctr">
               <a:buNone/>
             </a:pPr>
             <a:r>
@@ -6370,7 +6417,7 @@
           <a:bodyPr wrap="square" lIns="0" tIns="0" rIns="0" bIns="0" rtlCol="0" anchor="ctr"/>
           <a:lstStyle/>
           <a:p>
-            <a:pPr algn="ctr" indent="0" marL="0">
+            <a:pPr marL="0" indent="0" algn="ctr">
               <a:buNone/>
             </a:pPr>
             <a:r>
@@ -6407,13 +6454,20 @@
           </a:solidFill>
           <a:ln/>
           <a:effectLst>
-            <a:outerShdw sx="100000" sy="100000" kx="0" ky="0" algn="bl" rotWithShape="0" blurRad="101600" dist="38100" dir="8100000">
+            <a:outerShdw blurRad="101600" dist="38100" dir="8100000" algn="bl" rotWithShape="0">
               <a:srgbClr val="000000">
                 <a:alpha val="12000"/>
               </a:srgbClr>
             </a:outerShdw>
           </a:effectLst>
         </p:spPr>
+        <p:txBody>
+          <a:bodyPr/>
+          <a:lstStyle/>
+          <a:p>
+            <a:endParaRPr lang="es-CL"/>
+          </a:p>
+        </p:txBody>
       </p:sp>
       <p:sp>
         <p:nvSpPr>
@@ -6436,7 +6490,7 @@
           <a:bodyPr wrap="square" lIns="0" tIns="0" rIns="0" bIns="0" rtlCol="0" anchor="ctr"/>
           <a:lstStyle/>
           <a:p>
-            <a:pPr algn="ctr" indent="0" marL="0">
+            <a:pPr marL="0" indent="0" algn="ctr">
               <a:buNone/>
             </a:pPr>
             <a:r>
@@ -6475,7 +6529,7 @@
           <a:bodyPr wrap="square" lIns="0" tIns="0" rIns="0" bIns="0" rtlCol="0" anchor="ctr"/>
           <a:lstStyle/>
           <a:p>
-            <a:pPr algn="ctr" indent="0" marL="0">
+            <a:pPr marL="0" indent="0" algn="ctr">
               <a:buNone/>
             </a:pPr>
             <a:r>
@@ -6514,7 +6568,7 @@
           <a:bodyPr wrap="square" lIns="0" tIns="0" rIns="0" bIns="0" rtlCol="0" anchor="ctr"/>
           <a:lstStyle/>
           <a:p>
-            <a:pPr algn="ctr" indent="0" marL="0">
+            <a:pPr marL="0" indent="0" algn="ctr">
               <a:buNone/>
             </a:pPr>
             <a:r>
@@ -6556,6 +6610,13 @@
             <a:prstDash val="solid"/>
           </a:ln>
         </p:spPr>
+        <p:txBody>
+          <a:bodyPr/>
+          <a:lstStyle/>
+          <a:p>
+            <a:endParaRPr lang="es-CL"/>
+          </a:p>
+        </p:txBody>
       </p:sp>
       <p:sp>
         <p:nvSpPr>
@@ -6578,7 +6639,7 @@
           <a:bodyPr wrap="square" lIns="50800" tIns="50800" rIns="50800" bIns="50800" rtlCol="0" anchor="ctr"/>
           <a:lstStyle/>
           <a:p>
-            <a:pPr algn="ctr" indent="0" marL="0">
+            <a:pPr marL="0" indent="0" algn="ctr">
               <a:buNone/>
             </a:pPr>
             <a:r>
@@ -6620,6 +6681,13 @@
             <a:prstDash val="solid"/>
           </a:ln>
         </p:spPr>
+        <p:txBody>
+          <a:bodyPr/>
+          <a:lstStyle/>
+          <a:p>
+            <a:endParaRPr lang="es-CL"/>
+          </a:p>
+        </p:txBody>
       </p:sp>
       <p:sp>
         <p:nvSpPr>
@@ -6642,7 +6710,7 @@
           <a:bodyPr wrap="square" lIns="50800" tIns="50800" rIns="50800" bIns="50800" rtlCol="0" anchor="ctr"/>
           <a:lstStyle/>
           <a:p>
-            <a:pPr algn="ctr" indent="0" marL="0">
+            <a:pPr marL="0" indent="0" algn="ctr">
               <a:buNone/>
             </a:pPr>
             <a:r>
@@ -6684,6 +6752,13 @@
             <a:prstDash val="solid"/>
           </a:ln>
         </p:spPr>
+        <p:txBody>
+          <a:bodyPr/>
+          <a:lstStyle/>
+          <a:p>
+            <a:endParaRPr lang="es-CL"/>
+          </a:p>
+        </p:txBody>
       </p:sp>
       <p:sp>
         <p:nvSpPr>
@@ -6706,7 +6781,7 @@
           <a:bodyPr wrap="square" lIns="50800" tIns="50800" rIns="50800" bIns="50800" rtlCol="0" anchor="ctr"/>
           <a:lstStyle/>
           <a:p>
-            <a:pPr algn="ctr" indent="0" marL="0">
+            <a:pPr marL="0" indent="0" algn="ctr">
               <a:buNone/>
             </a:pPr>
             <a:r>
@@ -6748,6 +6823,13 @@
             <a:prstDash val="solid"/>
           </a:ln>
         </p:spPr>
+        <p:txBody>
+          <a:bodyPr/>
+          <a:lstStyle/>
+          <a:p>
+            <a:endParaRPr lang="es-CL"/>
+          </a:p>
+        </p:txBody>
       </p:sp>
       <p:sp>
         <p:nvSpPr>
@@ -6770,7 +6852,7 @@
           <a:bodyPr wrap="square" lIns="50800" tIns="50800" rIns="50800" bIns="50800" rtlCol="0" anchor="ctr"/>
           <a:lstStyle/>
           <a:p>
-            <a:pPr algn="ctr" indent="0" marL="0">
+            <a:pPr marL="0" indent="0" algn="ctr">
               <a:buNone/>
             </a:pPr>
             <a:r>
@@ -6804,6 +6886,7 @@
         <a:solidFill>
           <a:srgbClr val="F8FBF8"/>
         </a:solidFill>
+        <a:effectLst/>
       </p:bgPr>
     </p:bg>
     <p:spTree>
@@ -6841,7 +6924,7 @@
           <a:bodyPr wrap="square" lIns="0" tIns="0" rIns="0" bIns="0" rtlCol="0" anchor="ctr"/>
           <a:lstStyle/>
           <a:p>
-            <a:pPr algn="l" indent="0" marL="0">
+            <a:pPr marL="0" indent="0" algn="l">
               <a:buNone/>
             </a:pPr>
             <a:r>
@@ -6878,6 +6961,13 @@
           </a:solidFill>
           <a:ln/>
         </p:spPr>
+        <p:txBody>
+          <a:bodyPr/>
+          <a:lstStyle/>
+          <a:p>
+            <a:endParaRPr lang="es-CL"/>
+          </a:p>
+        </p:txBody>
       </p:sp>
       <p:sp>
         <p:nvSpPr>
@@ -6903,13 +6993,20 @@
             <a:prstDash val="solid"/>
           </a:ln>
           <a:effectLst>
-            <a:outerShdw sx="100000" sy="100000" kx="0" ky="0" algn="bl" rotWithShape="0" blurRad="101600" dist="38100" dir="8100000">
+            <a:outerShdw blurRad="101600" dist="38100" dir="8100000" algn="bl" rotWithShape="0">
               <a:srgbClr val="000000">
                 <a:alpha val="12000"/>
               </a:srgbClr>
             </a:outerShdw>
           </a:effectLst>
         </p:spPr>
+        <p:txBody>
+          <a:bodyPr/>
+          <a:lstStyle/>
+          <a:p>
+            <a:endParaRPr lang="es-CL"/>
+          </a:p>
+        </p:txBody>
       </p:sp>
       <p:sp>
         <p:nvSpPr>
@@ -6930,6 +7027,13 @@
           </a:solidFill>
           <a:ln/>
         </p:spPr>
+        <p:txBody>
+          <a:bodyPr/>
+          <a:lstStyle/>
+          <a:p>
+            <a:endParaRPr lang="es-CL"/>
+          </a:p>
+        </p:txBody>
       </p:sp>
       <p:sp>
         <p:nvSpPr>
@@ -6952,7 +7056,7 @@
           <a:bodyPr wrap="square" lIns="76200" tIns="76200" rIns="76200" bIns="76200" rtlCol="0" anchor="ctr"/>
           <a:lstStyle/>
           <a:p>
-            <a:pPr indent="0" marL="0">
+            <a:pPr marL="0" indent="0">
               <a:buNone/>
             </a:pPr>
             <a:r>
@@ -7154,13 +7258,20 @@
             <a:prstDash val="solid"/>
           </a:ln>
           <a:effectLst>
-            <a:outerShdw sx="100000" sy="100000" kx="0" ky="0" algn="bl" rotWithShape="0" blurRad="101600" dist="38100" dir="8100000">
+            <a:outerShdw blurRad="101600" dist="38100" dir="8100000" algn="bl" rotWithShape="0">
               <a:srgbClr val="000000">
                 <a:alpha val="12000"/>
               </a:srgbClr>
             </a:outerShdw>
           </a:effectLst>
         </p:spPr>
+        <p:txBody>
+          <a:bodyPr/>
+          <a:lstStyle/>
+          <a:p>
+            <a:endParaRPr lang="es-CL"/>
+          </a:p>
+        </p:txBody>
       </p:sp>
       <p:sp>
         <p:nvSpPr>
@@ -7181,6 +7292,13 @@
           </a:solidFill>
           <a:ln/>
         </p:spPr>
+        <p:txBody>
+          <a:bodyPr/>
+          <a:lstStyle/>
+          <a:p>
+            <a:endParaRPr lang="es-CL"/>
+          </a:p>
+        </p:txBody>
       </p:sp>
       <p:sp>
         <p:nvSpPr>
@@ -7203,7 +7321,7 @@
           <a:bodyPr wrap="square" lIns="76200" tIns="76200" rIns="76200" bIns="76200" rtlCol="0" anchor="ctr"/>
           <a:lstStyle/>
           <a:p>
-            <a:pPr indent="0" marL="0">
+            <a:pPr marL="0" indent="0">
               <a:buNone/>
             </a:pPr>
             <a:r>
@@ -7405,13 +7523,20 @@
             <a:prstDash val="solid"/>
           </a:ln>
           <a:effectLst>
-            <a:outerShdw sx="100000" sy="100000" kx="0" ky="0" algn="bl" rotWithShape="0" blurRad="101600" dist="38100" dir="8100000">
+            <a:outerShdw blurRad="101600" dist="38100" dir="8100000" algn="bl" rotWithShape="0">
               <a:srgbClr val="000000">
                 <a:alpha val="12000"/>
               </a:srgbClr>
             </a:outerShdw>
           </a:effectLst>
         </p:spPr>
+        <p:txBody>
+          <a:bodyPr/>
+          <a:lstStyle/>
+          <a:p>
+            <a:endParaRPr lang="es-CL"/>
+          </a:p>
+        </p:txBody>
       </p:sp>
       <p:sp>
         <p:nvSpPr>
@@ -7434,7 +7559,7 @@
           <a:bodyPr wrap="square" lIns="0" tIns="0" rIns="0" bIns="0" rtlCol="0" anchor="ctr"/>
           <a:lstStyle/>
           <a:p>
-            <a:pPr algn="ctr" indent="0" marL="0">
+            <a:pPr marL="0" indent="0" algn="ctr">
               <a:buNone/>
             </a:pPr>
             <a:r>
@@ -7473,7 +7598,7 @@
           <a:bodyPr wrap="square" lIns="0" tIns="0" rIns="0" bIns="0" rtlCol="0" anchor="ctr"/>
           <a:lstStyle/>
           <a:p>
-            <a:pPr algn="ctr" indent="0" marL="0">
+            <a:pPr marL="0" indent="0" algn="ctr">
               <a:buNone/>
             </a:pPr>
             <a:r>
@@ -7512,7 +7637,7 @@
           <a:bodyPr wrap="square" lIns="0" tIns="0" rIns="0" bIns="0" rtlCol="0" anchor="ctr"/>
           <a:lstStyle/>
           <a:p>
-            <a:pPr algn="ctr" indent="0" marL="0">
+            <a:pPr marL="0" indent="0" algn="ctr">
               <a:buNone/>
             </a:pPr>
             <a:r>
@@ -7554,13 +7679,20 @@
             <a:prstDash val="solid"/>
           </a:ln>
           <a:effectLst>
-            <a:outerShdw sx="100000" sy="100000" kx="0" ky="0" algn="bl" rotWithShape="0" blurRad="101600" dist="38100" dir="8100000">
+            <a:outerShdw blurRad="101600" dist="38100" dir="8100000" algn="bl" rotWithShape="0">
               <a:srgbClr val="000000">
                 <a:alpha val="12000"/>
               </a:srgbClr>
             </a:outerShdw>
           </a:effectLst>
         </p:spPr>
+        <p:txBody>
+          <a:bodyPr/>
+          <a:lstStyle/>
+          <a:p>
+            <a:endParaRPr lang="es-CL"/>
+          </a:p>
+        </p:txBody>
       </p:sp>
       <p:sp>
         <p:nvSpPr>
@@ -7583,7 +7715,7 @@
           <a:bodyPr wrap="square" lIns="0" tIns="0" rIns="0" bIns="0" rtlCol="0" anchor="ctr"/>
           <a:lstStyle/>
           <a:p>
-            <a:pPr algn="ctr" indent="0" marL="0">
+            <a:pPr marL="0" indent="0" algn="ctr">
               <a:buNone/>
             </a:pPr>
             <a:r>
@@ -7622,7 +7754,7 @@
           <a:bodyPr wrap="square" lIns="0" tIns="0" rIns="0" bIns="0" rtlCol="0" anchor="ctr"/>
           <a:lstStyle/>
           <a:p>
-            <a:pPr algn="ctr" indent="0" marL="0">
+            <a:pPr marL="0" indent="0" algn="ctr">
               <a:buNone/>
             </a:pPr>
             <a:r>
@@ -7661,7 +7793,7 @@
           <a:bodyPr wrap="square" lIns="0" tIns="0" rIns="0" bIns="0" rtlCol="0" anchor="ctr"/>
           <a:lstStyle/>
           <a:p>
-            <a:pPr algn="ctr" indent="0" marL="0">
+            <a:pPr marL="0" indent="0" algn="ctr">
               <a:buNone/>
             </a:pPr>
             <a:r>
@@ -7703,13 +7835,20 @@
             <a:prstDash val="solid"/>
           </a:ln>
           <a:effectLst>
-            <a:outerShdw sx="100000" sy="100000" kx="0" ky="0" algn="bl" rotWithShape="0" blurRad="101600" dist="38100" dir="8100000">
+            <a:outerShdw blurRad="101600" dist="38100" dir="8100000" algn="bl" rotWithShape="0">
               <a:srgbClr val="000000">
                 <a:alpha val="12000"/>
               </a:srgbClr>
             </a:outerShdw>
           </a:effectLst>
         </p:spPr>
+        <p:txBody>
+          <a:bodyPr/>
+          <a:lstStyle/>
+          <a:p>
+            <a:endParaRPr lang="es-CL"/>
+          </a:p>
+        </p:txBody>
       </p:sp>
       <p:sp>
         <p:nvSpPr>
@@ -7732,7 +7871,7 @@
           <a:bodyPr wrap="square" lIns="0" tIns="0" rIns="0" bIns="0" rtlCol="0" anchor="ctr"/>
           <a:lstStyle/>
           <a:p>
-            <a:pPr algn="ctr" indent="0" marL="0">
+            <a:pPr marL="0" indent="0" algn="ctr">
               <a:buNone/>
             </a:pPr>
             <a:r>
@@ -7771,7 +7910,7 @@
           <a:bodyPr wrap="square" lIns="0" tIns="0" rIns="0" bIns="0" rtlCol="0" anchor="ctr"/>
           <a:lstStyle/>
           <a:p>
-            <a:pPr algn="ctr" indent="0" marL="0">
+            <a:pPr marL="0" indent="0" algn="ctr">
               <a:buNone/>
             </a:pPr>
             <a:r>
@@ -7810,7 +7949,7 @@
           <a:bodyPr wrap="square" lIns="0" tIns="0" rIns="0" bIns="0" rtlCol="0" anchor="ctr"/>
           <a:lstStyle/>
           <a:p>
-            <a:pPr algn="ctr" indent="0" marL="0">
+            <a:pPr marL="0" indent="0" algn="ctr">
               <a:buNone/>
             </a:pPr>
             <a:r>
@@ -7844,6 +7983,7 @@
         <a:solidFill>
           <a:srgbClr val="0F2318"/>
         </a:solidFill>
+        <a:effectLst/>
       </p:bgPr>
     </p:bg>
     <p:spTree>
@@ -7881,7 +8021,7 @@
           <a:bodyPr wrap="square" lIns="0" tIns="0" rIns="0" bIns="0" rtlCol="0" anchor="ctr"/>
           <a:lstStyle/>
           <a:p>
-            <a:pPr algn="ctr" indent="0" marL="0">
+            <a:pPr marL="0" indent="0" algn="ctr">
               <a:buNone/>
             </a:pPr>
             <a:r>
@@ -7917,11 +8057,11 @@
           <a:bodyPr wrap="square" lIns="0" tIns="0" rIns="0" bIns="0" rtlCol="0" anchor="ctr"/>
           <a:lstStyle/>
           <a:p>
-            <a:pPr algn="ctr" indent="0" marL="0">
-              <a:buNone/>
-            </a:pPr>
-            <a:r>
-              <a:rPr lang="en-US" sz="5400" b="1" spc="400" kern="0" dirty="0">
+            <a:pPr marL="0" indent="0" algn="ctr">
+              <a:buNone/>
+            </a:pPr>
+            <a:r>
+              <a:rPr lang="en-US" sz="5400" b="1" kern="0" spc="400" dirty="0">
                 <a:solidFill>
                   <a:srgbClr val="FFFFFF"/>
                 </a:solidFill>
@@ -7956,7 +8096,7 @@
           <a:bodyPr wrap="square" lIns="0" tIns="0" rIns="0" bIns="0" rtlCol="0" anchor="ctr"/>
           <a:lstStyle/>
           <a:p>
-            <a:pPr algn="ctr" indent="0" marL="0">
+            <a:pPr marL="0" indent="0" algn="ctr">
               <a:buNone/>
             </a:pPr>
             <a:r>
@@ -7990,6 +8130,7 @@
         <a:solidFill>
           <a:srgbClr val="0F2318"/>
         </a:solidFill>
+        <a:effectLst/>
       </p:bgPr>
     </p:bg>
     <p:spTree>
@@ -8027,7 +8168,7 @@
           <a:bodyPr wrap="square" lIns="0" tIns="0" rIns="0" bIns="0" rtlCol="0" anchor="ctr"/>
           <a:lstStyle/>
           <a:p>
-            <a:pPr algn="l" indent="0" marL="0">
+            <a:pPr marL="0" indent="0" algn="l">
               <a:buNone/>
             </a:pPr>
             <a:r>
@@ -8064,6 +8205,13 @@
           </a:solidFill>
           <a:ln/>
         </p:spPr>
+        <p:txBody>
+          <a:bodyPr/>
+          <a:lstStyle/>
+          <a:p>
+            <a:endParaRPr lang="es-CL"/>
+          </a:p>
+        </p:txBody>
       </p:sp>
       <p:sp>
         <p:nvSpPr>
@@ -8084,13 +8232,20 @@
           </a:solidFill>
           <a:ln/>
           <a:effectLst>
-            <a:outerShdw sx="100000" sy="100000" kx="0" ky="0" algn="bl" rotWithShape="0" blurRad="101600" dist="38100" dir="8100000">
+            <a:outerShdw blurRad="101600" dist="38100" dir="8100000" algn="bl" rotWithShape="0">
               <a:srgbClr val="000000">
                 <a:alpha val="12000"/>
               </a:srgbClr>
             </a:outerShdw>
           </a:effectLst>
         </p:spPr>
+        <p:txBody>
+          <a:bodyPr/>
+          <a:lstStyle/>
+          <a:p>
+            <a:endParaRPr lang="es-CL"/>
+          </a:p>
+        </p:txBody>
       </p:sp>
       <p:sp>
         <p:nvSpPr>
@@ -8111,6 +8266,13 @@
           </a:solidFill>
           <a:ln/>
         </p:spPr>
+        <p:txBody>
+          <a:bodyPr/>
+          <a:lstStyle/>
+          <a:p>
+            <a:endParaRPr lang="es-CL"/>
+          </a:p>
+        </p:txBody>
       </p:sp>
       <p:sp>
         <p:nvSpPr>
@@ -8133,7 +8295,7 @@
           <a:bodyPr wrap="square" lIns="0" tIns="0" rIns="0" bIns="0" rtlCol="0" anchor="ctr"/>
           <a:lstStyle/>
           <a:p>
-            <a:pPr algn="ctr" indent="0" marL="0">
+            <a:pPr marL="0" indent="0" algn="ctr">
               <a:buNone/>
             </a:pPr>
             <a:r>
@@ -8169,7 +8331,7 @@
           <a:bodyPr wrap="square" lIns="0" tIns="0" rIns="0" bIns="0" rtlCol="0" anchor="ctr"/>
           <a:lstStyle/>
           <a:p>
-            <a:pPr indent="0" marL="0">
+            <a:pPr marL="0" indent="0">
               <a:buNone/>
             </a:pPr>
             <a:r>
@@ -8208,7 +8370,7 @@
           <a:bodyPr wrap="square" lIns="0" tIns="0" rIns="0" bIns="0" rtlCol="0" anchor="ctr"/>
           <a:lstStyle/>
           <a:p>
-            <a:pPr indent="0" marL="0">
+            <a:pPr marL="0" indent="0">
               <a:buNone/>
             </a:pPr>
             <a:r>
@@ -8245,13 +8407,20 @@
           </a:solidFill>
           <a:ln/>
           <a:effectLst>
-            <a:outerShdw sx="100000" sy="100000" kx="0" ky="0" algn="bl" rotWithShape="0" blurRad="101600" dist="38100" dir="8100000">
+            <a:outerShdw blurRad="101600" dist="38100" dir="8100000" algn="bl" rotWithShape="0">
               <a:srgbClr val="000000">
                 <a:alpha val="12000"/>
               </a:srgbClr>
             </a:outerShdw>
           </a:effectLst>
         </p:spPr>
+        <p:txBody>
+          <a:bodyPr/>
+          <a:lstStyle/>
+          <a:p>
+            <a:endParaRPr lang="es-CL"/>
+          </a:p>
+        </p:txBody>
       </p:sp>
       <p:sp>
         <p:nvSpPr>
@@ -8272,6 +8441,13 @@
           </a:solidFill>
           <a:ln/>
         </p:spPr>
+        <p:txBody>
+          <a:bodyPr/>
+          <a:lstStyle/>
+          <a:p>
+            <a:endParaRPr lang="es-CL"/>
+          </a:p>
+        </p:txBody>
       </p:sp>
       <p:sp>
         <p:nvSpPr>
@@ -8294,7 +8470,7 @@
           <a:bodyPr wrap="square" lIns="0" tIns="0" rIns="0" bIns="0" rtlCol="0" anchor="ctr"/>
           <a:lstStyle/>
           <a:p>
-            <a:pPr algn="ctr" indent="0" marL="0">
+            <a:pPr marL="0" indent="0" algn="ctr">
               <a:buNone/>
             </a:pPr>
             <a:r>
@@ -8330,7 +8506,7 @@
           <a:bodyPr wrap="square" lIns="0" tIns="0" rIns="0" bIns="0" rtlCol="0" anchor="ctr"/>
           <a:lstStyle/>
           <a:p>
-            <a:pPr indent="0" marL="0">
+            <a:pPr marL="0" indent="0">
               <a:buNone/>
             </a:pPr>
             <a:r>
@@ -8369,7 +8545,7 @@
           <a:bodyPr wrap="square" lIns="0" tIns="0" rIns="0" bIns="0" rtlCol="0" anchor="ctr"/>
           <a:lstStyle/>
           <a:p>
-            <a:pPr indent="0" marL="0">
+            <a:pPr marL="0" indent="0">
               <a:buNone/>
             </a:pPr>
             <a:r>
@@ -8406,13 +8582,20 @@
           </a:solidFill>
           <a:ln/>
           <a:effectLst>
-            <a:outerShdw sx="100000" sy="100000" kx="0" ky="0" algn="bl" rotWithShape="0" blurRad="101600" dist="38100" dir="8100000">
+            <a:outerShdw blurRad="101600" dist="38100" dir="8100000" algn="bl" rotWithShape="0">
               <a:srgbClr val="000000">
                 <a:alpha val="12000"/>
               </a:srgbClr>
             </a:outerShdw>
           </a:effectLst>
         </p:spPr>
+        <p:txBody>
+          <a:bodyPr/>
+          <a:lstStyle/>
+          <a:p>
+            <a:endParaRPr lang="es-CL"/>
+          </a:p>
+        </p:txBody>
       </p:sp>
       <p:sp>
         <p:nvSpPr>
@@ -8433,6 +8616,13 @@
           </a:solidFill>
           <a:ln/>
         </p:spPr>
+        <p:txBody>
+          <a:bodyPr/>
+          <a:lstStyle/>
+          <a:p>
+            <a:endParaRPr lang="es-CL"/>
+          </a:p>
+        </p:txBody>
       </p:sp>
       <p:sp>
         <p:nvSpPr>
@@ -8455,7 +8645,7 @@
           <a:bodyPr wrap="square" lIns="0" tIns="0" rIns="0" bIns="0" rtlCol="0" anchor="ctr"/>
           <a:lstStyle/>
           <a:p>
-            <a:pPr algn="ctr" indent="0" marL="0">
+            <a:pPr marL="0" indent="0" algn="ctr">
               <a:buNone/>
             </a:pPr>
             <a:r>
@@ -8491,7 +8681,7 @@
           <a:bodyPr wrap="square" lIns="0" tIns="0" rIns="0" bIns="0" rtlCol="0" anchor="ctr"/>
           <a:lstStyle/>
           <a:p>
-            <a:pPr indent="0" marL="0">
+            <a:pPr marL="0" indent="0">
               <a:buNone/>
             </a:pPr>
             <a:r>
@@ -8530,7 +8720,7 @@
           <a:bodyPr wrap="square" lIns="0" tIns="0" rIns="0" bIns="0" rtlCol="0" anchor="ctr"/>
           <a:lstStyle/>
           <a:p>
-            <a:pPr indent="0" marL="0">
+            <a:pPr marL="0" indent="0">
               <a:buNone/>
             </a:pPr>
             <a:r>
@@ -8569,7 +8759,7 @@
           <a:bodyPr wrap="square" lIns="0" tIns="0" rIns="0" bIns="0" rtlCol="0" anchor="ctr"/>
           <a:lstStyle/>
           <a:p>
-            <a:pPr algn="ctr" indent="0" marL="0">
+            <a:pPr marL="0" indent="0" algn="ctr">
               <a:buNone/>
             </a:pPr>
             <a:r>
@@ -8581,7 +8771,7 @@
                 <a:ea typeface="Calibri" pitchFamily="34" charset="-122"/>
                 <a:cs typeface="Calibri" pitchFamily="34" charset="-120"/>
               </a:rPr>
-              <a:t>Trabajo futuro: autenticación JWT · más frutas · modo offline (TFLite) · tests E2E</a:t>
+              <a:t>Trabajo futuro: autenticación JWT · más frutas · tests E2E</a:t>
             </a:r>
             <a:endParaRPr lang="en-US" sz="1100" dirty="0"/>
           </a:p>
@@ -8888,4 +9078,319 @@
     </a:ext>
   </a:extLst>
 </a:theme>
+</file>
+
+<file path=ppt/theme/theme2.xml><?xml version="1.0" encoding="utf-8"?>
+<a:theme xmlns:a="http://schemas.openxmlformats.org/drawingml/2006/main" name="Tema de Office">
+  <a:themeElements>
+    <a:clrScheme name="Office">
+      <a:dk1>
+        <a:sysClr val="windowText" lastClr="000000"/>
+      </a:dk1>
+      <a:lt1>
+        <a:sysClr val="window" lastClr="FFFFFF"/>
+      </a:lt1>
+      <a:dk2>
+        <a:srgbClr val="0E2841"/>
+      </a:dk2>
+      <a:lt2>
+        <a:srgbClr val="E8E8E8"/>
+      </a:lt2>
+      <a:accent1>
+        <a:srgbClr val="156082"/>
+      </a:accent1>
+      <a:accent2>
+        <a:srgbClr val="E97132"/>
+      </a:accent2>
+      <a:accent3>
+        <a:srgbClr val="196B24"/>
+      </a:accent3>
+      <a:accent4>
+        <a:srgbClr val="0F9ED5"/>
+      </a:accent4>
+      <a:accent5>
+        <a:srgbClr val="A02B93"/>
+      </a:accent5>
+      <a:accent6>
+        <a:srgbClr val="4EA72E"/>
+      </a:accent6>
+      <a:hlink>
+        <a:srgbClr val="467886"/>
+      </a:hlink>
+      <a:folHlink>
+        <a:srgbClr val="96607D"/>
+      </a:folHlink>
+    </a:clrScheme>
+    <a:fontScheme name="Office">
+      <a:majorFont>
+        <a:latin typeface="Aptos Display" panose="02110004020202020204"/>
+        <a:ea typeface=""/>
+        <a:cs typeface=""/>
+        <a:font script="Jpan" typeface="游ゴシック Light"/>
+        <a:font script="Hang" typeface="맑은 고딕"/>
+        <a:font script="Hans" typeface="等线 Light"/>
+        <a:font script="Hant" typeface="新細明體"/>
+        <a:font script="Arab" typeface="Times New Roman"/>
+        <a:font script="Hebr" typeface="Times New Roman"/>
+        <a:font script="Thai" typeface="Angsana New"/>
+        <a:font script="Ethi" typeface="Nyala"/>
+        <a:font script="Beng" typeface="Vrinda"/>
+        <a:font script="Gujr" typeface="Shruti"/>
+        <a:font script="Khmr" typeface="MoolBoran"/>
+        <a:font script="Knda" typeface="Tunga"/>
+        <a:font script="Guru" typeface="Raavi"/>
+        <a:font script="Cans" typeface="Euphemia"/>
+        <a:font script="Cher" typeface="Plantagenet Cherokee"/>
+        <a:font script="Yiii" typeface="Microsoft Yi Baiti"/>
+        <a:font script="Tibt" typeface="Microsoft Himalaya"/>
+        <a:font script="Thaa" typeface="MV Boli"/>
+        <a:font script="Deva" typeface="Mangal"/>
+        <a:font script="Telu" typeface="Gautami"/>
+        <a:font script="Taml" typeface="Latha"/>
+        <a:font script="Syrc" typeface="Estrangelo Edessa"/>
+        <a:font script="Orya" typeface="Kalinga"/>
+        <a:font script="Mlym" typeface="Kartika"/>
+        <a:font script="Laoo" typeface="DokChampa"/>
+        <a:font script="Sinh" typeface="Iskoola Pota"/>
+        <a:font script="Mong" typeface="Mongolian Baiti"/>
+        <a:font script="Viet" typeface="Times New Roman"/>
+        <a:font script="Uigh" typeface="Microsoft Uighur"/>
+        <a:font script="Geor" typeface="Sylfaen"/>
+        <a:font script="Armn" typeface="Arial"/>
+        <a:font script="Bugi" typeface="Leelawadee UI"/>
+        <a:font script="Bopo" typeface="Microsoft JhengHei"/>
+        <a:font script="Java" typeface="Javanese Text"/>
+        <a:font script="Lisu" typeface="Segoe UI"/>
+        <a:font script="Mymr" typeface="Myanmar Text"/>
+        <a:font script="Nkoo" typeface="Ebrima"/>
+        <a:font script="Olck" typeface="Nirmala UI"/>
+        <a:font script="Osma" typeface="Ebrima"/>
+        <a:font script="Phag" typeface="Phagspa"/>
+        <a:font script="Syrn" typeface="Estrangelo Edessa"/>
+        <a:font script="Syrj" typeface="Estrangelo Edessa"/>
+        <a:font script="Syre" typeface="Estrangelo Edessa"/>
+        <a:font script="Sora" typeface="Nirmala UI"/>
+        <a:font script="Tale" typeface="Microsoft Tai Le"/>
+        <a:font script="Talu" typeface="Microsoft New Tai Lue"/>
+        <a:font script="Tfng" typeface="Ebrima"/>
+      </a:majorFont>
+      <a:minorFont>
+        <a:latin typeface="Aptos" panose="02110004020202020204"/>
+        <a:ea typeface=""/>
+        <a:cs typeface=""/>
+        <a:font script="Jpan" typeface="游ゴシック"/>
+        <a:font script="Hang" typeface="맑은 고딕"/>
+        <a:font script="Hans" typeface="等线"/>
+        <a:font script="Hant" typeface="新細明體"/>
+        <a:font script="Arab" typeface="Arial"/>
+        <a:font script="Hebr" typeface="Arial"/>
+        <a:font script="Thai" typeface="Cordia New"/>
+        <a:font script="Ethi" typeface="Nyala"/>
+        <a:font script="Beng" typeface="Vrinda"/>
+        <a:font script="Gujr" typeface="Shruti"/>
+        <a:font script="Khmr" typeface="DaunPenh"/>
+        <a:font script="Knda" typeface="Tunga"/>
+        <a:font script="Guru" typeface="Raavi"/>
+        <a:font script="Cans" typeface="Euphemia"/>
+        <a:font script="Cher" typeface="Plantagenet Cherokee"/>
+        <a:font script="Yiii" typeface="Microsoft Yi Baiti"/>
+        <a:font script="Tibt" typeface="Microsoft Himalaya"/>
+        <a:font script="Thaa" typeface="MV Boli"/>
+        <a:font script="Deva" typeface="Mangal"/>
+        <a:font script="Telu" typeface="Gautami"/>
+        <a:font script="Taml" typeface="Latha"/>
+        <a:font script="Syrc" typeface="Estrangelo Edessa"/>
+        <a:font script="Orya" typeface="Kalinga"/>
+        <a:font script="Mlym" typeface="Kartika"/>
+        <a:font script="Laoo" typeface="DokChampa"/>
+        <a:font script="Sinh" typeface="Iskoola Pota"/>
+        <a:font script="Mong" typeface="Mongolian Baiti"/>
+        <a:font script="Viet" typeface="Arial"/>
+        <a:font script="Uigh" typeface="Microsoft Uighur"/>
+        <a:font script="Geor" typeface="Sylfaen"/>
+        <a:font script="Armn" typeface="Arial"/>
+        <a:font script="Bugi" typeface="Leelawadee UI"/>
+        <a:font script="Bopo" typeface="Microsoft JhengHei"/>
+        <a:font script="Java" typeface="Javanese Text"/>
+        <a:font script="Lisu" typeface="Segoe UI"/>
+        <a:font script="Mymr" typeface="Myanmar Text"/>
+        <a:font script="Nkoo" typeface="Ebrima"/>
+        <a:font script="Olck" typeface="Nirmala UI"/>
+        <a:font script="Osma" typeface="Ebrima"/>
+        <a:font script="Phag" typeface="Phagspa"/>
+        <a:font script="Syrn" typeface="Estrangelo Edessa"/>
+        <a:font script="Syrj" typeface="Estrangelo Edessa"/>
+        <a:font script="Syre" typeface="Estrangelo Edessa"/>
+        <a:font script="Sora" typeface="Nirmala UI"/>
+        <a:font script="Tale" typeface="Microsoft Tai Le"/>
+        <a:font script="Talu" typeface="Microsoft New Tai Lue"/>
+        <a:font script="Tfng" typeface="Ebrima"/>
+      </a:minorFont>
+    </a:fontScheme>
+    <a:fmtScheme name="Office">
+      <a:fillStyleLst>
+        <a:solidFill>
+          <a:schemeClr val="phClr"/>
+        </a:solidFill>
+        <a:gradFill rotWithShape="1">
+          <a:gsLst>
+            <a:gs pos="0">
+              <a:schemeClr val="phClr">
+                <a:lumMod val="110000"/>
+                <a:satMod val="105000"/>
+                <a:tint val="67000"/>
+              </a:schemeClr>
+            </a:gs>
+            <a:gs pos="50000">
+              <a:schemeClr val="phClr">
+                <a:lumMod val="105000"/>
+                <a:satMod val="103000"/>
+                <a:tint val="73000"/>
+              </a:schemeClr>
+            </a:gs>
+            <a:gs pos="100000">
+              <a:schemeClr val="phClr">
+                <a:lumMod val="105000"/>
+                <a:satMod val="109000"/>
+                <a:tint val="81000"/>
+              </a:schemeClr>
+            </a:gs>
+          </a:gsLst>
+          <a:lin ang="5400000" scaled="0"/>
+        </a:gradFill>
+        <a:gradFill rotWithShape="1">
+          <a:gsLst>
+            <a:gs pos="0">
+              <a:schemeClr val="phClr">
+                <a:satMod val="103000"/>
+                <a:lumMod val="102000"/>
+                <a:tint val="94000"/>
+              </a:schemeClr>
+            </a:gs>
+            <a:gs pos="50000">
+              <a:schemeClr val="phClr">
+                <a:satMod val="110000"/>
+                <a:lumMod val="100000"/>
+                <a:shade val="100000"/>
+              </a:schemeClr>
+            </a:gs>
+            <a:gs pos="100000">
+              <a:schemeClr val="phClr">
+                <a:lumMod val="99000"/>
+                <a:satMod val="120000"/>
+                <a:shade val="78000"/>
+              </a:schemeClr>
+            </a:gs>
+          </a:gsLst>
+          <a:lin ang="5400000" scaled="0"/>
+        </a:gradFill>
+      </a:fillStyleLst>
+      <a:lnStyleLst>
+        <a:ln w="12700" cap="flat" cmpd="sng" algn="ctr">
+          <a:solidFill>
+            <a:schemeClr val="phClr"/>
+          </a:solidFill>
+          <a:prstDash val="solid"/>
+          <a:miter lim="800000"/>
+        </a:ln>
+        <a:ln w="19050" cap="flat" cmpd="sng" algn="ctr">
+          <a:solidFill>
+            <a:schemeClr val="phClr"/>
+          </a:solidFill>
+          <a:prstDash val="solid"/>
+          <a:miter lim="800000"/>
+        </a:ln>
+        <a:ln w="25400" cap="flat" cmpd="sng" algn="ctr">
+          <a:solidFill>
+            <a:schemeClr val="phClr"/>
+          </a:solidFill>
+          <a:prstDash val="solid"/>
+          <a:miter lim="800000"/>
+        </a:ln>
+      </a:lnStyleLst>
+      <a:effectStyleLst>
+        <a:effectStyle>
+          <a:effectLst/>
+        </a:effectStyle>
+        <a:effectStyle>
+          <a:effectLst/>
+        </a:effectStyle>
+        <a:effectStyle>
+          <a:effectLst>
+            <a:outerShdw blurRad="57150" dist="19050" dir="5400000" algn="ctr" rotWithShape="0">
+              <a:srgbClr val="000000">
+                <a:alpha val="63000"/>
+              </a:srgbClr>
+            </a:outerShdw>
+          </a:effectLst>
+        </a:effectStyle>
+      </a:effectStyleLst>
+      <a:bgFillStyleLst>
+        <a:solidFill>
+          <a:schemeClr val="phClr"/>
+        </a:solidFill>
+        <a:solidFill>
+          <a:schemeClr val="phClr">
+            <a:tint val="95000"/>
+            <a:satMod val="170000"/>
+          </a:schemeClr>
+        </a:solidFill>
+        <a:gradFill rotWithShape="1">
+          <a:gsLst>
+            <a:gs pos="0">
+              <a:schemeClr val="phClr">
+                <a:tint val="93000"/>
+                <a:satMod val="150000"/>
+                <a:shade val="98000"/>
+                <a:lumMod val="102000"/>
+              </a:schemeClr>
+            </a:gs>
+            <a:gs pos="50000">
+              <a:schemeClr val="phClr">
+                <a:tint val="98000"/>
+                <a:satMod val="130000"/>
+                <a:shade val="90000"/>
+                <a:lumMod val="103000"/>
+              </a:schemeClr>
+            </a:gs>
+            <a:gs pos="100000">
+              <a:schemeClr val="phClr">
+                <a:shade val="63000"/>
+                <a:satMod val="120000"/>
+              </a:schemeClr>
+            </a:gs>
+          </a:gsLst>
+          <a:lin ang="5400000" scaled="0"/>
+        </a:gradFill>
+      </a:bgFillStyleLst>
+    </a:fmtScheme>
+  </a:themeElements>
+  <a:objectDefaults>
+    <a:lnDef>
+      <a:spPr/>
+      <a:bodyPr/>
+      <a:lstStyle/>
+      <a:style>
+        <a:lnRef idx="2">
+          <a:schemeClr val="accent1"/>
+        </a:lnRef>
+        <a:fillRef idx="0">
+          <a:schemeClr val="accent1"/>
+        </a:fillRef>
+        <a:effectRef idx="1">
+          <a:schemeClr val="accent1"/>
+        </a:effectRef>
+        <a:fontRef idx="minor">
+          <a:schemeClr val="tx1"/>
+        </a:fontRef>
+      </a:style>
+    </a:lnDef>
+  </a:objectDefaults>
+  <a:extraClrSchemeLst/>
+  <a:extLst>
+    <a:ext uri="{05A4C25C-085E-4340-85A3-A5531E510DB2}">
+      <thm15:themeFamily xmlns:thm15="http://schemas.microsoft.com/office/thememl/2012/main" name="Office Theme" id="{2E142A2C-CD16-42D6-873A-C26D2A0506FA}" vid="{1BDDFF52-6CD6-40A5-AB3C-68EB2F1E4D0A}"/>
+    </a:ext>
+  </a:extLst>
+</a:theme>
 </file>
</xml_diff>

<commit_message>
docs(ev2): agregar informe con diagramas, PDF y PPT final
- Informe Word con 13 diagramas arquitectónicos insertados (modelo 4+1 Kruchten)
- PDF exportado desde el informe final
- PPT de presentación Evaluación 2 finalizado
- Passdown sesión 2026-05-27

Co-Authored-By: Claude Sonnet 4.6 <noreply@anthropic.com>
</commit_message>
<xml_diff>
--- a/Documentación/Evaluacion_2/MaduraApp_Presentacion_Evaluacion2.pptx
+++ b/Documentación/Evaluacion_2/MaduraApp_Presentacion_Evaluacion2.pptx
@@ -5,7 +5,7 @@
     <p:sldMasterId id="2147483648" r:id="rId1"/>
   </p:sldMasterIdLst>
   <p:notesMasterIdLst>
-    <p:notesMasterId r:id="rId11"/>
+    <p:notesMasterId r:id="rId13"/>
   </p:notesMasterIdLst>
   <p:sldIdLst>
     <p:sldId id="256" r:id="rId2"/>
@@ -13,10 +13,12 @@
     <p:sldId id="258" r:id="rId4"/>
     <p:sldId id="259" r:id="rId5"/>
     <p:sldId id="260" r:id="rId6"/>
-    <p:sldId id="261" r:id="rId7"/>
-    <p:sldId id="262" r:id="rId8"/>
-    <p:sldId id="263" r:id="rId9"/>
-    <p:sldId id="264" r:id="rId10"/>
+    <p:sldId id="265" r:id="rId7"/>
+    <p:sldId id="266" r:id="rId8"/>
+    <p:sldId id="261" r:id="rId9"/>
+    <p:sldId id="262" r:id="rId10"/>
+    <p:sldId id="263" r:id="rId11"/>
+    <p:sldId id="264" r:id="rId12"/>
   </p:sldIdLst>
   <p:sldSz cx="9144000" cy="5143500" type="screen16x9"/>
   <p:notesSz cx="5143500" cy="9144000"/>
@@ -730,7 +732,7 @@
           <a:p>
             <a:fld id="{F7021451-1387-4CA6-816F-3879F97B5CBC}" type="slidenum">
               <a:rPr lang="en-US"/>
-              <a:t>6</a:t>
+              <a:t>8</a:t>
             </a:fld>
             <a:endParaRPr lang="en-US"/>
           </a:p>
@@ -814,7 +816,7 @@
           <a:p>
             <a:fld id="{F7021451-1387-4CA6-816F-3879F97B5CBC}" type="slidenum">
               <a:rPr lang="en-US"/>
-              <a:t>7</a:t>
+              <a:t>9</a:t>
             </a:fld>
             <a:endParaRPr lang="en-US"/>
           </a:p>
@@ -898,7 +900,7 @@
           <a:p>
             <a:fld id="{F7021451-1387-4CA6-816F-3879F97B5CBC}" type="slidenum">
               <a:rPr lang="en-US"/>
-              <a:t>8</a:t>
+              <a:t>10</a:t>
             </a:fld>
             <a:endParaRPr lang="en-US"/>
           </a:p>
@@ -982,7 +984,7 @@
           <a:p>
             <a:fld id="{F7021451-1387-4CA6-816F-3879F97B5CBC}" type="slidenum">
               <a:rPr lang="en-US"/>
-              <a:t>9</a:t>
+              <a:t>11</a:t>
             </a:fld>
             <a:endParaRPr lang="en-US"/>
           </a:p>
@@ -1865,6 +1867,816 @@
 </p:sld>
 </file>
 
+<file path=ppt/slides/slide10.xml><?xml version="1.0" encoding="utf-8"?>
+<p:sld xmlns:a="http://schemas.openxmlformats.org/drawingml/2006/main" xmlns:r="http://schemas.openxmlformats.org/officeDocument/2006/relationships" xmlns:p="http://schemas.openxmlformats.org/presentationml/2006/main">
+  <p:cSld name="Slide 8">
+    <p:bg>
+      <p:bgPr>
+        <a:solidFill>
+          <a:srgbClr val="0F2318"/>
+        </a:solidFill>
+        <a:effectLst/>
+      </p:bgPr>
+    </p:bg>
+    <p:spTree>
+      <p:nvGrpSpPr>
+        <p:cNvPr id="1" name=""/>
+        <p:cNvGrpSpPr/>
+        <p:nvPr/>
+      </p:nvGrpSpPr>
+      <p:grpSpPr>
+        <a:xfrm>
+          <a:off x="0" y="0"/>
+          <a:ext cx="0" cy="0"/>
+          <a:chOff x="0" y="0"/>
+          <a:chExt cx="0" cy="0"/>
+        </a:xfrm>
+      </p:grpSpPr>
+      <p:sp>
+        <p:nvSpPr>
+          <p:cNvPr id="2" name="Text 0"/>
+          <p:cNvSpPr/>
+          <p:nvPr/>
+        </p:nvSpPr>
+        <p:spPr>
+          <a:xfrm>
+            <a:off x="0" y="548640"/>
+            <a:ext cx="9144000" cy="1828800"/>
+          </a:xfrm>
+          <a:prstGeom prst="rect">
+            <a:avLst/>
+          </a:prstGeom>
+          <a:noFill/>
+          <a:ln/>
+        </p:spPr>
+        <p:txBody>
+          <a:bodyPr wrap="square" lIns="0" tIns="0" rIns="0" bIns="0" rtlCol="0" anchor="ctr"/>
+          <a:lstStyle/>
+          <a:p>
+            <a:pPr marL="0" indent="0" algn="ctr">
+              <a:buNone/>
+            </a:pPr>
+            <a:r>
+              <a:rPr lang="en-US" sz="9000" dirty="0">
+                <a:solidFill>
+                  <a:srgbClr val="000000"/>
+                </a:solidFill>
+              </a:rPr>
+              <a:t>🎬</a:t>
+            </a:r>
+            <a:endParaRPr lang="en-US" sz="9000" dirty="0"/>
+          </a:p>
+        </p:txBody>
+      </p:sp>
+      <p:sp>
+        <p:nvSpPr>
+          <p:cNvPr id="3" name="Text 1"/>
+          <p:cNvSpPr/>
+          <p:nvPr/>
+        </p:nvSpPr>
+        <p:spPr>
+          <a:xfrm>
+            <a:off x="457200" y="2560320"/>
+            <a:ext cx="8229600" cy="1005840"/>
+          </a:xfrm>
+          <a:prstGeom prst="rect">
+            <a:avLst/>
+          </a:prstGeom>
+          <a:noFill/>
+          <a:ln/>
+        </p:spPr>
+        <p:txBody>
+          <a:bodyPr wrap="square" lIns="0" tIns="0" rIns="0" bIns="0" rtlCol="0" anchor="ctr"/>
+          <a:lstStyle/>
+          <a:p>
+            <a:pPr marL="0" indent="0" algn="ctr">
+              <a:buNone/>
+            </a:pPr>
+            <a:r>
+              <a:rPr lang="en-US" sz="5400" b="1" kern="0" spc="400" dirty="0">
+                <a:solidFill>
+                  <a:srgbClr val="FFFFFF"/>
+                </a:solidFill>
+                <a:latin typeface="Calibri" pitchFamily="34" charset="0"/>
+                <a:ea typeface="Calibri" pitchFamily="34" charset="-122"/>
+                <a:cs typeface="Calibri" pitchFamily="34" charset="-120"/>
+              </a:rPr>
+              <a:t>Demo en vivo</a:t>
+            </a:r>
+            <a:endParaRPr lang="en-US" sz="5400" dirty="0"/>
+          </a:p>
+        </p:txBody>
+      </p:sp>
+      <p:sp>
+        <p:nvSpPr>
+          <p:cNvPr id="4" name="Text 2"/>
+          <p:cNvSpPr/>
+          <p:nvPr/>
+        </p:nvSpPr>
+        <p:spPr>
+          <a:xfrm>
+            <a:off x="457200" y="3611880"/>
+            <a:ext cx="8229600" cy="457200"/>
+          </a:xfrm>
+          <a:prstGeom prst="rect">
+            <a:avLst/>
+          </a:prstGeom>
+          <a:noFill/>
+          <a:ln/>
+        </p:spPr>
+        <p:txBody>
+          <a:bodyPr wrap="square" lIns="0" tIns="0" rIns="0" bIns="0" rtlCol="0" anchor="ctr"/>
+          <a:lstStyle/>
+          <a:p>
+            <a:pPr marL="0" indent="0" algn="ctr">
+              <a:buNone/>
+            </a:pPr>
+            <a:r>
+              <a:rPr lang="en-US" sz="1600" dirty="0">
+                <a:solidFill>
+                  <a:srgbClr val="4CAF50"/>
+                </a:solidFill>
+                <a:latin typeface="Calibri" pitchFamily="34" charset="0"/>
+                <a:ea typeface="Calibri" pitchFamily="34" charset="-122"/>
+                <a:cs typeface="Calibri" pitchFamily="34" charset="-120"/>
+              </a:rPr>
+              <a:t>Escaneo de fruta  ·  Historial  ·  Tests</a:t>
+            </a:r>
+            <a:endParaRPr lang="en-US" sz="1600" dirty="0"/>
+          </a:p>
+        </p:txBody>
+      </p:sp>
+    </p:spTree>
+  </p:cSld>
+  <p:clrMapOvr>
+    <a:masterClrMapping/>
+  </p:clrMapOvr>
+</p:sld>
+</file>
+
+<file path=ppt/slides/slide11.xml><?xml version="1.0" encoding="utf-8"?>
+<p:sld xmlns:a="http://schemas.openxmlformats.org/drawingml/2006/main" xmlns:r="http://schemas.openxmlformats.org/officeDocument/2006/relationships" xmlns:p="http://schemas.openxmlformats.org/presentationml/2006/main">
+  <p:cSld name="Slide 9">
+    <p:bg>
+      <p:bgPr>
+        <a:solidFill>
+          <a:srgbClr val="0F2318"/>
+        </a:solidFill>
+        <a:effectLst/>
+      </p:bgPr>
+    </p:bg>
+    <p:spTree>
+      <p:nvGrpSpPr>
+        <p:cNvPr id="1" name=""/>
+        <p:cNvGrpSpPr/>
+        <p:nvPr/>
+      </p:nvGrpSpPr>
+      <p:grpSpPr>
+        <a:xfrm>
+          <a:off x="0" y="0"/>
+          <a:ext cx="0" cy="0"/>
+          <a:chOff x="0" y="0"/>
+          <a:chExt cx="0" cy="0"/>
+        </a:xfrm>
+      </p:grpSpPr>
+      <p:sp>
+        <p:nvSpPr>
+          <p:cNvPr id="2" name="Text 0"/>
+          <p:cNvSpPr/>
+          <p:nvPr/>
+        </p:nvSpPr>
+        <p:spPr>
+          <a:xfrm>
+            <a:off x="457200" y="256032"/>
+            <a:ext cx="8229600" cy="594360"/>
+          </a:xfrm>
+          <a:prstGeom prst="rect">
+            <a:avLst/>
+          </a:prstGeom>
+          <a:noFill/>
+          <a:ln/>
+        </p:spPr>
+        <p:txBody>
+          <a:bodyPr wrap="square" lIns="0" tIns="0" rIns="0" bIns="0" rtlCol="0" anchor="ctr"/>
+          <a:lstStyle/>
+          <a:p>
+            <a:pPr marL="0" indent="0" algn="l">
+              <a:buNone/>
+            </a:pPr>
+            <a:r>
+              <a:rPr lang="en-US" sz="2800" b="1" dirty="0">
+                <a:solidFill>
+                  <a:srgbClr val="FFFFFF"/>
+                </a:solidFill>
+                <a:latin typeface="Calibri" pitchFamily="34" charset="0"/>
+                <a:ea typeface="Calibri" pitchFamily="34" charset="-122"/>
+                <a:cs typeface="Calibri" pitchFamily="34" charset="-120"/>
+              </a:rPr>
+              <a:t>Conclusiones</a:t>
+            </a:r>
+            <a:endParaRPr lang="en-US" sz="2800" dirty="0"/>
+          </a:p>
+        </p:txBody>
+      </p:sp>
+      <p:sp>
+        <p:nvSpPr>
+          <p:cNvPr id="3" name="Shape 1"/>
+          <p:cNvSpPr/>
+          <p:nvPr/>
+        </p:nvSpPr>
+        <p:spPr>
+          <a:xfrm>
+            <a:off x="457200" y="896112"/>
+            <a:ext cx="914400" cy="54864"/>
+          </a:xfrm>
+          <a:prstGeom prst="rect">
+            <a:avLst/>
+          </a:prstGeom>
+          <a:solidFill>
+            <a:srgbClr val="4CAF50"/>
+          </a:solidFill>
+          <a:ln/>
+        </p:spPr>
+        <p:txBody>
+          <a:bodyPr/>
+          <a:lstStyle/>
+          <a:p>
+            <a:endParaRPr lang="es-CL"/>
+          </a:p>
+        </p:txBody>
+      </p:sp>
+      <p:sp>
+        <p:nvSpPr>
+          <p:cNvPr id="4" name="Shape 2"/>
+          <p:cNvSpPr/>
+          <p:nvPr/>
+        </p:nvSpPr>
+        <p:spPr>
+          <a:xfrm>
+            <a:off x="457200" y="1097280"/>
+            <a:ext cx="8229600" cy="1078992"/>
+          </a:xfrm>
+          <a:prstGeom prst="rect">
+            <a:avLst/>
+          </a:prstGeom>
+          <a:solidFill>
+            <a:srgbClr val="1B3A24"/>
+          </a:solidFill>
+          <a:ln/>
+          <a:effectLst>
+            <a:outerShdw blurRad="101600" dist="38100" dir="8100000" algn="bl" rotWithShape="0">
+              <a:srgbClr val="000000">
+                <a:alpha val="12000"/>
+              </a:srgbClr>
+            </a:outerShdw>
+          </a:effectLst>
+        </p:spPr>
+        <p:txBody>
+          <a:bodyPr/>
+          <a:lstStyle/>
+          <a:p>
+            <a:endParaRPr lang="es-CL"/>
+          </a:p>
+        </p:txBody>
+      </p:sp>
+      <p:sp>
+        <p:nvSpPr>
+          <p:cNvPr id="5" name="Shape 3"/>
+          <p:cNvSpPr/>
+          <p:nvPr/>
+        </p:nvSpPr>
+        <p:spPr>
+          <a:xfrm>
+            <a:off x="457200" y="1097280"/>
+            <a:ext cx="502920" cy="1078992"/>
+          </a:xfrm>
+          <a:prstGeom prst="rect">
+            <a:avLst/>
+          </a:prstGeom>
+          <a:solidFill>
+            <a:srgbClr val="4CAF50"/>
+          </a:solidFill>
+          <a:ln/>
+        </p:spPr>
+        <p:txBody>
+          <a:bodyPr/>
+          <a:lstStyle/>
+          <a:p>
+            <a:endParaRPr lang="es-CL"/>
+          </a:p>
+        </p:txBody>
+      </p:sp>
+      <p:sp>
+        <p:nvSpPr>
+          <p:cNvPr id="6" name="Text 4"/>
+          <p:cNvSpPr/>
+          <p:nvPr/>
+        </p:nvSpPr>
+        <p:spPr>
+          <a:xfrm>
+            <a:off x="457200" y="1097280"/>
+            <a:ext cx="502920" cy="1078992"/>
+          </a:xfrm>
+          <a:prstGeom prst="rect">
+            <a:avLst/>
+          </a:prstGeom>
+          <a:noFill/>
+          <a:ln/>
+        </p:spPr>
+        <p:txBody>
+          <a:bodyPr wrap="square" lIns="0" tIns="0" rIns="0" bIns="0" rtlCol="0" anchor="ctr"/>
+          <a:lstStyle/>
+          <a:p>
+            <a:pPr marL="0" indent="0" algn="ctr">
+              <a:buNone/>
+            </a:pPr>
+            <a:r>
+              <a:rPr lang="en-US" sz="2200" dirty="0">
+                <a:solidFill>
+                  <a:srgbClr val="000000"/>
+                </a:solidFill>
+              </a:rPr>
+              <a:t>✅</a:t>
+            </a:r>
+            <a:endParaRPr lang="en-US" sz="2200" dirty="0"/>
+          </a:p>
+        </p:txBody>
+      </p:sp>
+      <p:sp>
+        <p:nvSpPr>
+          <p:cNvPr id="7" name="Text 5"/>
+          <p:cNvSpPr/>
+          <p:nvPr/>
+        </p:nvSpPr>
+        <p:spPr>
+          <a:xfrm>
+            <a:off x="1051560" y="1188720"/>
+            <a:ext cx="7498080" cy="365760"/>
+          </a:xfrm>
+          <a:prstGeom prst="rect">
+            <a:avLst/>
+          </a:prstGeom>
+          <a:noFill/>
+          <a:ln/>
+        </p:spPr>
+        <p:txBody>
+          <a:bodyPr wrap="square" lIns="0" tIns="0" rIns="0" bIns="0" rtlCol="0" anchor="ctr"/>
+          <a:lstStyle/>
+          <a:p>
+            <a:pPr marL="0" indent="0">
+              <a:buNone/>
+            </a:pPr>
+            <a:r>
+              <a:rPr lang="en-US" sz="1600" b="1" dirty="0">
+                <a:solidFill>
+                  <a:srgbClr val="FFFFFF"/>
+                </a:solidFill>
+                <a:latin typeface="Calibri" pitchFamily="34" charset="0"/>
+                <a:ea typeface="Calibri" pitchFamily="34" charset="-122"/>
+                <a:cs typeface="Calibri" pitchFamily="34" charset="-120"/>
+              </a:rPr>
+              <a:t>KPI cumplido</a:t>
+            </a:r>
+            <a:endParaRPr lang="en-US" sz="1600" dirty="0"/>
+          </a:p>
+        </p:txBody>
+      </p:sp>
+      <p:sp>
+        <p:nvSpPr>
+          <p:cNvPr id="8" name="Text 6"/>
+          <p:cNvSpPr/>
+          <p:nvPr/>
+        </p:nvSpPr>
+        <p:spPr>
+          <a:xfrm>
+            <a:off x="1051560" y="1572768"/>
+            <a:ext cx="7498080" cy="438912"/>
+          </a:xfrm>
+          <a:prstGeom prst="rect">
+            <a:avLst/>
+          </a:prstGeom>
+          <a:noFill/>
+          <a:ln/>
+        </p:spPr>
+        <p:txBody>
+          <a:bodyPr wrap="square" lIns="0" tIns="0" rIns="0" bIns="0" rtlCol="0" anchor="ctr"/>
+          <a:lstStyle/>
+          <a:p>
+            <a:pPr marL="0" indent="0">
+              <a:buNone/>
+            </a:pPr>
+            <a:r>
+              <a:rPr lang="en-US" sz="1300" dirty="0">
+                <a:solidFill>
+                  <a:srgbClr val="C8E6C9"/>
+                </a:solidFill>
+                <a:latin typeface="Calibri" pitchFamily="34" charset="0"/>
+                <a:ea typeface="Calibri" pitchFamily="34" charset="-122"/>
+                <a:cs typeface="Calibri" pitchFamily="34" charset="-120"/>
+              </a:rPr>
+              <a:t>mAP@50 = 0.9229 supera el umbral de 0.75 exigido por +17.3 puntos</a:t>
+            </a:r>
+            <a:endParaRPr lang="en-US" sz="1300" dirty="0"/>
+          </a:p>
+        </p:txBody>
+      </p:sp>
+      <p:sp>
+        <p:nvSpPr>
+          <p:cNvPr id="9" name="Shape 7"/>
+          <p:cNvSpPr/>
+          <p:nvPr/>
+        </p:nvSpPr>
+        <p:spPr>
+          <a:xfrm>
+            <a:off x="457200" y="2359152"/>
+            <a:ext cx="8229600" cy="1078992"/>
+          </a:xfrm>
+          <a:prstGeom prst="rect">
+            <a:avLst/>
+          </a:prstGeom>
+          <a:solidFill>
+            <a:srgbClr val="1B3A24"/>
+          </a:solidFill>
+          <a:ln/>
+          <a:effectLst>
+            <a:outerShdw blurRad="101600" dist="38100" dir="8100000" algn="bl" rotWithShape="0">
+              <a:srgbClr val="000000">
+                <a:alpha val="12000"/>
+              </a:srgbClr>
+            </a:outerShdw>
+          </a:effectLst>
+        </p:spPr>
+        <p:txBody>
+          <a:bodyPr/>
+          <a:lstStyle/>
+          <a:p>
+            <a:endParaRPr lang="es-CL"/>
+          </a:p>
+        </p:txBody>
+      </p:sp>
+      <p:sp>
+        <p:nvSpPr>
+          <p:cNvPr id="10" name="Shape 8"/>
+          <p:cNvSpPr/>
+          <p:nvPr/>
+        </p:nvSpPr>
+        <p:spPr>
+          <a:xfrm>
+            <a:off x="457200" y="2359152"/>
+            <a:ext cx="502920" cy="1078992"/>
+          </a:xfrm>
+          <a:prstGeom prst="rect">
+            <a:avLst/>
+          </a:prstGeom>
+          <a:solidFill>
+            <a:srgbClr val="42A5F5"/>
+          </a:solidFill>
+          <a:ln/>
+        </p:spPr>
+        <p:txBody>
+          <a:bodyPr/>
+          <a:lstStyle/>
+          <a:p>
+            <a:endParaRPr lang="es-CL"/>
+          </a:p>
+        </p:txBody>
+      </p:sp>
+      <p:sp>
+        <p:nvSpPr>
+          <p:cNvPr id="11" name="Text 9"/>
+          <p:cNvSpPr/>
+          <p:nvPr/>
+        </p:nvSpPr>
+        <p:spPr>
+          <a:xfrm>
+            <a:off x="457200" y="2359152"/>
+            <a:ext cx="502920" cy="1078992"/>
+          </a:xfrm>
+          <a:prstGeom prst="rect">
+            <a:avLst/>
+          </a:prstGeom>
+          <a:noFill/>
+          <a:ln/>
+        </p:spPr>
+        <p:txBody>
+          <a:bodyPr wrap="square" lIns="0" tIns="0" rIns="0" bIns="0" rtlCol="0" anchor="ctr"/>
+          <a:lstStyle/>
+          <a:p>
+            <a:pPr marL="0" indent="0" algn="ctr">
+              <a:buNone/>
+            </a:pPr>
+            <a:r>
+              <a:rPr lang="en-US" sz="2200" dirty="0">
+                <a:solidFill>
+                  <a:srgbClr val="000000"/>
+                </a:solidFill>
+              </a:rPr>
+              <a:t>🏗</a:t>
+            </a:r>
+            <a:endParaRPr lang="en-US" sz="2200" dirty="0"/>
+          </a:p>
+        </p:txBody>
+      </p:sp>
+      <p:sp>
+        <p:nvSpPr>
+          <p:cNvPr id="12" name="Text 10"/>
+          <p:cNvSpPr/>
+          <p:nvPr/>
+        </p:nvSpPr>
+        <p:spPr>
+          <a:xfrm>
+            <a:off x="1051560" y="2450592"/>
+            <a:ext cx="7498080" cy="365760"/>
+          </a:xfrm>
+          <a:prstGeom prst="rect">
+            <a:avLst/>
+          </a:prstGeom>
+          <a:noFill/>
+          <a:ln/>
+        </p:spPr>
+        <p:txBody>
+          <a:bodyPr wrap="square" lIns="0" tIns="0" rIns="0" bIns="0" rtlCol="0" anchor="ctr"/>
+          <a:lstStyle/>
+          <a:p>
+            <a:pPr marL="0" indent="0">
+              <a:buNone/>
+            </a:pPr>
+            <a:r>
+              <a:rPr lang="en-US" sz="1600" b="1" dirty="0">
+                <a:solidFill>
+                  <a:srgbClr val="FFFFFF"/>
+                </a:solidFill>
+                <a:latin typeface="Calibri" pitchFamily="34" charset="0"/>
+                <a:ea typeface="Calibri" pitchFamily="34" charset="-122"/>
+                <a:cs typeface="Calibri" pitchFamily="34" charset="-120"/>
+              </a:rPr>
+              <a:t>Arquitectura bien fundamentada</a:t>
+            </a:r>
+            <a:endParaRPr lang="en-US" sz="1600" dirty="0"/>
+          </a:p>
+        </p:txBody>
+      </p:sp>
+      <p:sp>
+        <p:nvSpPr>
+          <p:cNvPr id="13" name="Text 11"/>
+          <p:cNvSpPr/>
+          <p:nvPr/>
+        </p:nvSpPr>
+        <p:spPr>
+          <a:xfrm>
+            <a:off x="1051560" y="2834640"/>
+            <a:ext cx="7498080" cy="438912"/>
+          </a:xfrm>
+          <a:prstGeom prst="rect">
+            <a:avLst/>
+          </a:prstGeom>
+          <a:noFill/>
+          <a:ln/>
+        </p:spPr>
+        <p:txBody>
+          <a:bodyPr wrap="square" lIns="0" tIns="0" rIns="0" bIns="0" rtlCol="0" anchor="ctr"/>
+          <a:lstStyle/>
+          <a:p>
+            <a:pPr marL="0" indent="0">
+              <a:buNone/>
+            </a:pPr>
+            <a:r>
+              <a:rPr lang="en-US" sz="1300" dirty="0">
+                <a:solidFill>
+                  <a:srgbClr val="C8E6C9"/>
+                </a:solidFill>
+                <a:latin typeface="Calibri" pitchFamily="34" charset="0"/>
+                <a:ea typeface="Calibri" pitchFamily="34" charset="-122"/>
+                <a:cs typeface="Calibri" pitchFamily="34" charset="-120"/>
+              </a:rPr>
+              <a:t>Modelo 4+1 de Kruchten aplicado con las 5 vistas documentadas y trazadas a casos de uso reales</a:t>
+            </a:r>
+            <a:endParaRPr lang="en-US" sz="1300" dirty="0"/>
+          </a:p>
+        </p:txBody>
+      </p:sp>
+      <p:sp>
+        <p:nvSpPr>
+          <p:cNvPr id="14" name="Shape 12"/>
+          <p:cNvSpPr/>
+          <p:nvPr/>
+        </p:nvSpPr>
+        <p:spPr>
+          <a:xfrm>
+            <a:off x="457200" y="3621024"/>
+            <a:ext cx="8229600" cy="1078992"/>
+          </a:xfrm>
+          <a:prstGeom prst="rect">
+            <a:avLst/>
+          </a:prstGeom>
+          <a:solidFill>
+            <a:srgbClr val="1B3A24"/>
+          </a:solidFill>
+          <a:ln/>
+          <a:effectLst>
+            <a:outerShdw blurRad="101600" dist="38100" dir="8100000" algn="bl" rotWithShape="0">
+              <a:srgbClr val="000000">
+                <a:alpha val="12000"/>
+              </a:srgbClr>
+            </a:outerShdw>
+          </a:effectLst>
+        </p:spPr>
+        <p:txBody>
+          <a:bodyPr/>
+          <a:lstStyle/>
+          <a:p>
+            <a:endParaRPr lang="es-CL"/>
+          </a:p>
+        </p:txBody>
+      </p:sp>
+      <p:sp>
+        <p:nvSpPr>
+          <p:cNvPr id="15" name="Shape 13"/>
+          <p:cNvSpPr/>
+          <p:nvPr/>
+        </p:nvSpPr>
+        <p:spPr>
+          <a:xfrm>
+            <a:off x="457200" y="3621024"/>
+            <a:ext cx="502920" cy="1078992"/>
+          </a:xfrm>
+          <a:prstGeom prst="rect">
+            <a:avLst/>
+          </a:prstGeom>
+          <a:solidFill>
+            <a:srgbClr val="AB47BC"/>
+          </a:solidFill>
+          <a:ln/>
+        </p:spPr>
+        <p:txBody>
+          <a:bodyPr/>
+          <a:lstStyle/>
+          <a:p>
+            <a:endParaRPr lang="es-CL"/>
+          </a:p>
+        </p:txBody>
+      </p:sp>
+      <p:sp>
+        <p:nvSpPr>
+          <p:cNvPr id="16" name="Text 14"/>
+          <p:cNvSpPr/>
+          <p:nvPr/>
+        </p:nvSpPr>
+        <p:spPr>
+          <a:xfrm>
+            <a:off x="457200" y="3621024"/>
+            <a:ext cx="502920" cy="1078992"/>
+          </a:xfrm>
+          <a:prstGeom prst="rect">
+            <a:avLst/>
+          </a:prstGeom>
+          <a:noFill/>
+          <a:ln/>
+        </p:spPr>
+        <p:txBody>
+          <a:bodyPr wrap="square" lIns="0" tIns="0" rIns="0" bIns="0" rtlCol="0" anchor="ctr"/>
+          <a:lstStyle/>
+          <a:p>
+            <a:pPr marL="0" indent="0" algn="ctr">
+              <a:buNone/>
+            </a:pPr>
+            <a:r>
+              <a:rPr lang="en-US" sz="2200" dirty="0">
+                <a:solidFill>
+                  <a:srgbClr val="000000"/>
+                </a:solidFill>
+              </a:rPr>
+              <a:t>🚀</a:t>
+            </a:r>
+            <a:endParaRPr lang="en-US" sz="2200" dirty="0"/>
+          </a:p>
+        </p:txBody>
+      </p:sp>
+      <p:sp>
+        <p:nvSpPr>
+          <p:cNvPr id="17" name="Text 15"/>
+          <p:cNvSpPr/>
+          <p:nvPr/>
+        </p:nvSpPr>
+        <p:spPr>
+          <a:xfrm>
+            <a:off x="1051560" y="3712464"/>
+            <a:ext cx="7498080" cy="365760"/>
+          </a:xfrm>
+          <a:prstGeom prst="rect">
+            <a:avLst/>
+          </a:prstGeom>
+          <a:noFill/>
+          <a:ln/>
+        </p:spPr>
+        <p:txBody>
+          <a:bodyPr wrap="square" lIns="0" tIns="0" rIns="0" bIns="0" rtlCol="0" anchor="ctr"/>
+          <a:lstStyle/>
+          <a:p>
+            <a:pPr marL="0" indent="0">
+              <a:buNone/>
+            </a:pPr>
+            <a:r>
+              <a:rPr lang="en-US" sz="1600" b="1" dirty="0">
+                <a:solidFill>
+                  <a:srgbClr val="FFFFFF"/>
+                </a:solidFill>
+                <a:latin typeface="Calibri" pitchFamily="34" charset="0"/>
+                <a:ea typeface="Calibri" pitchFamily="34" charset="-122"/>
+                <a:cs typeface="Calibri" pitchFamily="34" charset="-120"/>
+              </a:rPr>
+              <a:t>Producto funcional</a:t>
+            </a:r>
+            <a:endParaRPr lang="en-US" sz="1600" dirty="0"/>
+          </a:p>
+        </p:txBody>
+      </p:sp>
+      <p:sp>
+        <p:nvSpPr>
+          <p:cNvPr id="18" name="Text 16"/>
+          <p:cNvSpPr/>
+          <p:nvPr/>
+        </p:nvSpPr>
+        <p:spPr>
+          <a:xfrm>
+            <a:off x="1051560" y="4096512"/>
+            <a:ext cx="7498080" cy="438912"/>
+          </a:xfrm>
+          <a:prstGeom prst="rect">
+            <a:avLst/>
+          </a:prstGeom>
+          <a:noFill/>
+          <a:ln/>
+        </p:spPr>
+        <p:txBody>
+          <a:bodyPr wrap="square" lIns="0" tIns="0" rIns="0" bIns="0" rtlCol="0" anchor="ctr"/>
+          <a:lstStyle/>
+          <a:p>
+            <a:pPr marL="0" indent="0">
+              <a:buNone/>
+            </a:pPr>
+            <a:r>
+              <a:rPr lang="en-US" sz="1300" dirty="0">
+                <a:solidFill>
+                  <a:srgbClr val="C8E6C9"/>
+                </a:solidFill>
+                <a:latin typeface="Calibri" pitchFamily="34" charset="0"/>
+                <a:ea typeface="Calibri" pitchFamily="34" charset="-122"/>
+                <a:cs typeface="Calibri" pitchFamily="34" charset="-120"/>
+              </a:rPr>
+              <a:t>12/12 requerimientos implementados, desplegado en Render con CI verde en cada commit</a:t>
+            </a:r>
+            <a:endParaRPr lang="en-US" sz="1300" dirty="0"/>
+          </a:p>
+        </p:txBody>
+      </p:sp>
+      <p:sp>
+        <p:nvSpPr>
+          <p:cNvPr id="19" name="Text 17"/>
+          <p:cNvSpPr/>
+          <p:nvPr/>
+        </p:nvSpPr>
+        <p:spPr>
+          <a:xfrm>
+            <a:off x="457200" y="4754880"/>
+            <a:ext cx="8229600" cy="256032"/>
+          </a:xfrm>
+          <a:prstGeom prst="rect">
+            <a:avLst/>
+          </a:prstGeom>
+          <a:noFill/>
+          <a:ln/>
+        </p:spPr>
+        <p:txBody>
+          <a:bodyPr wrap="square" lIns="0" tIns="0" rIns="0" bIns="0" rtlCol="0" anchor="ctr"/>
+          <a:lstStyle/>
+          <a:p>
+            <a:pPr marL="0" indent="0" algn="ctr">
+              <a:buNone/>
+            </a:pPr>
+            <a:r>
+              <a:rPr lang="en-US" sz="1100" i="1" dirty="0">
+                <a:solidFill>
+                  <a:srgbClr val="718096"/>
+                </a:solidFill>
+                <a:latin typeface="Calibri" pitchFamily="34" charset="0"/>
+                <a:ea typeface="Calibri" pitchFamily="34" charset="-122"/>
+                <a:cs typeface="Calibri" pitchFamily="34" charset="-120"/>
+              </a:rPr>
+              <a:t>Trabajo futuro: autenticación JWT · más frutas · tests E2E</a:t>
+            </a:r>
+            <a:endParaRPr lang="en-US" sz="1100" dirty="0"/>
+          </a:p>
+        </p:txBody>
+      </p:sp>
+    </p:spTree>
+  </p:cSld>
+  <p:clrMapOvr>
+    <a:masterClrMapping/>
+  </p:clrMapOvr>
+</p:sld>
+</file>
+
 <file path=ppt/slides/slide2.xml><?xml version="1.0" encoding="utf-8"?>
 <p:sld xmlns:a="http://schemas.openxmlformats.org/drawingml/2006/main" xmlns:r="http://schemas.openxmlformats.org/officeDocument/2006/relationships" xmlns:p="http://schemas.openxmlformats.org/presentationml/2006/main">
   <p:cSld name="Slide 2">
@@ -5859,6 +6671,126 @@
 
 <file path=ppt/slides/slide6.xml><?xml version="1.0" encoding="utf-8"?>
 <p:sld xmlns:a="http://schemas.openxmlformats.org/drawingml/2006/main" xmlns:r="http://schemas.openxmlformats.org/officeDocument/2006/relationships" xmlns:p="http://schemas.openxmlformats.org/presentationml/2006/main">
+  <p:cSld>
+    <p:spTree>
+      <p:nvGrpSpPr>
+        <p:cNvPr id="1" name=""/>
+        <p:cNvGrpSpPr/>
+        <p:nvPr/>
+      </p:nvGrpSpPr>
+      <p:grpSpPr>
+        <a:xfrm>
+          <a:off x="0" y="0"/>
+          <a:ext cx="0" cy="0"/>
+          <a:chOff x="0" y="0"/>
+          <a:chExt cx="0" cy="0"/>
+        </a:xfrm>
+      </p:grpSpPr>
+      <p:pic>
+        <p:nvPicPr>
+          <p:cNvPr id="5" name="Imagen 4">
+            <a:extLst>
+              <a:ext uri="{FF2B5EF4-FFF2-40B4-BE49-F238E27FC236}">
+                <a16:creationId xmlns:a16="http://schemas.microsoft.com/office/drawing/2014/main" id="{3CE57D68-6BA2-9B35-99AA-50135A75A519}"/>
+              </a:ext>
+            </a:extLst>
+          </p:cNvPr>
+          <p:cNvPicPr>
+            <a:picLocks noChangeAspect="1"/>
+          </p:cNvPicPr>
+          <p:nvPr/>
+        </p:nvPicPr>
+        <p:blipFill>
+          <a:blip r:embed="rId2"/>
+          <a:stretch>
+            <a:fillRect/>
+          </a:stretch>
+        </p:blipFill>
+        <p:spPr>
+          <a:xfrm>
+            <a:off x="1677104" y="0"/>
+            <a:ext cx="5789792" cy="5143500"/>
+          </a:xfrm>
+          <a:prstGeom prst="rect">
+            <a:avLst/>
+          </a:prstGeom>
+        </p:spPr>
+      </p:pic>
+    </p:spTree>
+    <p:extLst>
+      <p:ext uri="{BB962C8B-B14F-4D97-AF65-F5344CB8AC3E}">
+        <p14:creationId xmlns:p14="http://schemas.microsoft.com/office/powerpoint/2010/main" val="1501553125"/>
+      </p:ext>
+    </p:extLst>
+  </p:cSld>
+  <p:clrMapOvr>
+    <a:masterClrMapping/>
+  </p:clrMapOvr>
+</p:sld>
+</file>
+
+<file path=ppt/slides/slide7.xml><?xml version="1.0" encoding="utf-8"?>
+<p:sld xmlns:a="http://schemas.openxmlformats.org/drawingml/2006/main" xmlns:r="http://schemas.openxmlformats.org/officeDocument/2006/relationships" xmlns:p="http://schemas.openxmlformats.org/presentationml/2006/main">
+  <p:cSld>
+    <p:spTree>
+      <p:nvGrpSpPr>
+        <p:cNvPr id="1" name=""/>
+        <p:cNvGrpSpPr/>
+        <p:nvPr/>
+      </p:nvGrpSpPr>
+      <p:grpSpPr>
+        <a:xfrm>
+          <a:off x="0" y="0"/>
+          <a:ext cx="0" cy="0"/>
+          <a:chOff x="0" y="0"/>
+          <a:chExt cx="0" cy="0"/>
+        </a:xfrm>
+      </p:grpSpPr>
+      <p:pic>
+        <p:nvPicPr>
+          <p:cNvPr id="3" name="Imagen 2">
+            <a:extLst>
+              <a:ext uri="{FF2B5EF4-FFF2-40B4-BE49-F238E27FC236}">
+                <a16:creationId xmlns:a16="http://schemas.microsoft.com/office/drawing/2014/main" id="{1A516479-6CE0-D46C-A130-AE8DB326717A}"/>
+              </a:ext>
+            </a:extLst>
+          </p:cNvPr>
+          <p:cNvPicPr>
+            <a:picLocks noChangeAspect="1"/>
+          </p:cNvPicPr>
+          <p:nvPr/>
+        </p:nvPicPr>
+        <p:blipFill>
+          <a:blip r:embed="rId2"/>
+          <a:stretch>
+            <a:fillRect/>
+          </a:stretch>
+        </p:blipFill>
+        <p:spPr>
+          <a:xfrm>
+            <a:off x="2405156" y="0"/>
+            <a:ext cx="4333687" cy="5143500"/>
+          </a:xfrm>
+          <a:prstGeom prst="rect">
+            <a:avLst/>
+          </a:prstGeom>
+        </p:spPr>
+      </p:pic>
+    </p:spTree>
+    <p:extLst>
+      <p:ext uri="{BB962C8B-B14F-4D97-AF65-F5344CB8AC3E}">
+        <p14:creationId xmlns:p14="http://schemas.microsoft.com/office/powerpoint/2010/main" val="1544652275"/>
+      </p:ext>
+    </p:extLst>
+  </p:cSld>
+  <p:clrMapOvr>
+    <a:masterClrMapping/>
+  </p:clrMapOvr>
+</p:sld>
+</file>
+
+<file path=ppt/slides/slide8.xml><?xml version="1.0" encoding="utf-8"?>
+<p:sld xmlns:a="http://schemas.openxmlformats.org/drawingml/2006/main" xmlns:r="http://schemas.openxmlformats.org/officeDocument/2006/relationships" xmlns:p="http://schemas.openxmlformats.org/presentationml/2006/main">
   <p:cSld name="Slide 6">
     <p:bg>
       <p:bgPr>
@@ -6878,7 +7810,7 @@
 </p:sld>
 </file>
 
-<file path=ppt/slides/slide7.xml><?xml version="1.0" encoding="utf-8"?>
+<file path=ppt/slides/slide9.xml><?xml version="1.0" encoding="utf-8"?>
 <p:sld xmlns:a="http://schemas.openxmlformats.org/drawingml/2006/main" xmlns:r="http://schemas.openxmlformats.org/officeDocument/2006/relationships" xmlns:p="http://schemas.openxmlformats.org/presentationml/2006/main">
   <p:cSld name="Slide 7">
     <p:bg>
@@ -7964,816 +8896,6 @@
               <a:t>pytest backend — CI ✅</a:t>
             </a:r>
             <a:endParaRPr lang="en-US" sz="1000" dirty="0"/>
-          </a:p>
-        </p:txBody>
-      </p:sp>
-    </p:spTree>
-  </p:cSld>
-  <p:clrMapOvr>
-    <a:masterClrMapping/>
-  </p:clrMapOvr>
-</p:sld>
-</file>
-
-<file path=ppt/slides/slide8.xml><?xml version="1.0" encoding="utf-8"?>
-<p:sld xmlns:a="http://schemas.openxmlformats.org/drawingml/2006/main" xmlns:r="http://schemas.openxmlformats.org/officeDocument/2006/relationships" xmlns:p="http://schemas.openxmlformats.org/presentationml/2006/main">
-  <p:cSld name="Slide 8">
-    <p:bg>
-      <p:bgPr>
-        <a:solidFill>
-          <a:srgbClr val="0F2318"/>
-        </a:solidFill>
-        <a:effectLst/>
-      </p:bgPr>
-    </p:bg>
-    <p:spTree>
-      <p:nvGrpSpPr>
-        <p:cNvPr id="1" name=""/>
-        <p:cNvGrpSpPr/>
-        <p:nvPr/>
-      </p:nvGrpSpPr>
-      <p:grpSpPr>
-        <a:xfrm>
-          <a:off x="0" y="0"/>
-          <a:ext cx="0" cy="0"/>
-          <a:chOff x="0" y="0"/>
-          <a:chExt cx="0" cy="0"/>
-        </a:xfrm>
-      </p:grpSpPr>
-      <p:sp>
-        <p:nvSpPr>
-          <p:cNvPr id="2" name="Text 0"/>
-          <p:cNvSpPr/>
-          <p:nvPr/>
-        </p:nvSpPr>
-        <p:spPr>
-          <a:xfrm>
-            <a:off x="0" y="548640"/>
-            <a:ext cx="9144000" cy="1828800"/>
-          </a:xfrm>
-          <a:prstGeom prst="rect">
-            <a:avLst/>
-          </a:prstGeom>
-          <a:noFill/>
-          <a:ln/>
-        </p:spPr>
-        <p:txBody>
-          <a:bodyPr wrap="square" lIns="0" tIns="0" rIns="0" bIns="0" rtlCol="0" anchor="ctr"/>
-          <a:lstStyle/>
-          <a:p>
-            <a:pPr marL="0" indent="0" algn="ctr">
-              <a:buNone/>
-            </a:pPr>
-            <a:r>
-              <a:rPr lang="en-US" sz="9000" dirty="0">
-                <a:solidFill>
-                  <a:srgbClr val="000000"/>
-                </a:solidFill>
-              </a:rPr>
-              <a:t>🎬</a:t>
-            </a:r>
-            <a:endParaRPr lang="en-US" sz="9000" dirty="0"/>
-          </a:p>
-        </p:txBody>
-      </p:sp>
-      <p:sp>
-        <p:nvSpPr>
-          <p:cNvPr id="3" name="Text 1"/>
-          <p:cNvSpPr/>
-          <p:nvPr/>
-        </p:nvSpPr>
-        <p:spPr>
-          <a:xfrm>
-            <a:off x="457200" y="2560320"/>
-            <a:ext cx="8229600" cy="1005840"/>
-          </a:xfrm>
-          <a:prstGeom prst="rect">
-            <a:avLst/>
-          </a:prstGeom>
-          <a:noFill/>
-          <a:ln/>
-        </p:spPr>
-        <p:txBody>
-          <a:bodyPr wrap="square" lIns="0" tIns="0" rIns="0" bIns="0" rtlCol="0" anchor="ctr"/>
-          <a:lstStyle/>
-          <a:p>
-            <a:pPr marL="0" indent="0" algn="ctr">
-              <a:buNone/>
-            </a:pPr>
-            <a:r>
-              <a:rPr lang="en-US" sz="5400" b="1" kern="0" spc="400" dirty="0">
-                <a:solidFill>
-                  <a:srgbClr val="FFFFFF"/>
-                </a:solidFill>
-                <a:latin typeface="Calibri" pitchFamily="34" charset="0"/>
-                <a:ea typeface="Calibri" pitchFamily="34" charset="-122"/>
-                <a:cs typeface="Calibri" pitchFamily="34" charset="-120"/>
-              </a:rPr>
-              <a:t>Demo en vivo</a:t>
-            </a:r>
-            <a:endParaRPr lang="en-US" sz="5400" dirty="0"/>
-          </a:p>
-        </p:txBody>
-      </p:sp>
-      <p:sp>
-        <p:nvSpPr>
-          <p:cNvPr id="4" name="Text 2"/>
-          <p:cNvSpPr/>
-          <p:nvPr/>
-        </p:nvSpPr>
-        <p:spPr>
-          <a:xfrm>
-            <a:off x="457200" y="3611880"/>
-            <a:ext cx="8229600" cy="457200"/>
-          </a:xfrm>
-          <a:prstGeom prst="rect">
-            <a:avLst/>
-          </a:prstGeom>
-          <a:noFill/>
-          <a:ln/>
-        </p:spPr>
-        <p:txBody>
-          <a:bodyPr wrap="square" lIns="0" tIns="0" rIns="0" bIns="0" rtlCol="0" anchor="ctr"/>
-          <a:lstStyle/>
-          <a:p>
-            <a:pPr marL="0" indent="0" algn="ctr">
-              <a:buNone/>
-            </a:pPr>
-            <a:r>
-              <a:rPr lang="en-US" sz="1600" dirty="0">
-                <a:solidFill>
-                  <a:srgbClr val="4CAF50"/>
-                </a:solidFill>
-                <a:latin typeface="Calibri" pitchFamily="34" charset="0"/>
-                <a:ea typeface="Calibri" pitchFamily="34" charset="-122"/>
-                <a:cs typeface="Calibri" pitchFamily="34" charset="-120"/>
-              </a:rPr>
-              <a:t>Escaneo de fruta  ·  Historial  ·  Tests</a:t>
-            </a:r>
-            <a:endParaRPr lang="en-US" sz="1600" dirty="0"/>
-          </a:p>
-        </p:txBody>
-      </p:sp>
-    </p:spTree>
-  </p:cSld>
-  <p:clrMapOvr>
-    <a:masterClrMapping/>
-  </p:clrMapOvr>
-</p:sld>
-</file>
-
-<file path=ppt/slides/slide9.xml><?xml version="1.0" encoding="utf-8"?>
-<p:sld xmlns:a="http://schemas.openxmlformats.org/drawingml/2006/main" xmlns:r="http://schemas.openxmlformats.org/officeDocument/2006/relationships" xmlns:p="http://schemas.openxmlformats.org/presentationml/2006/main">
-  <p:cSld name="Slide 9">
-    <p:bg>
-      <p:bgPr>
-        <a:solidFill>
-          <a:srgbClr val="0F2318"/>
-        </a:solidFill>
-        <a:effectLst/>
-      </p:bgPr>
-    </p:bg>
-    <p:spTree>
-      <p:nvGrpSpPr>
-        <p:cNvPr id="1" name=""/>
-        <p:cNvGrpSpPr/>
-        <p:nvPr/>
-      </p:nvGrpSpPr>
-      <p:grpSpPr>
-        <a:xfrm>
-          <a:off x="0" y="0"/>
-          <a:ext cx="0" cy="0"/>
-          <a:chOff x="0" y="0"/>
-          <a:chExt cx="0" cy="0"/>
-        </a:xfrm>
-      </p:grpSpPr>
-      <p:sp>
-        <p:nvSpPr>
-          <p:cNvPr id="2" name="Text 0"/>
-          <p:cNvSpPr/>
-          <p:nvPr/>
-        </p:nvSpPr>
-        <p:spPr>
-          <a:xfrm>
-            <a:off x="457200" y="256032"/>
-            <a:ext cx="8229600" cy="594360"/>
-          </a:xfrm>
-          <a:prstGeom prst="rect">
-            <a:avLst/>
-          </a:prstGeom>
-          <a:noFill/>
-          <a:ln/>
-        </p:spPr>
-        <p:txBody>
-          <a:bodyPr wrap="square" lIns="0" tIns="0" rIns="0" bIns="0" rtlCol="0" anchor="ctr"/>
-          <a:lstStyle/>
-          <a:p>
-            <a:pPr marL="0" indent="0" algn="l">
-              <a:buNone/>
-            </a:pPr>
-            <a:r>
-              <a:rPr lang="en-US" sz="2800" b="1" dirty="0">
-                <a:solidFill>
-                  <a:srgbClr val="FFFFFF"/>
-                </a:solidFill>
-                <a:latin typeface="Calibri" pitchFamily="34" charset="0"/>
-                <a:ea typeface="Calibri" pitchFamily="34" charset="-122"/>
-                <a:cs typeface="Calibri" pitchFamily="34" charset="-120"/>
-              </a:rPr>
-              <a:t>Conclusiones</a:t>
-            </a:r>
-            <a:endParaRPr lang="en-US" sz="2800" dirty="0"/>
-          </a:p>
-        </p:txBody>
-      </p:sp>
-      <p:sp>
-        <p:nvSpPr>
-          <p:cNvPr id="3" name="Shape 1"/>
-          <p:cNvSpPr/>
-          <p:nvPr/>
-        </p:nvSpPr>
-        <p:spPr>
-          <a:xfrm>
-            <a:off x="457200" y="896112"/>
-            <a:ext cx="914400" cy="54864"/>
-          </a:xfrm>
-          <a:prstGeom prst="rect">
-            <a:avLst/>
-          </a:prstGeom>
-          <a:solidFill>
-            <a:srgbClr val="4CAF50"/>
-          </a:solidFill>
-          <a:ln/>
-        </p:spPr>
-        <p:txBody>
-          <a:bodyPr/>
-          <a:lstStyle/>
-          <a:p>
-            <a:endParaRPr lang="es-CL"/>
-          </a:p>
-        </p:txBody>
-      </p:sp>
-      <p:sp>
-        <p:nvSpPr>
-          <p:cNvPr id="4" name="Shape 2"/>
-          <p:cNvSpPr/>
-          <p:nvPr/>
-        </p:nvSpPr>
-        <p:spPr>
-          <a:xfrm>
-            <a:off x="457200" y="1097280"/>
-            <a:ext cx="8229600" cy="1078992"/>
-          </a:xfrm>
-          <a:prstGeom prst="rect">
-            <a:avLst/>
-          </a:prstGeom>
-          <a:solidFill>
-            <a:srgbClr val="1B3A24"/>
-          </a:solidFill>
-          <a:ln/>
-          <a:effectLst>
-            <a:outerShdw blurRad="101600" dist="38100" dir="8100000" algn="bl" rotWithShape="0">
-              <a:srgbClr val="000000">
-                <a:alpha val="12000"/>
-              </a:srgbClr>
-            </a:outerShdw>
-          </a:effectLst>
-        </p:spPr>
-        <p:txBody>
-          <a:bodyPr/>
-          <a:lstStyle/>
-          <a:p>
-            <a:endParaRPr lang="es-CL"/>
-          </a:p>
-        </p:txBody>
-      </p:sp>
-      <p:sp>
-        <p:nvSpPr>
-          <p:cNvPr id="5" name="Shape 3"/>
-          <p:cNvSpPr/>
-          <p:nvPr/>
-        </p:nvSpPr>
-        <p:spPr>
-          <a:xfrm>
-            <a:off x="457200" y="1097280"/>
-            <a:ext cx="502920" cy="1078992"/>
-          </a:xfrm>
-          <a:prstGeom prst="rect">
-            <a:avLst/>
-          </a:prstGeom>
-          <a:solidFill>
-            <a:srgbClr val="4CAF50"/>
-          </a:solidFill>
-          <a:ln/>
-        </p:spPr>
-        <p:txBody>
-          <a:bodyPr/>
-          <a:lstStyle/>
-          <a:p>
-            <a:endParaRPr lang="es-CL"/>
-          </a:p>
-        </p:txBody>
-      </p:sp>
-      <p:sp>
-        <p:nvSpPr>
-          <p:cNvPr id="6" name="Text 4"/>
-          <p:cNvSpPr/>
-          <p:nvPr/>
-        </p:nvSpPr>
-        <p:spPr>
-          <a:xfrm>
-            <a:off x="457200" y="1097280"/>
-            <a:ext cx="502920" cy="1078992"/>
-          </a:xfrm>
-          <a:prstGeom prst="rect">
-            <a:avLst/>
-          </a:prstGeom>
-          <a:noFill/>
-          <a:ln/>
-        </p:spPr>
-        <p:txBody>
-          <a:bodyPr wrap="square" lIns="0" tIns="0" rIns="0" bIns="0" rtlCol="0" anchor="ctr"/>
-          <a:lstStyle/>
-          <a:p>
-            <a:pPr marL="0" indent="0" algn="ctr">
-              <a:buNone/>
-            </a:pPr>
-            <a:r>
-              <a:rPr lang="en-US" sz="2200" dirty="0">
-                <a:solidFill>
-                  <a:srgbClr val="000000"/>
-                </a:solidFill>
-              </a:rPr>
-              <a:t>✅</a:t>
-            </a:r>
-            <a:endParaRPr lang="en-US" sz="2200" dirty="0"/>
-          </a:p>
-        </p:txBody>
-      </p:sp>
-      <p:sp>
-        <p:nvSpPr>
-          <p:cNvPr id="7" name="Text 5"/>
-          <p:cNvSpPr/>
-          <p:nvPr/>
-        </p:nvSpPr>
-        <p:spPr>
-          <a:xfrm>
-            <a:off x="1051560" y="1188720"/>
-            <a:ext cx="7498080" cy="365760"/>
-          </a:xfrm>
-          <a:prstGeom prst="rect">
-            <a:avLst/>
-          </a:prstGeom>
-          <a:noFill/>
-          <a:ln/>
-        </p:spPr>
-        <p:txBody>
-          <a:bodyPr wrap="square" lIns="0" tIns="0" rIns="0" bIns="0" rtlCol="0" anchor="ctr"/>
-          <a:lstStyle/>
-          <a:p>
-            <a:pPr marL="0" indent="0">
-              <a:buNone/>
-            </a:pPr>
-            <a:r>
-              <a:rPr lang="en-US" sz="1600" b="1" dirty="0">
-                <a:solidFill>
-                  <a:srgbClr val="FFFFFF"/>
-                </a:solidFill>
-                <a:latin typeface="Calibri" pitchFamily="34" charset="0"/>
-                <a:ea typeface="Calibri" pitchFamily="34" charset="-122"/>
-                <a:cs typeface="Calibri" pitchFamily="34" charset="-120"/>
-              </a:rPr>
-              <a:t>KPI cumplido</a:t>
-            </a:r>
-            <a:endParaRPr lang="en-US" sz="1600" dirty="0"/>
-          </a:p>
-        </p:txBody>
-      </p:sp>
-      <p:sp>
-        <p:nvSpPr>
-          <p:cNvPr id="8" name="Text 6"/>
-          <p:cNvSpPr/>
-          <p:nvPr/>
-        </p:nvSpPr>
-        <p:spPr>
-          <a:xfrm>
-            <a:off x="1051560" y="1572768"/>
-            <a:ext cx="7498080" cy="438912"/>
-          </a:xfrm>
-          <a:prstGeom prst="rect">
-            <a:avLst/>
-          </a:prstGeom>
-          <a:noFill/>
-          <a:ln/>
-        </p:spPr>
-        <p:txBody>
-          <a:bodyPr wrap="square" lIns="0" tIns="0" rIns="0" bIns="0" rtlCol="0" anchor="ctr"/>
-          <a:lstStyle/>
-          <a:p>
-            <a:pPr marL="0" indent="0">
-              <a:buNone/>
-            </a:pPr>
-            <a:r>
-              <a:rPr lang="en-US" sz="1300" dirty="0">
-                <a:solidFill>
-                  <a:srgbClr val="C8E6C9"/>
-                </a:solidFill>
-                <a:latin typeface="Calibri" pitchFamily="34" charset="0"/>
-                <a:ea typeface="Calibri" pitchFamily="34" charset="-122"/>
-                <a:cs typeface="Calibri" pitchFamily="34" charset="-120"/>
-              </a:rPr>
-              <a:t>mAP@50 = 0.9229 supera el umbral de 0.75 exigido por +17.3 puntos</a:t>
-            </a:r>
-            <a:endParaRPr lang="en-US" sz="1300" dirty="0"/>
-          </a:p>
-        </p:txBody>
-      </p:sp>
-      <p:sp>
-        <p:nvSpPr>
-          <p:cNvPr id="9" name="Shape 7"/>
-          <p:cNvSpPr/>
-          <p:nvPr/>
-        </p:nvSpPr>
-        <p:spPr>
-          <a:xfrm>
-            <a:off x="457200" y="2359152"/>
-            <a:ext cx="8229600" cy="1078992"/>
-          </a:xfrm>
-          <a:prstGeom prst="rect">
-            <a:avLst/>
-          </a:prstGeom>
-          <a:solidFill>
-            <a:srgbClr val="1B3A24"/>
-          </a:solidFill>
-          <a:ln/>
-          <a:effectLst>
-            <a:outerShdw blurRad="101600" dist="38100" dir="8100000" algn="bl" rotWithShape="0">
-              <a:srgbClr val="000000">
-                <a:alpha val="12000"/>
-              </a:srgbClr>
-            </a:outerShdw>
-          </a:effectLst>
-        </p:spPr>
-        <p:txBody>
-          <a:bodyPr/>
-          <a:lstStyle/>
-          <a:p>
-            <a:endParaRPr lang="es-CL"/>
-          </a:p>
-        </p:txBody>
-      </p:sp>
-      <p:sp>
-        <p:nvSpPr>
-          <p:cNvPr id="10" name="Shape 8"/>
-          <p:cNvSpPr/>
-          <p:nvPr/>
-        </p:nvSpPr>
-        <p:spPr>
-          <a:xfrm>
-            <a:off x="457200" y="2359152"/>
-            <a:ext cx="502920" cy="1078992"/>
-          </a:xfrm>
-          <a:prstGeom prst="rect">
-            <a:avLst/>
-          </a:prstGeom>
-          <a:solidFill>
-            <a:srgbClr val="42A5F5"/>
-          </a:solidFill>
-          <a:ln/>
-        </p:spPr>
-        <p:txBody>
-          <a:bodyPr/>
-          <a:lstStyle/>
-          <a:p>
-            <a:endParaRPr lang="es-CL"/>
-          </a:p>
-        </p:txBody>
-      </p:sp>
-      <p:sp>
-        <p:nvSpPr>
-          <p:cNvPr id="11" name="Text 9"/>
-          <p:cNvSpPr/>
-          <p:nvPr/>
-        </p:nvSpPr>
-        <p:spPr>
-          <a:xfrm>
-            <a:off x="457200" y="2359152"/>
-            <a:ext cx="502920" cy="1078992"/>
-          </a:xfrm>
-          <a:prstGeom prst="rect">
-            <a:avLst/>
-          </a:prstGeom>
-          <a:noFill/>
-          <a:ln/>
-        </p:spPr>
-        <p:txBody>
-          <a:bodyPr wrap="square" lIns="0" tIns="0" rIns="0" bIns="0" rtlCol="0" anchor="ctr"/>
-          <a:lstStyle/>
-          <a:p>
-            <a:pPr marL="0" indent="0" algn="ctr">
-              <a:buNone/>
-            </a:pPr>
-            <a:r>
-              <a:rPr lang="en-US" sz="2200" dirty="0">
-                <a:solidFill>
-                  <a:srgbClr val="000000"/>
-                </a:solidFill>
-              </a:rPr>
-              <a:t>🏗</a:t>
-            </a:r>
-            <a:endParaRPr lang="en-US" sz="2200" dirty="0"/>
-          </a:p>
-        </p:txBody>
-      </p:sp>
-      <p:sp>
-        <p:nvSpPr>
-          <p:cNvPr id="12" name="Text 10"/>
-          <p:cNvSpPr/>
-          <p:nvPr/>
-        </p:nvSpPr>
-        <p:spPr>
-          <a:xfrm>
-            <a:off x="1051560" y="2450592"/>
-            <a:ext cx="7498080" cy="365760"/>
-          </a:xfrm>
-          <a:prstGeom prst="rect">
-            <a:avLst/>
-          </a:prstGeom>
-          <a:noFill/>
-          <a:ln/>
-        </p:spPr>
-        <p:txBody>
-          <a:bodyPr wrap="square" lIns="0" tIns="0" rIns="0" bIns="0" rtlCol="0" anchor="ctr"/>
-          <a:lstStyle/>
-          <a:p>
-            <a:pPr marL="0" indent="0">
-              <a:buNone/>
-            </a:pPr>
-            <a:r>
-              <a:rPr lang="en-US" sz="1600" b="1" dirty="0">
-                <a:solidFill>
-                  <a:srgbClr val="FFFFFF"/>
-                </a:solidFill>
-                <a:latin typeface="Calibri" pitchFamily="34" charset="0"/>
-                <a:ea typeface="Calibri" pitchFamily="34" charset="-122"/>
-                <a:cs typeface="Calibri" pitchFamily="34" charset="-120"/>
-              </a:rPr>
-              <a:t>Arquitectura bien fundamentada</a:t>
-            </a:r>
-            <a:endParaRPr lang="en-US" sz="1600" dirty="0"/>
-          </a:p>
-        </p:txBody>
-      </p:sp>
-      <p:sp>
-        <p:nvSpPr>
-          <p:cNvPr id="13" name="Text 11"/>
-          <p:cNvSpPr/>
-          <p:nvPr/>
-        </p:nvSpPr>
-        <p:spPr>
-          <a:xfrm>
-            <a:off x="1051560" y="2834640"/>
-            <a:ext cx="7498080" cy="438912"/>
-          </a:xfrm>
-          <a:prstGeom prst="rect">
-            <a:avLst/>
-          </a:prstGeom>
-          <a:noFill/>
-          <a:ln/>
-        </p:spPr>
-        <p:txBody>
-          <a:bodyPr wrap="square" lIns="0" tIns="0" rIns="0" bIns="0" rtlCol="0" anchor="ctr"/>
-          <a:lstStyle/>
-          <a:p>
-            <a:pPr marL="0" indent="0">
-              <a:buNone/>
-            </a:pPr>
-            <a:r>
-              <a:rPr lang="en-US" sz="1300" dirty="0">
-                <a:solidFill>
-                  <a:srgbClr val="C8E6C9"/>
-                </a:solidFill>
-                <a:latin typeface="Calibri" pitchFamily="34" charset="0"/>
-                <a:ea typeface="Calibri" pitchFamily="34" charset="-122"/>
-                <a:cs typeface="Calibri" pitchFamily="34" charset="-120"/>
-              </a:rPr>
-              <a:t>Modelo 4+1 de Kruchten aplicado con las 5 vistas documentadas y trazadas a casos de uso reales</a:t>
-            </a:r>
-            <a:endParaRPr lang="en-US" sz="1300" dirty="0"/>
-          </a:p>
-        </p:txBody>
-      </p:sp>
-      <p:sp>
-        <p:nvSpPr>
-          <p:cNvPr id="14" name="Shape 12"/>
-          <p:cNvSpPr/>
-          <p:nvPr/>
-        </p:nvSpPr>
-        <p:spPr>
-          <a:xfrm>
-            <a:off x="457200" y="3621024"/>
-            <a:ext cx="8229600" cy="1078992"/>
-          </a:xfrm>
-          <a:prstGeom prst="rect">
-            <a:avLst/>
-          </a:prstGeom>
-          <a:solidFill>
-            <a:srgbClr val="1B3A24"/>
-          </a:solidFill>
-          <a:ln/>
-          <a:effectLst>
-            <a:outerShdw blurRad="101600" dist="38100" dir="8100000" algn="bl" rotWithShape="0">
-              <a:srgbClr val="000000">
-                <a:alpha val="12000"/>
-              </a:srgbClr>
-            </a:outerShdw>
-          </a:effectLst>
-        </p:spPr>
-        <p:txBody>
-          <a:bodyPr/>
-          <a:lstStyle/>
-          <a:p>
-            <a:endParaRPr lang="es-CL"/>
-          </a:p>
-        </p:txBody>
-      </p:sp>
-      <p:sp>
-        <p:nvSpPr>
-          <p:cNvPr id="15" name="Shape 13"/>
-          <p:cNvSpPr/>
-          <p:nvPr/>
-        </p:nvSpPr>
-        <p:spPr>
-          <a:xfrm>
-            <a:off x="457200" y="3621024"/>
-            <a:ext cx="502920" cy="1078992"/>
-          </a:xfrm>
-          <a:prstGeom prst="rect">
-            <a:avLst/>
-          </a:prstGeom>
-          <a:solidFill>
-            <a:srgbClr val="AB47BC"/>
-          </a:solidFill>
-          <a:ln/>
-        </p:spPr>
-        <p:txBody>
-          <a:bodyPr/>
-          <a:lstStyle/>
-          <a:p>
-            <a:endParaRPr lang="es-CL"/>
-          </a:p>
-        </p:txBody>
-      </p:sp>
-      <p:sp>
-        <p:nvSpPr>
-          <p:cNvPr id="16" name="Text 14"/>
-          <p:cNvSpPr/>
-          <p:nvPr/>
-        </p:nvSpPr>
-        <p:spPr>
-          <a:xfrm>
-            <a:off x="457200" y="3621024"/>
-            <a:ext cx="502920" cy="1078992"/>
-          </a:xfrm>
-          <a:prstGeom prst="rect">
-            <a:avLst/>
-          </a:prstGeom>
-          <a:noFill/>
-          <a:ln/>
-        </p:spPr>
-        <p:txBody>
-          <a:bodyPr wrap="square" lIns="0" tIns="0" rIns="0" bIns="0" rtlCol="0" anchor="ctr"/>
-          <a:lstStyle/>
-          <a:p>
-            <a:pPr marL="0" indent="0" algn="ctr">
-              <a:buNone/>
-            </a:pPr>
-            <a:r>
-              <a:rPr lang="en-US" sz="2200" dirty="0">
-                <a:solidFill>
-                  <a:srgbClr val="000000"/>
-                </a:solidFill>
-              </a:rPr>
-              <a:t>🚀</a:t>
-            </a:r>
-            <a:endParaRPr lang="en-US" sz="2200" dirty="0"/>
-          </a:p>
-        </p:txBody>
-      </p:sp>
-      <p:sp>
-        <p:nvSpPr>
-          <p:cNvPr id="17" name="Text 15"/>
-          <p:cNvSpPr/>
-          <p:nvPr/>
-        </p:nvSpPr>
-        <p:spPr>
-          <a:xfrm>
-            <a:off x="1051560" y="3712464"/>
-            <a:ext cx="7498080" cy="365760"/>
-          </a:xfrm>
-          <a:prstGeom prst="rect">
-            <a:avLst/>
-          </a:prstGeom>
-          <a:noFill/>
-          <a:ln/>
-        </p:spPr>
-        <p:txBody>
-          <a:bodyPr wrap="square" lIns="0" tIns="0" rIns="0" bIns="0" rtlCol="0" anchor="ctr"/>
-          <a:lstStyle/>
-          <a:p>
-            <a:pPr marL="0" indent="0">
-              <a:buNone/>
-            </a:pPr>
-            <a:r>
-              <a:rPr lang="en-US" sz="1600" b="1" dirty="0">
-                <a:solidFill>
-                  <a:srgbClr val="FFFFFF"/>
-                </a:solidFill>
-                <a:latin typeface="Calibri" pitchFamily="34" charset="0"/>
-                <a:ea typeface="Calibri" pitchFamily="34" charset="-122"/>
-                <a:cs typeface="Calibri" pitchFamily="34" charset="-120"/>
-              </a:rPr>
-              <a:t>Producto funcional</a:t>
-            </a:r>
-            <a:endParaRPr lang="en-US" sz="1600" dirty="0"/>
-          </a:p>
-        </p:txBody>
-      </p:sp>
-      <p:sp>
-        <p:nvSpPr>
-          <p:cNvPr id="18" name="Text 16"/>
-          <p:cNvSpPr/>
-          <p:nvPr/>
-        </p:nvSpPr>
-        <p:spPr>
-          <a:xfrm>
-            <a:off x="1051560" y="4096512"/>
-            <a:ext cx="7498080" cy="438912"/>
-          </a:xfrm>
-          <a:prstGeom prst="rect">
-            <a:avLst/>
-          </a:prstGeom>
-          <a:noFill/>
-          <a:ln/>
-        </p:spPr>
-        <p:txBody>
-          <a:bodyPr wrap="square" lIns="0" tIns="0" rIns="0" bIns="0" rtlCol="0" anchor="ctr"/>
-          <a:lstStyle/>
-          <a:p>
-            <a:pPr marL="0" indent="0">
-              <a:buNone/>
-            </a:pPr>
-            <a:r>
-              <a:rPr lang="en-US" sz="1300" dirty="0">
-                <a:solidFill>
-                  <a:srgbClr val="C8E6C9"/>
-                </a:solidFill>
-                <a:latin typeface="Calibri" pitchFamily="34" charset="0"/>
-                <a:ea typeface="Calibri" pitchFamily="34" charset="-122"/>
-                <a:cs typeface="Calibri" pitchFamily="34" charset="-120"/>
-              </a:rPr>
-              <a:t>12/12 requerimientos implementados, desplegado en Render con CI verde en cada commit</a:t>
-            </a:r>
-            <a:endParaRPr lang="en-US" sz="1300" dirty="0"/>
-          </a:p>
-        </p:txBody>
-      </p:sp>
-      <p:sp>
-        <p:nvSpPr>
-          <p:cNvPr id="19" name="Text 17"/>
-          <p:cNvSpPr/>
-          <p:nvPr/>
-        </p:nvSpPr>
-        <p:spPr>
-          <a:xfrm>
-            <a:off x="457200" y="4754880"/>
-            <a:ext cx="8229600" cy="256032"/>
-          </a:xfrm>
-          <a:prstGeom prst="rect">
-            <a:avLst/>
-          </a:prstGeom>
-          <a:noFill/>
-          <a:ln/>
-        </p:spPr>
-        <p:txBody>
-          <a:bodyPr wrap="square" lIns="0" tIns="0" rIns="0" bIns="0" rtlCol="0" anchor="ctr"/>
-          <a:lstStyle/>
-          <a:p>
-            <a:pPr marL="0" indent="0" algn="ctr">
-              <a:buNone/>
-            </a:pPr>
-            <a:r>
-              <a:rPr lang="en-US" sz="1100" i="1" dirty="0">
-                <a:solidFill>
-                  <a:srgbClr val="718096"/>
-                </a:solidFill>
-                <a:latin typeface="Calibri" pitchFamily="34" charset="0"/>
-                <a:ea typeface="Calibri" pitchFamily="34" charset="-122"/>
-                <a:cs typeface="Calibri" pitchFamily="34" charset="-120"/>
-              </a:rPr>
-              <a:t>Trabajo futuro: autenticación JWT · más frutas · tests E2E</a:t>
-            </a:r>
-            <a:endParaRPr lang="en-US" sz="1100" dirty="0"/>
           </a:p>
         </p:txBody>
       </p:sp>

</xml_diff>

<commit_message>
docs(ev2): agregar notas de orador a la presentación
</commit_message>
<xml_diff>
--- a/Documentación/Evaluacion_2/MaduraApp_Presentacion_Evaluacion2.pptx
+++ b/Documentación/Evaluacion_2/MaduraApp_Presentacion_Evaluacion2.pptx
@@ -291,6 +291,19 @@
           <a:bodyPr/>
           <a:lstStyle/>
           <a:p>
+            <a:r>
+              <a:t>Buenos días / buenas tardes. Mi nombre es Claudio Aro, estudiante de la sección 001D de Taller Aplicado de Programación.</a:t>
+            </a:r>
+            <a:br/>
+            <a:br/>
+            <a:r>
+              <a:t>Les presento MaduraApp: un sistema de análisis de madurez agrícola mediante visión computacional. La idea es simple: tomas una foto de una fruta con tu celular y el sistema te dice al instante si está inmadura, en punto óptimo o sobre-madura.</a:t>
+            </a:r>
+            <a:br/>
+            <a:br/>
+            <a:r>
+              <a:t>[TÉCNICO] El proyecto cubre backend FastAPI + modelo YOLO26n + app Android nativa — todo desplegado y funcional.</a:t>
+            </a:r>
             <a:endParaRPr lang="en-US" dirty="0"/>
           </a:p>
         </p:txBody>
@@ -324,6 +337,120 @@
         <p14:creationId xmlns:p14="http://schemas.microsoft.com/office/powerpoint/2010/main" val="1024086991"/>
       </p:ext>
     </p:extLst>
+  </p:cSld>
+  <p:clrMapOvr>
+    <a:masterClrMapping/>
+  </p:clrMapOvr>
+</p:notes>
+</file>
+
+<file path=ppt/notesSlides/notesSlide10.xml><?xml version="1.0" encoding="utf-8"?>
+<p:notes xmlns:a="http://schemas.openxmlformats.org/drawingml/2006/main" xmlns:p="http://schemas.openxmlformats.org/presentationml/2006/main" xmlns:r="http://schemas.openxmlformats.org/officeDocument/2006/relationships">
+  <p:cSld>
+    <p:spTree>
+      <p:nvGrpSpPr>
+        <p:cNvPr id="1" name=""/>
+        <p:cNvGrpSpPr/>
+        <p:nvPr/>
+      </p:nvGrpSpPr>
+      <p:grpSpPr>
+        <a:xfrm>
+          <a:off x="0" y="0"/>
+          <a:ext cx="0" cy="0"/>
+          <a:chOff x="0" y="0"/>
+          <a:chExt cx="0" cy="0"/>
+        </a:xfrm>
+      </p:grpSpPr>
+      <p:sp>
+        <p:nvSpPr>
+          <p:cNvPr id="3" name="Notes Placeholder 2"/>
+          <p:cNvSpPr>
+            <a:spLocks noGrp="1"/>
+          </p:cNvSpPr>
+          <p:nvPr>
+            <p:ph type="body" idx="1"/>
+          </p:nvPr>
+        </p:nvSpPr>
+        <p:spPr/>
+        <p:txBody>
+          <a:bodyPr/>
+          <a:lstStyle/>
+          <a:p>
+            <a:r>
+              <a:t>[Describir el diagrama que aparece en esta slide]</a:t>
+            </a:r>
+            <a:br/>
+            <a:br/>
+            <a:r>
+              <a:t>Señalen las capas o flujos principales. Expliquen cómo se comunican los componentes y qué problema de diseño resuelve esta estructura.</a:t>
+            </a:r>
+            <a:br/>
+            <a:br/>
+            <a:r>
+              <a:t>[TÉCNICO] Si preguntan detalles: el backend separa routers → services → models de forma estricta — ninguna capa puede importar de una superior. La sesión de base de datos se inyecta vía FastAPI Depends, lo que permite sobrescribirla en tests con SQLite in-memory.</a:t>
+            </a:r>
+            <a:endParaRPr lang="es-CL" dirty="0"/>
+          </a:p>
+        </p:txBody>
+      </p:sp>
+    </p:spTree>
+  </p:cSld>
+  <p:clrMapOvr>
+    <a:masterClrMapping/>
+  </p:clrMapOvr>
+</p:notes>
+</file>
+
+<file path=ppt/notesSlides/notesSlide11.xml><?xml version="1.0" encoding="utf-8"?>
+<p:notes xmlns:a="http://schemas.openxmlformats.org/drawingml/2006/main" xmlns:p="http://schemas.openxmlformats.org/presentationml/2006/main" xmlns:r="http://schemas.openxmlformats.org/officeDocument/2006/relationships">
+  <p:cSld>
+    <p:spTree>
+      <p:nvGrpSpPr>
+        <p:cNvPr id="1" name=""/>
+        <p:cNvGrpSpPr/>
+        <p:nvPr/>
+      </p:nvGrpSpPr>
+      <p:grpSpPr>
+        <a:xfrm>
+          <a:off x="0" y="0"/>
+          <a:ext cx="0" cy="0"/>
+          <a:chOff x="0" y="0"/>
+          <a:chExt cx="0" cy="0"/>
+        </a:xfrm>
+      </p:grpSpPr>
+      <p:sp>
+        <p:nvSpPr>
+          <p:cNvPr id="3" name="Notes Placeholder 2"/>
+          <p:cNvSpPr>
+            <a:spLocks noGrp="1"/>
+          </p:cNvSpPr>
+          <p:nvPr>
+            <p:ph type="body" idx="1"/>
+          </p:nvPr>
+        </p:nvSpPr>
+        <p:spPr/>
+        <p:txBody>
+          <a:bodyPr/>
+          <a:lstStyle/>
+          <a:p>
+            <a:r>
+              <a:t>[Describir el diagrama que aparece en esta slide]</a:t>
+            </a:r>
+            <a:br/>
+            <a:br/>
+            <a:r>
+              <a:t>Expliquen el flujo o la topología. Si es el diagrama de despliegue, mencionar que Android se conecta vía HTTPS a Render, y Render persiste en Supabase PostgreSQL.</a:t>
+            </a:r>
+            <a:br/>
+            <a:br/>
+            <a:r>
+              <a:t>[TÉCNICO] Para la demo en sala se usa adb reverse tcp:8000 tcp:8000, lo que evita depender del WiFi del laboratorio: el teléfono accede al backend corriendo en el mismo PC a través del cable USB.</a:t>
+            </a:r>
+            <a:endParaRPr lang="es-CL" dirty="0"/>
+          </a:p>
+        </p:txBody>
+      </p:sp>
+    </p:spTree>
   </p:cSld>
   <p:clrMapOvr>
     <a:masterClrMapping/>
@@ -375,6 +502,19 @@
           <a:bodyPr/>
           <a:lstStyle/>
           <a:p>
+            <a:r>
+              <a:t>El problema que aborda MaduraApp es real y cuantificable: entre el 20 y el 40 por ciento de la producción frutícola se pierde post-cosecha en Chile, según datos de FAO y ODEPA.</a:t>
+            </a:r>
+            <a:br/>
+            <a:br/>
+            <a:r>
+              <a:t>El núcleo del problema es la falta de un criterio objetivo para saber cuándo comer o comercializar una fruta. Hoy eso depende de la experiencia visual del productor o vendedor, que es subjetiva y no escalable.</a:t>
+            </a:r>
+            <a:br/>
+            <a:br/>
+            <a:r>
+              <a:t>[TÉCNICO] Las frutas trabajadas son "climatéricas": aguacate Hass, plátano, tomate cherry y mango — todas maduran después de la cosecha, lo que hace el timing crítico. El impacto económico afecta especialmente a pequeños productores que representan el 40% de las pérdidas.</a:t>
+            </a:r>
             <a:endParaRPr lang="en-US" dirty="0"/>
           </a:p>
         </p:txBody>
@@ -459,6 +599,19 @@
           <a:bodyPr/>
           <a:lstStyle/>
           <a:p>
+            <a:r>
+              <a:t>MaduraApp resuelve esto con tres componentes que trabajan en cadena.</a:t>
+            </a:r>
+            <a:br/>
+            <a:br/>
+            <a:r>
+              <a:t>Primero, la app Android: el usuario elige la fruta, toma una foto o selecciona una desde la galería. Segundo, esa imagen se envía al backend FastAPI que ejecuta el modelo YOLO26n y retorna el diagnóstico en menos de 2.5 segundos. Tercero, la app muestra el resultado: inmaduro, óptimo o sobre-maduro, con una recomendación agronómica.</a:t>
+            </a:r>
+            <a:br/>
+            <a:br/>
+            <a:r>
+              <a:t>[TÉCNICO] El selector de fruta en la pantalla inicial no es sólo UX: activa el filtrado por clase en el modelo y habilita Test-Time Augmentation (TTA), lo que mejora la precisión en 2-3 puntos porcentuales a costo de ~200ms extra de latencia.</a:t>
+            </a:r>
             <a:endParaRPr lang="en-US" dirty="0"/>
           </a:p>
         </p:txBody>
@@ -543,6 +696,19 @@
           <a:bodyPr/>
           <a:lstStyle/>
           <a:p>
+            <a:r>
+              <a:t>El stack fue seleccionado priorizando rendimiento en producción, buenas prácticas y facilidad de mantenimiento.</a:t>
+            </a:r>
+            <a:br/>
+            <a:br/>
+            <a:r>
+              <a:t>En Android: Kotlin con CameraX para la cámara, arquitectura MVVM con LiveData, Room para cache offline y Retrofit para las llamadas HTTP. En backend: FastAPI asíncrono, SQLAlchemy async con Alembic para migraciones, todo containerizado con Docker y desplegado en Render. El modelo es YOLO26n de Ultralytics, corriendo en CPU.</a:t>
+            </a:r>
+            <a:br/>
+            <a:br/>
+            <a:r>
+              <a:t>[TÉCNICO] Elegimos YOLO26n por su balance peso/precisión: solo 5.2 MB, lo que permite desplegarlo en instancias con 2 GB RAM sin GPU. El patrón Repository con Room como Single Source of Truth garantiza que el historial funcione sin conexión.</a:t>
+            </a:r>
             <a:endParaRPr lang="en-US" dirty="0"/>
           </a:p>
         </p:txBody>
@@ -627,6 +793,19 @@
           <a:bodyPr/>
           <a:lstStyle/>
           <a:p>
+            <a:r>
+              <a:t>Para documentar la arquitectura usamos el modelo 4+1 de Kruchten, estándar de la industria propuesto por Philippe Kruchten en IEEE Software, 1995.</a:t>
+            </a:r>
+            <a:br/>
+            <a:br/>
+            <a:r>
+              <a:t>Las cuatro vistas describen el sistema desde distintos ángulos: la Vista Lógica muestra las clases y el dominio; la Vista de Procesos, la concurrencia y el flujo async; la Vista de Desarrollo, la organización del código en capas; y la Vista Física, el despliegue en cloud. La vista +1 de Escenarios valida las otras cuatro mediante los casos de uso concretos.</a:t>
+            </a:r>
+            <a:br/>
+            <a:br/>
+            <a:r>
+              <a:t>[TÉCNICO] Esto garantiza que cualquier decisión de diseño —por ejemplo, usar asyncio.to_thread para la inferencia YOLO— se puede rastrear desde el código hasta el caso de uso CU-01 que la motiva.</a:t>
+            </a:r>
             <a:endParaRPr lang="en-US" dirty="0"/>
           </a:p>
         </p:txBody>
@@ -711,6 +890,19 @@
           <a:bodyPr/>
           <a:lstStyle/>
           <a:p>
+            <a:r>
+              <a:t>Los resultados del modelo superan ampliamente el KPI establecido.</a:t>
+            </a:r>
+            <a:br/>
+            <a:br/>
+            <a:r>
+              <a:t>Obtuvimos un mAP@50 de 0.9229 — el KPI mínimo era 0.75 — lo que representa 17.3 puntos porcentuales de holgura. La precisión es 94.5% y el recall 87.3%, lo que significa que el modelo casi nunca produce falsos positivos y rara vez pierde una detección real.</a:t>
+            </a:r>
+            <a:br/>
+            <a:br/>
+            <a:r>
+              <a:t>[TÉCNICO] El entrenamiento fue de 80 épocas con el dataset propio de 31.940 imágenes en Kaggle con dos GPUs Tesla T4. El dataset combinó fuentes de Kaggle y Mendeley con augmentation agresivo. El umbral de confianza en producción es 0.55; con fruit_filter activo baja a 0.275 porque ya acotamos las clases posibles.</a:t>
+            </a:r>
             <a:endParaRPr lang="en-US" dirty="0"/>
           </a:p>
         </p:txBody>
@@ -795,6 +987,19 @@
           <a:bodyPr/>
           <a:lstStyle/>
           <a:p>
+            <a:r>
+              <a:t>Al cierre de la Evaluación 2, ambos sprints están completos y verificados.</a:t>
+            </a:r>
+            <a:br/>
+            <a:br/>
+            <a:r>
+              <a:t>Sprint 1: el backend tiene los tres endpoints —predict, history, health— con persistencia async y nueve tests en pytest, todos pasando en CI. Sprint 2: la app Android cubre todas las funcionalidades: cámara, galería, selector de fruta y cache offline con Room.</a:t>
+            </a:r>
+            <a:br/>
+            <a:br/>
+            <a:r>
+              <a:t>[TÉCNICO] El 100% de cobertura de requerimientos funcionales (12/12 RF) fue validado ejecutando cada caso de uso definido en la ERS. El CI corre en GitHub Actions en cada push; un merge a main con CI rojo está bloqueado por configuración del repositorio.</a:t>
+            </a:r>
             <a:endParaRPr lang="en-US" dirty="0"/>
           </a:p>
         </p:txBody>
@@ -879,6 +1084,19 @@
           <a:bodyPr/>
           <a:lstStyle/>
           <a:p>
+            <a:r>
+              <a:t>Vamos a hacer una demostración en vivo del sistema.</a:t>
+            </a:r>
+            <a:br/>
+            <a:br/>
+            <a:r>
+              <a:t>El flujo que verán: selecciono la fruta en la pantalla inicial, tomo una foto o selecciono una desde la galería, el backend procesa la imagen con YOLO26n y en menos de 2.5 segundos aparece el diagnóstico con la recomendación. También mostraré el historial de escaneos y los tests corriendo.</a:t>
+            </a:r>
+            <a:br/>
+            <a:br/>
+            <a:r>
+              <a:t>[TÉCNICO] La demo usa el backend corriendo localmente con adb reverse tcp:8000 tcp:8000. Si hay problemas de red, tengo capturas de pantalla de respaldo. El modelo está cargado en memoria, así que el cold start ya pasó.</a:t>
+            </a:r>
             <a:endParaRPr lang="en-US" dirty="0"/>
           </a:p>
         </p:txBody>
@@ -963,6 +1181,24 @@
           <a:bodyPr/>
           <a:lstStyle/>
           <a:p>
+            <a:r>
+              <a:t>Para cerrar, tres conclusiones clave.</a:t>
+            </a:r>
+            <a:br/>
+            <a:br/>
+            <a:r>
+              <a:t>Primero, el KPI fue cumplido: mAP@50 de 0.9229 superando el umbral de 0.75 con amplio margen. Segundo, la arquitectura está bien fundamentada con el modelo 4+1 de Kruchten, lo que hace el sistema mantenible y extensible. Tercero, el producto es funcional: 12/12 requerimientos implementados y desplegado en Render con CI verde.</a:t>
+            </a:r>
+            <a:br/>
+            <a:br/>
+            <a:r>
+              <a:t>Como trabajo futuro: autenticación JWT real, más frutas en el catálogo y tests E2E automatizados con Espresso.</a:t>
+            </a:r>
+            <a:br/>
+            <a:br/>
+            <a:r>
+              <a:t>Quedo a disposición para preguntas. Muchas gracias.</a:t>
+            </a:r>
             <a:endParaRPr lang="en-US" dirty="0"/>
           </a:p>
         </p:txBody>

</xml_diff>